<commit_message>
What Changed? drops parts $ per RO; luxury option A without the average line for review
Co-Authored-By: Claude Opus 5.5 <noreply@anthropic.com>
Claude-Session: https://claude.ai/code/session_01Xa4nFVxuQGXmHARGph9WhS
</commit_message>
<xml_diff>
--- a/day2-deck/decks/Most Improved v2 - Review.pptx
+++ b/day2-deck/decks/Most Improved v2 - Review.pptx
@@ -23783,7 +23783,7 @@
                 <a:ea typeface="Inter" pitchFamily="34" charset="-122"/>
                 <a:cs typeface="Inter" pitchFamily="34" charset="-120"/>
               </a:rPr>
-              <a:t>VW ST GEORGE</a:t>
+              <a:t>ACURA</a:t>
             </a:r>
             <a:endParaRPr lang="en-US" sz="1500" dirty="0"/>
           </a:p>
@@ -23822,7 +23822,7 @@
                 <a:ea typeface="Inter" pitchFamily="34" charset="-122"/>
                 <a:cs typeface="Inter" pitchFamily="34" charset="-120"/>
               </a:rPr>
-              <a:t>CP Parts $ per RO</a:t>
+              <a:t>CP Parts GP %</a:t>
             </a:r>
             <a:endParaRPr lang="en-US" sz="1500" dirty="0"/>
           </a:p>
@@ -23861,7 +23861,7 @@
                 <a:ea typeface="Inter" pitchFamily="34" charset="-122"/>
                 <a:cs typeface="Inter" pitchFamily="34" charset="-120"/>
               </a:rPr>
-              <a:t>$224 → $298</a:t>
+              <a:t>39.4% → 46.6%</a:t>
             </a:r>
             <a:endParaRPr lang="en-US" sz="1500" dirty="0"/>
           </a:p>
@@ -23900,7 +23900,7 @@
                 <a:ea typeface="Inter" pitchFamily="34" charset="-122"/>
                 <a:cs typeface="Inter" pitchFamily="34" charset="-120"/>
               </a:rPr>
-              <a:t>June</a:t>
+              <a:t>April</a:t>
             </a:r>
             <a:endParaRPr lang="en-US" sz="1500" dirty="0"/>
           </a:p>
@@ -23939,7 +23939,7 @@
                 <a:ea typeface="Inter" pitchFamily="34" charset="-122"/>
                 <a:cs typeface="Inter" pitchFamily="34" charset="-120"/>
               </a:rPr>
-              <a:t>+32.9%</a:t>
+              <a:t>+7.2 pts</a:t>
             </a:r>
             <a:endParaRPr lang="en-US" sz="1500" dirty="0"/>
           </a:p>
@@ -23978,7 +23978,7 @@
                 <a:ea typeface="Inter" pitchFamily="34" charset="-122"/>
                 <a:cs typeface="Inter" pitchFamily="34" charset="-120"/>
               </a:rPr>
-              <a:t>ACURA</a:t>
+              <a:t>MAZDA</a:t>
             </a:r>
             <a:endParaRPr lang="en-US" sz="1500" dirty="0"/>
           </a:p>
@@ -24017,7 +24017,7 @@
                 <a:ea typeface="Inter" pitchFamily="34" charset="-122"/>
                 <a:cs typeface="Inter" pitchFamily="34" charset="-120"/>
               </a:rPr>
-              <a:t>CP Parts GP %</a:t>
+              <a:t>Opcodes · alignment</a:t>
             </a:r>
             <a:endParaRPr lang="en-US" sz="1500" dirty="0"/>
           </a:p>
@@ -24056,7 +24056,7 @@
                 <a:ea typeface="Inter" pitchFamily="34" charset="-122"/>
                 <a:cs typeface="Inter" pitchFamily="34" charset="-120"/>
               </a:rPr>
-              <a:t>39.4% → 46.6%</a:t>
+              <a:t>12.6% → 22.8%</a:t>
             </a:r>
             <a:endParaRPr lang="en-US" sz="1500" dirty="0"/>
           </a:p>
@@ -24095,7 +24095,7 @@
                 <a:ea typeface="Inter" pitchFamily="34" charset="-122"/>
                 <a:cs typeface="Inter" pitchFamily="34" charset="-120"/>
               </a:rPr>
-              <a:t>April</a:t>
+              <a:t>August</a:t>
             </a:r>
             <a:endParaRPr lang="en-US" sz="1500" dirty="0"/>
           </a:p>
@@ -24134,7 +24134,7 @@
                 <a:ea typeface="Inter" pitchFamily="34" charset="-122"/>
                 <a:cs typeface="Inter" pitchFamily="34" charset="-120"/>
               </a:rPr>
-              <a:t>+7.2 pts</a:t>
+              <a:t>+10.1 pts</a:t>
             </a:r>
             <a:endParaRPr lang="en-US" sz="1500" dirty="0"/>
           </a:p>
@@ -24143,221 +24143,6 @@
       <p:sp>
         <p:nvSpPr>
           <p:cNvPr id="44" name="Shape 42"/>
-          <p:cNvSpPr/>
-          <p:nvPr/>
-        </p:nvSpPr>
-        <p:spPr>
-          <a:xfrm>
-            <a:off x="621792" y="5065776"/>
-            <a:ext cx="10945368" cy="548640"/>
-          </a:xfrm>
-          <a:prstGeom prst="rect">
-            <a:avLst/>
-          </a:prstGeom>
-          <a:solidFill>
-            <a:srgbClr val="F7F7F7"/>
-          </a:solidFill>
-          <a:ln/>
-        </p:spPr>
-      </p:sp>
-      <p:sp>
-        <p:nvSpPr>
-          <p:cNvPr id="45" name="Text 43"/>
-          <p:cNvSpPr txBox="1"/>
-          <p:nvPr/>
-        </p:nvSpPr>
-        <p:spPr>
-          <a:xfrm>
-            <a:off x="749808" y="5065776"/>
-            <a:ext cx="2651760" cy="548640"/>
-          </a:xfrm>
-          <a:prstGeom prst="rect">
-            <a:avLst/>
-          </a:prstGeom>
-          <a:noFill/>
-          <a:ln/>
-        </p:spPr>
-        <p:txBody>
-          <a:bodyPr wrap="square" lIns="0" tIns="0" rIns="0" bIns="0" rtlCol="0" anchor="ctr"/>
-          <a:lstStyle/>
-          <a:p>
-            <a:pPr indent="0" marL="0">
-              <a:buNone/>
-            </a:pPr>
-            <a:r>
-              <a:rPr lang="en-US" sz="1500" b="1" dirty="0">
-                <a:solidFill>
-                  <a:srgbClr val="1A1A1A"/>
-                </a:solidFill>
-                <a:latin typeface="Inter" pitchFamily="34" charset="0"/>
-                <a:ea typeface="Inter" pitchFamily="34" charset="-122"/>
-                <a:cs typeface="Inter" pitchFamily="34" charset="-120"/>
-              </a:rPr>
-              <a:t>MAZDA</a:t>
-            </a:r>
-            <a:endParaRPr lang="en-US" sz="1500" dirty="0"/>
-          </a:p>
-        </p:txBody>
-      </p:sp>
-      <p:sp>
-        <p:nvSpPr>
-          <p:cNvPr id="46" name="Text 44"/>
-          <p:cNvSpPr txBox="1"/>
-          <p:nvPr/>
-        </p:nvSpPr>
-        <p:spPr>
-          <a:xfrm>
-            <a:off x="3520440" y="5065776"/>
-            <a:ext cx="2103120" cy="548640"/>
-          </a:xfrm>
-          <a:prstGeom prst="rect">
-            <a:avLst/>
-          </a:prstGeom>
-          <a:noFill/>
-          <a:ln/>
-        </p:spPr>
-        <p:txBody>
-          <a:bodyPr wrap="square" lIns="0" tIns="0" rIns="0" bIns="0" rtlCol="0" anchor="ctr"/>
-          <a:lstStyle/>
-          <a:p>
-            <a:pPr indent="0" marL="0">
-              <a:buNone/>
-            </a:pPr>
-            <a:r>
-              <a:rPr lang="en-US" sz="1500" dirty="0">
-                <a:solidFill>
-                  <a:srgbClr val="1A1A1A"/>
-                </a:solidFill>
-                <a:latin typeface="Inter" pitchFamily="34" charset="0"/>
-                <a:ea typeface="Inter" pitchFamily="34" charset="-122"/>
-                <a:cs typeface="Inter" pitchFamily="34" charset="-120"/>
-              </a:rPr>
-              <a:t>Opcodes · alignment</a:t>
-            </a:r>
-            <a:endParaRPr lang="en-US" sz="1500" dirty="0"/>
-          </a:p>
-        </p:txBody>
-      </p:sp>
-      <p:sp>
-        <p:nvSpPr>
-          <p:cNvPr id="47" name="Text 45"/>
-          <p:cNvSpPr txBox="1"/>
-          <p:nvPr/>
-        </p:nvSpPr>
-        <p:spPr>
-          <a:xfrm>
-            <a:off x="5669280" y="5065776"/>
-            <a:ext cx="2011680" cy="548640"/>
-          </a:xfrm>
-          <a:prstGeom prst="rect">
-            <a:avLst/>
-          </a:prstGeom>
-          <a:noFill/>
-          <a:ln/>
-        </p:spPr>
-        <p:txBody>
-          <a:bodyPr wrap="square" lIns="0" tIns="0" rIns="0" bIns="0" rtlCol="0" anchor="ctr"/>
-          <a:lstStyle/>
-          <a:p>
-            <a:pPr indent="0" marL="0">
-              <a:buNone/>
-            </a:pPr>
-            <a:r>
-              <a:rPr lang="en-US" sz="1500" dirty="0">
-                <a:solidFill>
-                  <a:srgbClr val="1A1A1A"/>
-                </a:solidFill>
-                <a:latin typeface="Inter" pitchFamily="34" charset="0"/>
-                <a:ea typeface="Inter" pitchFamily="34" charset="-122"/>
-                <a:cs typeface="Inter" pitchFamily="34" charset="-120"/>
-              </a:rPr>
-              <a:t>12.6% → 22.8%</a:t>
-            </a:r>
-            <a:endParaRPr lang="en-US" sz="1500" dirty="0"/>
-          </a:p>
-        </p:txBody>
-      </p:sp>
-      <p:sp>
-        <p:nvSpPr>
-          <p:cNvPr id="48" name="Text 46"/>
-          <p:cNvSpPr txBox="1"/>
-          <p:nvPr/>
-        </p:nvSpPr>
-        <p:spPr>
-          <a:xfrm>
-            <a:off x="7726680" y="5065776"/>
-            <a:ext cx="1554480" cy="548640"/>
-          </a:xfrm>
-          <a:prstGeom prst="rect">
-            <a:avLst/>
-          </a:prstGeom>
-          <a:noFill/>
-          <a:ln/>
-        </p:spPr>
-        <p:txBody>
-          <a:bodyPr wrap="square" lIns="0" tIns="0" rIns="0" bIns="0" rtlCol="0" anchor="ctr"/>
-          <a:lstStyle/>
-          <a:p>
-            <a:pPr indent="0" marL="0">
-              <a:buNone/>
-            </a:pPr>
-            <a:r>
-              <a:rPr lang="en-US" sz="1500" b="1" dirty="0">
-                <a:solidFill>
-                  <a:srgbClr val="0B2C4A"/>
-                </a:solidFill>
-                <a:latin typeface="Inter" pitchFamily="34" charset="0"/>
-                <a:ea typeface="Inter" pitchFamily="34" charset="-122"/>
-                <a:cs typeface="Inter" pitchFamily="34" charset="-120"/>
-              </a:rPr>
-              <a:t>August</a:t>
-            </a:r>
-            <a:endParaRPr lang="en-US" sz="1500" dirty="0"/>
-          </a:p>
-        </p:txBody>
-      </p:sp>
-      <p:sp>
-        <p:nvSpPr>
-          <p:cNvPr id="49" name="Text 47"/>
-          <p:cNvSpPr txBox="1"/>
-          <p:nvPr/>
-        </p:nvSpPr>
-        <p:spPr>
-          <a:xfrm>
-            <a:off x="9326880" y="5065776"/>
-            <a:ext cx="1280160" cy="548640"/>
-          </a:xfrm>
-          <a:prstGeom prst="rect">
-            <a:avLst/>
-          </a:prstGeom>
-          <a:noFill/>
-          <a:ln/>
-        </p:spPr>
-        <p:txBody>
-          <a:bodyPr wrap="square" lIns="0" tIns="0" rIns="0" bIns="0" rtlCol="0" anchor="ctr"/>
-          <a:lstStyle/>
-          <a:p>
-            <a:pPr indent="0" marL="0">
-              <a:buNone/>
-            </a:pPr>
-            <a:r>
-              <a:rPr lang="en-US" sz="1500" b="1" dirty="0">
-                <a:solidFill>
-                  <a:srgbClr val="0B7A4A"/>
-                </a:solidFill>
-                <a:latin typeface="Inter" pitchFamily="34" charset="0"/>
-                <a:ea typeface="Inter" pitchFamily="34" charset="-122"/>
-                <a:cs typeface="Inter" pitchFamily="34" charset="-120"/>
-              </a:rPr>
-              <a:t>+10.1 pts</a:t>
-            </a:r>
-            <a:endParaRPr lang="en-US" sz="1500" dirty="0"/>
-          </a:p>
-        </p:txBody>
-      </p:sp>
-      <p:sp>
-        <p:nvSpPr>
-          <p:cNvPr id="50" name="Shape 48"/>
           <p:cNvSpPr/>
           <p:nvPr/>
         </p:nvSpPr>
@@ -24377,7 +24162,7 @@
       </p:sp>
       <p:sp>
         <p:nvSpPr>
-          <p:cNvPr id="51" name="Text 49"/>
+          <p:cNvPr id="45" name="Text 43"/>
           <p:cNvSpPr txBox="1"/>
           <p:nvPr/>
         </p:nvSpPr>

</xml_diff>

<commit_message>
Day 2 deck: column rules on Most Improved grids, both-lists bar on Two Ways, warranty and Where the Money Is bands
Co-Authored-By: Claude Opus 5.5 <noreply@anthropic.com>
Claude-Session: https://claude.ai/code/session_01Xa4nFVxuQGXmHARGph9WhS
</commit_message>
<xml_diff>
--- a/day2-deck/decks/Most Improved v2 - Review.pptx
+++ b/day2-deck/decks/Most Improved v2 - Review.pptx
@@ -18782,7 +18782,7 @@
           <a:p>
             <a:r>
               <a:rPr lang="en-US" dirty="0"/>
-              <a:t>Takeaway with the store call-outs (off the slide): Last year: Subaru Prescott leads. Moving now: Three stores tie. Eight stores make both views.Source: Qlik - Closed Repair Orders. Customer pay, by close date. Same-store, 33 stores (INEOS excluded, opened 2026). GMC Prescott body shop labor types excluded. CP gross = CP labor gross + CP parts gross. Left: Jan-Sep 2026 vs Jan-Sep 2025. Right: Q3 2026 vs Q1 2026. Top-5 finishes counted across five measures (parts $ per RO dropped, Oct 23); top six stores shown in each view.</a:t>
+              <a:t>Takeaway with the store call-outs (off the slide): Last year: Subaru Prescott leads. Moving now: Three stores tie. One store is on both lists (green bar).Source: Qlik - Closed Repair Orders. Customer pay, by close date. Same-store, 33 stores (INEOS excluded, opened 2026). GMC Prescott body shop labor types excluded. CP gross = CP labor gross + CP parts gross. Left: Jan-Sep 2026 vs Jan-Sep 2025. Right: Q3 2026 vs Q1 2026. Top-5 finishes counted across five measures (parts $ per RO dropped, Oct 23); top six stores shown in each view.</a:t>
             </a:r>
             <a:endParaRPr lang="en-US" dirty="0"/>
           </a:p>
@@ -19674,6 +19674,86 @@
         </p:nvSpPr>
         <p:spPr>
           <a:xfrm>
+            <a:off x="3044952" y="1691640"/>
+            <a:ext cx="10973" cy="3977640"/>
+          </a:xfrm>
+          <a:prstGeom prst="rect">
+            <a:avLst/>
+          </a:prstGeom>
+          <a:solidFill>
+            <a:srgbClr val="D9D9D9"/>
+          </a:solidFill>
+          <a:ln/>
+        </p:spPr>
+      </p:sp>
+      <p:sp>
+        <p:nvSpPr>
+          <p:cNvPr id="20" name="Shape 18"/>
+          <p:cNvSpPr/>
+          <p:nvPr/>
+        </p:nvSpPr>
+        <p:spPr>
+          <a:xfrm>
+            <a:off x="5180990" y="1691640"/>
+            <a:ext cx="10973" cy="3977640"/>
+          </a:xfrm>
+          <a:prstGeom prst="rect">
+            <a:avLst/>
+          </a:prstGeom>
+          <a:solidFill>
+            <a:srgbClr val="D9D9D9"/>
+          </a:solidFill>
+          <a:ln/>
+        </p:spPr>
+      </p:sp>
+      <p:sp>
+        <p:nvSpPr>
+          <p:cNvPr id="21" name="Shape 19"/>
+          <p:cNvSpPr/>
+          <p:nvPr/>
+        </p:nvSpPr>
+        <p:spPr>
+          <a:xfrm>
+            <a:off x="7317029" y="1691640"/>
+            <a:ext cx="10973" cy="3977640"/>
+          </a:xfrm>
+          <a:prstGeom prst="rect">
+            <a:avLst/>
+          </a:prstGeom>
+          <a:solidFill>
+            <a:srgbClr val="D9D9D9"/>
+          </a:solidFill>
+          <a:ln/>
+        </p:spPr>
+      </p:sp>
+      <p:sp>
+        <p:nvSpPr>
+          <p:cNvPr id="22" name="Shape 20"/>
+          <p:cNvSpPr/>
+          <p:nvPr/>
+        </p:nvSpPr>
+        <p:spPr>
+          <a:xfrm>
+            <a:off x="9453067" y="1691640"/>
+            <a:ext cx="10973" cy="3977640"/>
+          </a:xfrm>
+          <a:prstGeom prst="rect">
+            <a:avLst/>
+          </a:prstGeom>
+          <a:solidFill>
+            <a:srgbClr val="D9D9D9"/>
+          </a:solidFill>
+          <a:ln/>
+        </p:spPr>
+      </p:sp>
+      <p:sp>
+        <p:nvSpPr>
+          <p:cNvPr id="23" name="Shape 21"/>
+          <p:cNvSpPr/>
+          <p:nvPr/>
+        </p:nvSpPr>
+        <p:spPr>
+          <a:xfrm>
             <a:off x="969264" y="1691640"/>
             <a:ext cx="2026310" cy="45720"/>
           </a:xfrm>
@@ -19688,7 +19768,7 @@
       </p:sp>
       <p:sp>
         <p:nvSpPr>
-          <p:cNvPr id="20" name="Text 18"/>
+          <p:cNvPr id="24" name="Text 22"/>
           <p:cNvSpPr txBox="1"/>
           <p:nvPr/>
         </p:nvSpPr>
@@ -19729,7 +19809,7 @@
       </p:sp>
       <p:sp>
         <p:nvSpPr>
-          <p:cNvPr id="21" name="Text 19"/>
+          <p:cNvPr id="25" name="Text 23"/>
           <p:cNvSpPr txBox="1"/>
           <p:nvPr/>
         </p:nvSpPr>
@@ -19768,7 +19848,7 @@
       </p:sp>
       <p:sp>
         <p:nvSpPr>
-          <p:cNvPr id="22" name="Text 20"/>
+          <p:cNvPr id="26" name="Text 24"/>
           <p:cNvSpPr txBox="1"/>
           <p:nvPr/>
         </p:nvSpPr>
@@ -19807,7 +19887,7 @@
       </p:sp>
       <p:sp>
         <p:nvSpPr>
-          <p:cNvPr id="23" name="Text 21"/>
+          <p:cNvPr id="27" name="Text 25"/>
           <p:cNvSpPr txBox="1"/>
           <p:nvPr/>
         </p:nvSpPr>
@@ -19846,7 +19926,7 @@
       </p:sp>
       <p:sp>
         <p:nvSpPr>
-          <p:cNvPr id="24" name="Text 22"/>
+          <p:cNvPr id="28" name="Text 26"/>
           <p:cNvSpPr txBox="1"/>
           <p:nvPr/>
         </p:nvSpPr>
@@ -19885,7 +19965,7 @@
       </p:sp>
       <p:sp>
         <p:nvSpPr>
-          <p:cNvPr id="25" name="Text 23"/>
+          <p:cNvPr id="29" name="Text 27"/>
           <p:cNvSpPr txBox="1"/>
           <p:nvPr/>
         </p:nvSpPr>
@@ -19924,7 +20004,7 @@
       </p:sp>
       <p:sp>
         <p:nvSpPr>
-          <p:cNvPr id="26" name="Text 24"/>
+          <p:cNvPr id="30" name="Text 28"/>
           <p:cNvSpPr txBox="1"/>
           <p:nvPr/>
         </p:nvSpPr>
@@ -19963,7 +20043,7 @@
       </p:sp>
       <p:sp>
         <p:nvSpPr>
-          <p:cNvPr id="27" name="Text 25"/>
+          <p:cNvPr id="31" name="Text 29"/>
           <p:cNvSpPr txBox="1"/>
           <p:nvPr/>
         </p:nvSpPr>
@@ -20002,7 +20082,7 @@
       </p:sp>
       <p:sp>
         <p:nvSpPr>
-          <p:cNvPr id="28" name="Text 26"/>
+          <p:cNvPr id="32" name="Text 30"/>
           <p:cNvSpPr txBox="1"/>
           <p:nvPr/>
         </p:nvSpPr>
@@ -20041,7 +20121,7 @@
       </p:sp>
       <p:sp>
         <p:nvSpPr>
-          <p:cNvPr id="29" name="Text 27"/>
+          <p:cNvPr id="33" name="Text 31"/>
           <p:cNvSpPr txBox="1"/>
           <p:nvPr/>
         </p:nvSpPr>
@@ -20080,7 +20160,7 @@
       </p:sp>
       <p:sp>
         <p:nvSpPr>
-          <p:cNvPr id="30" name="Text 28"/>
+          <p:cNvPr id="34" name="Text 32"/>
           <p:cNvSpPr txBox="1"/>
           <p:nvPr/>
         </p:nvSpPr>
@@ -20119,7 +20199,7 @@
       </p:sp>
       <p:sp>
         <p:nvSpPr>
-          <p:cNvPr id="31" name="Text 29"/>
+          <p:cNvPr id="35" name="Text 33"/>
           <p:cNvSpPr txBox="1"/>
           <p:nvPr/>
         </p:nvSpPr>
@@ -20158,7 +20238,7 @@
       </p:sp>
       <p:sp>
         <p:nvSpPr>
-          <p:cNvPr id="32" name="Text 30"/>
+          <p:cNvPr id="36" name="Text 34"/>
           <p:cNvSpPr txBox="1"/>
           <p:nvPr/>
         </p:nvSpPr>
@@ -20197,7 +20277,7 @@
       </p:sp>
       <p:sp>
         <p:nvSpPr>
-          <p:cNvPr id="33" name="Text 31"/>
+          <p:cNvPr id="37" name="Text 35"/>
           <p:cNvSpPr txBox="1"/>
           <p:nvPr/>
         </p:nvSpPr>
@@ -20236,7 +20316,7 @@
       </p:sp>
       <p:sp>
         <p:nvSpPr>
-          <p:cNvPr id="34" name="Shape 32"/>
+          <p:cNvPr id="38" name="Shape 36"/>
           <p:cNvSpPr/>
           <p:nvPr/>
         </p:nvSpPr>
@@ -20256,7 +20336,7 @@
       </p:sp>
       <p:sp>
         <p:nvSpPr>
-          <p:cNvPr id="35" name="Text 33"/>
+          <p:cNvPr id="39" name="Text 37"/>
           <p:cNvSpPr txBox="1"/>
           <p:nvPr/>
         </p:nvSpPr>
@@ -20297,7 +20377,7 @@
       </p:sp>
       <p:sp>
         <p:nvSpPr>
-          <p:cNvPr id="36" name="Text 34"/>
+          <p:cNvPr id="40" name="Text 38"/>
           <p:cNvSpPr txBox="1"/>
           <p:nvPr/>
         </p:nvSpPr>
@@ -20336,7 +20416,7 @@
       </p:sp>
       <p:sp>
         <p:nvSpPr>
-          <p:cNvPr id="37" name="Text 35"/>
+          <p:cNvPr id="41" name="Text 39"/>
           <p:cNvSpPr txBox="1"/>
           <p:nvPr/>
         </p:nvSpPr>
@@ -20375,7 +20455,7 @@
       </p:sp>
       <p:sp>
         <p:nvSpPr>
-          <p:cNvPr id="38" name="Text 36"/>
+          <p:cNvPr id="42" name="Text 40"/>
           <p:cNvSpPr txBox="1"/>
           <p:nvPr/>
         </p:nvSpPr>
@@ -20414,7 +20494,7 @@
       </p:sp>
       <p:sp>
         <p:nvSpPr>
-          <p:cNvPr id="39" name="Text 37"/>
+          <p:cNvPr id="43" name="Text 41"/>
           <p:cNvSpPr txBox="1"/>
           <p:nvPr/>
         </p:nvSpPr>
@@ -20453,7 +20533,7 @@
       </p:sp>
       <p:sp>
         <p:nvSpPr>
-          <p:cNvPr id="40" name="Text 38"/>
+          <p:cNvPr id="44" name="Text 42"/>
           <p:cNvSpPr txBox="1"/>
           <p:nvPr/>
         </p:nvSpPr>
@@ -20492,7 +20572,7 @@
       </p:sp>
       <p:sp>
         <p:nvSpPr>
-          <p:cNvPr id="41" name="Text 39"/>
+          <p:cNvPr id="45" name="Text 43"/>
           <p:cNvSpPr txBox="1"/>
           <p:nvPr/>
         </p:nvSpPr>
@@ -20531,7 +20611,7 @@
       </p:sp>
       <p:sp>
         <p:nvSpPr>
-          <p:cNvPr id="42" name="Text 40"/>
+          <p:cNvPr id="46" name="Text 44"/>
           <p:cNvSpPr txBox="1"/>
           <p:nvPr/>
         </p:nvSpPr>
@@ -20570,7 +20650,7 @@
       </p:sp>
       <p:sp>
         <p:nvSpPr>
-          <p:cNvPr id="43" name="Text 41"/>
+          <p:cNvPr id="47" name="Text 45"/>
           <p:cNvSpPr txBox="1"/>
           <p:nvPr/>
         </p:nvSpPr>
@@ -20609,7 +20689,7 @@
       </p:sp>
       <p:sp>
         <p:nvSpPr>
-          <p:cNvPr id="44" name="Text 42"/>
+          <p:cNvPr id="48" name="Text 46"/>
           <p:cNvSpPr txBox="1"/>
           <p:nvPr/>
         </p:nvSpPr>
@@ -20648,7 +20728,7 @@
       </p:sp>
       <p:sp>
         <p:nvSpPr>
-          <p:cNvPr id="45" name="Text 43"/>
+          <p:cNvPr id="49" name="Text 47"/>
           <p:cNvSpPr txBox="1"/>
           <p:nvPr/>
         </p:nvSpPr>
@@ -20687,7 +20767,7 @@
       </p:sp>
       <p:sp>
         <p:nvSpPr>
-          <p:cNvPr id="46" name="Text 44"/>
+          <p:cNvPr id="50" name="Text 48"/>
           <p:cNvSpPr txBox="1"/>
           <p:nvPr/>
         </p:nvSpPr>
@@ -20726,7 +20806,7 @@
       </p:sp>
       <p:sp>
         <p:nvSpPr>
-          <p:cNvPr id="47" name="Text 45"/>
+          <p:cNvPr id="51" name="Text 49"/>
           <p:cNvSpPr txBox="1"/>
           <p:nvPr/>
         </p:nvSpPr>
@@ -20765,7 +20845,7 @@
       </p:sp>
       <p:sp>
         <p:nvSpPr>
-          <p:cNvPr id="48" name="Text 46"/>
+          <p:cNvPr id="52" name="Text 50"/>
           <p:cNvSpPr txBox="1"/>
           <p:nvPr/>
         </p:nvSpPr>
@@ -20804,7 +20884,7 @@
       </p:sp>
       <p:sp>
         <p:nvSpPr>
-          <p:cNvPr id="49" name="Shape 47"/>
+          <p:cNvPr id="53" name="Shape 51"/>
           <p:cNvSpPr/>
           <p:nvPr/>
         </p:nvSpPr>
@@ -20824,7 +20904,7 @@
       </p:sp>
       <p:sp>
         <p:nvSpPr>
-          <p:cNvPr id="50" name="Text 48"/>
+          <p:cNvPr id="54" name="Text 52"/>
           <p:cNvSpPr txBox="1"/>
           <p:nvPr/>
         </p:nvSpPr>
@@ -20865,7 +20945,7 @@
       </p:sp>
       <p:sp>
         <p:nvSpPr>
-          <p:cNvPr id="51" name="Text 49"/>
+          <p:cNvPr id="55" name="Text 53"/>
           <p:cNvSpPr txBox="1"/>
           <p:nvPr/>
         </p:nvSpPr>
@@ -20904,7 +20984,7 @@
       </p:sp>
       <p:sp>
         <p:nvSpPr>
-          <p:cNvPr id="52" name="Text 50"/>
+          <p:cNvPr id="56" name="Text 54"/>
           <p:cNvSpPr txBox="1"/>
           <p:nvPr/>
         </p:nvSpPr>
@@ -20943,7 +21023,7 @@
       </p:sp>
       <p:sp>
         <p:nvSpPr>
-          <p:cNvPr id="53" name="Text 51"/>
+          <p:cNvPr id="57" name="Text 55"/>
           <p:cNvSpPr txBox="1"/>
           <p:nvPr/>
         </p:nvSpPr>
@@ -20982,7 +21062,7 @@
       </p:sp>
       <p:sp>
         <p:nvSpPr>
-          <p:cNvPr id="54" name="Text 52"/>
+          <p:cNvPr id="58" name="Text 56"/>
           <p:cNvSpPr txBox="1"/>
           <p:nvPr/>
         </p:nvSpPr>
@@ -21021,7 +21101,7 @@
       </p:sp>
       <p:sp>
         <p:nvSpPr>
-          <p:cNvPr id="55" name="Text 53"/>
+          <p:cNvPr id="59" name="Text 57"/>
           <p:cNvSpPr txBox="1"/>
           <p:nvPr/>
         </p:nvSpPr>
@@ -21060,7 +21140,7 @@
       </p:sp>
       <p:sp>
         <p:nvSpPr>
-          <p:cNvPr id="56" name="Text 54"/>
+          <p:cNvPr id="60" name="Text 58"/>
           <p:cNvSpPr txBox="1"/>
           <p:nvPr/>
         </p:nvSpPr>
@@ -21099,7 +21179,7 @@
       </p:sp>
       <p:sp>
         <p:nvSpPr>
-          <p:cNvPr id="57" name="Text 55"/>
+          <p:cNvPr id="61" name="Text 59"/>
           <p:cNvSpPr txBox="1"/>
           <p:nvPr/>
         </p:nvSpPr>
@@ -21138,7 +21218,7 @@
       </p:sp>
       <p:sp>
         <p:nvSpPr>
-          <p:cNvPr id="58" name="Text 56"/>
+          <p:cNvPr id="62" name="Text 60"/>
           <p:cNvSpPr txBox="1"/>
           <p:nvPr/>
         </p:nvSpPr>
@@ -21177,7 +21257,7 @@
       </p:sp>
       <p:sp>
         <p:nvSpPr>
-          <p:cNvPr id="59" name="Text 57"/>
+          <p:cNvPr id="63" name="Text 61"/>
           <p:cNvSpPr txBox="1"/>
           <p:nvPr/>
         </p:nvSpPr>
@@ -21216,7 +21296,7 @@
       </p:sp>
       <p:sp>
         <p:nvSpPr>
-          <p:cNvPr id="60" name="Text 58"/>
+          <p:cNvPr id="64" name="Text 62"/>
           <p:cNvSpPr txBox="1"/>
           <p:nvPr/>
         </p:nvSpPr>
@@ -21255,7 +21335,7 @@
       </p:sp>
       <p:sp>
         <p:nvSpPr>
-          <p:cNvPr id="61" name="Text 59"/>
+          <p:cNvPr id="65" name="Text 63"/>
           <p:cNvSpPr txBox="1"/>
           <p:nvPr/>
         </p:nvSpPr>
@@ -21294,7 +21374,7 @@
       </p:sp>
       <p:sp>
         <p:nvSpPr>
-          <p:cNvPr id="62" name="Text 60"/>
+          <p:cNvPr id="66" name="Text 64"/>
           <p:cNvSpPr txBox="1"/>
           <p:nvPr/>
         </p:nvSpPr>
@@ -21333,7 +21413,7 @@
       </p:sp>
       <p:sp>
         <p:nvSpPr>
-          <p:cNvPr id="63" name="Text 61"/>
+          <p:cNvPr id="67" name="Text 65"/>
           <p:cNvSpPr txBox="1"/>
           <p:nvPr/>
         </p:nvSpPr>
@@ -21372,7 +21452,7 @@
       </p:sp>
       <p:sp>
         <p:nvSpPr>
-          <p:cNvPr id="64" name="Shape 62"/>
+          <p:cNvPr id="68" name="Shape 66"/>
           <p:cNvSpPr/>
           <p:nvPr/>
         </p:nvSpPr>
@@ -21392,7 +21472,7 @@
       </p:sp>
       <p:sp>
         <p:nvSpPr>
-          <p:cNvPr id="65" name="Text 63"/>
+          <p:cNvPr id="69" name="Text 67"/>
           <p:cNvSpPr txBox="1"/>
           <p:nvPr/>
         </p:nvSpPr>
@@ -21433,7 +21513,7 @@
       </p:sp>
       <p:sp>
         <p:nvSpPr>
-          <p:cNvPr id="66" name="Text 64"/>
+          <p:cNvPr id="70" name="Text 68"/>
           <p:cNvSpPr txBox="1"/>
           <p:nvPr/>
         </p:nvSpPr>
@@ -21472,7 +21552,7 @@
       </p:sp>
       <p:sp>
         <p:nvSpPr>
-          <p:cNvPr id="67" name="Text 65"/>
+          <p:cNvPr id="71" name="Text 69"/>
           <p:cNvSpPr txBox="1"/>
           <p:nvPr/>
         </p:nvSpPr>
@@ -21511,7 +21591,7 @@
       </p:sp>
       <p:sp>
         <p:nvSpPr>
-          <p:cNvPr id="68" name="Text 66"/>
+          <p:cNvPr id="72" name="Text 70"/>
           <p:cNvSpPr txBox="1"/>
           <p:nvPr/>
         </p:nvSpPr>
@@ -21550,7 +21630,7 @@
       </p:sp>
       <p:sp>
         <p:nvSpPr>
-          <p:cNvPr id="69" name="Text 67"/>
+          <p:cNvPr id="73" name="Text 71"/>
           <p:cNvSpPr txBox="1"/>
           <p:nvPr/>
         </p:nvSpPr>
@@ -21589,7 +21669,7 @@
       </p:sp>
       <p:sp>
         <p:nvSpPr>
-          <p:cNvPr id="70" name="Text 68"/>
+          <p:cNvPr id="74" name="Text 72"/>
           <p:cNvSpPr txBox="1"/>
           <p:nvPr/>
         </p:nvSpPr>
@@ -21628,7 +21708,7 @@
       </p:sp>
       <p:sp>
         <p:nvSpPr>
-          <p:cNvPr id="71" name="Text 69"/>
+          <p:cNvPr id="75" name="Text 73"/>
           <p:cNvSpPr txBox="1"/>
           <p:nvPr/>
         </p:nvSpPr>
@@ -21667,7 +21747,7 @@
       </p:sp>
       <p:sp>
         <p:nvSpPr>
-          <p:cNvPr id="72" name="Text 70"/>
+          <p:cNvPr id="76" name="Text 74"/>
           <p:cNvSpPr txBox="1"/>
           <p:nvPr/>
         </p:nvSpPr>
@@ -21706,7 +21786,7 @@
       </p:sp>
       <p:sp>
         <p:nvSpPr>
-          <p:cNvPr id="73" name="Text 71"/>
+          <p:cNvPr id="77" name="Text 75"/>
           <p:cNvSpPr txBox="1"/>
           <p:nvPr/>
         </p:nvSpPr>
@@ -21745,7 +21825,7 @@
       </p:sp>
       <p:sp>
         <p:nvSpPr>
-          <p:cNvPr id="74" name="Text 72"/>
+          <p:cNvPr id="78" name="Text 76"/>
           <p:cNvSpPr txBox="1"/>
           <p:nvPr/>
         </p:nvSpPr>
@@ -21784,7 +21864,7 @@
       </p:sp>
       <p:sp>
         <p:nvSpPr>
-          <p:cNvPr id="75" name="Text 73"/>
+          <p:cNvPr id="79" name="Text 77"/>
           <p:cNvSpPr txBox="1"/>
           <p:nvPr/>
         </p:nvSpPr>
@@ -21823,7 +21903,7 @@
       </p:sp>
       <p:sp>
         <p:nvSpPr>
-          <p:cNvPr id="76" name="Text 74"/>
+          <p:cNvPr id="80" name="Text 78"/>
           <p:cNvSpPr txBox="1"/>
           <p:nvPr/>
         </p:nvSpPr>
@@ -21862,7 +21942,7 @@
       </p:sp>
       <p:sp>
         <p:nvSpPr>
-          <p:cNvPr id="77" name="Text 75"/>
+          <p:cNvPr id="81" name="Text 79"/>
           <p:cNvSpPr txBox="1"/>
           <p:nvPr/>
         </p:nvSpPr>
@@ -21901,7 +21981,7 @@
       </p:sp>
       <p:sp>
         <p:nvSpPr>
-          <p:cNvPr id="78" name="Text 76"/>
+          <p:cNvPr id="82" name="Text 80"/>
           <p:cNvSpPr txBox="1"/>
           <p:nvPr/>
         </p:nvSpPr>
@@ -21940,7 +22020,7 @@
       </p:sp>
       <p:sp>
         <p:nvSpPr>
-          <p:cNvPr id="79" name="Shape 77"/>
+          <p:cNvPr id="83" name="Shape 81"/>
           <p:cNvSpPr/>
           <p:nvPr/>
         </p:nvSpPr>
@@ -21960,7 +22040,7 @@
       </p:sp>
       <p:sp>
         <p:nvSpPr>
-          <p:cNvPr id="80" name="Text 78"/>
+          <p:cNvPr id="84" name="Text 82"/>
           <p:cNvSpPr txBox="1"/>
           <p:nvPr/>
         </p:nvSpPr>
@@ -22001,7 +22081,7 @@
       </p:sp>
       <p:sp>
         <p:nvSpPr>
-          <p:cNvPr id="81" name="Text 79"/>
+          <p:cNvPr id="85" name="Text 83"/>
           <p:cNvSpPr txBox="1"/>
           <p:nvPr/>
         </p:nvSpPr>
@@ -22040,7 +22120,7 @@
       </p:sp>
       <p:sp>
         <p:nvSpPr>
-          <p:cNvPr id="82" name="Text 80"/>
+          <p:cNvPr id="86" name="Text 84"/>
           <p:cNvSpPr txBox="1"/>
           <p:nvPr/>
         </p:nvSpPr>
@@ -22079,7 +22159,7 @@
       </p:sp>
       <p:sp>
         <p:nvSpPr>
-          <p:cNvPr id="83" name="Text 81"/>
+          <p:cNvPr id="87" name="Text 85"/>
           <p:cNvSpPr txBox="1"/>
           <p:nvPr/>
         </p:nvSpPr>
@@ -22118,7 +22198,7 @@
       </p:sp>
       <p:sp>
         <p:nvSpPr>
-          <p:cNvPr id="84" name="Text 82"/>
+          <p:cNvPr id="88" name="Text 86"/>
           <p:cNvSpPr txBox="1"/>
           <p:nvPr/>
         </p:nvSpPr>
@@ -22157,7 +22237,7 @@
       </p:sp>
       <p:sp>
         <p:nvSpPr>
-          <p:cNvPr id="85" name="Text 83"/>
+          <p:cNvPr id="89" name="Text 87"/>
           <p:cNvSpPr txBox="1"/>
           <p:nvPr/>
         </p:nvSpPr>
@@ -22196,7 +22276,7 @@
       </p:sp>
       <p:sp>
         <p:nvSpPr>
-          <p:cNvPr id="86" name="Text 84"/>
+          <p:cNvPr id="90" name="Text 88"/>
           <p:cNvSpPr txBox="1"/>
           <p:nvPr/>
         </p:nvSpPr>
@@ -22235,7 +22315,7 @@
       </p:sp>
       <p:sp>
         <p:nvSpPr>
-          <p:cNvPr id="87" name="Text 85"/>
+          <p:cNvPr id="91" name="Text 89"/>
           <p:cNvSpPr txBox="1"/>
           <p:nvPr/>
         </p:nvSpPr>
@@ -22274,7 +22354,7 @@
       </p:sp>
       <p:sp>
         <p:nvSpPr>
-          <p:cNvPr id="88" name="Text 86"/>
+          <p:cNvPr id="92" name="Text 90"/>
           <p:cNvSpPr txBox="1"/>
           <p:nvPr/>
         </p:nvSpPr>
@@ -22313,7 +22393,7 @@
       </p:sp>
       <p:sp>
         <p:nvSpPr>
-          <p:cNvPr id="89" name="Text 87"/>
+          <p:cNvPr id="93" name="Text 91"/>
           <p:cNvSpPr txBox="1"/>
           <p:nvPr/>
         </p:nvSpPr>
@@ -22352,7 +22432,7 @@
       </p:sp>
       <p:sp>
         <p:nvSpPr>
-          <p:cNvPr id="90" name="Text 88"/>
+          <p:cNvPr id="94" name="Text 92"/>
           <p:cNvSpPr txBox="1"/>
           <p:nvPr/>
         </p:nvSpPr>
@@ -22391,7 +22471,7 @@
       </p:sp>
       <p:sp>
         <p:nvSpPr>
-          <p:cNvPr id="91" name="Text 89"/>
+          <p:cNvPr id="95" name="Text 93"/>
           <p:cNvSpPr txBox="1"/>
           <p:nvPr/>
         </p:nvSpPr>
@@ -22430,7 +22510,7 @@
       </p:sp>
       <p:sp>
         <p:nvSpPr>
-          <p:cNvPr id="92" name="Text 90"/>
+          <p:cNvPr id="96" name="Text 94"/>
           <p:cNvSpPr txBox="1"/>
           <p:nvPr/>
         </p:nvSpPr>
@@ -22469,7 +22549,7 @@
       </p:sp>
       <p:sp>
         <p:nvSpPr>
-          <p:cNvPr id="93" name="Text 91"/>
+          <p:cNvPr id="97" name="Text 95"/>
           <p:cNvSpPr txBox="1"/>
           <p:nvPr/>
         </p:nvSpPr>
@@ -24691,6 +24771,86 @@
         </p:nvSpPr>
         <p:spPr>
           <a:xfrm>
+            <a:off x="3044952" y="1691640"/>
+            <a:ext cx="10973" cy="3977640"/>
+          </a:xfrm>
+          <a:prstGeom prst="rect">
+            <a:avLst/>
+          </a:prstGeom>
+          <a:solidFill>
+            <a:srgbClr val="D9D9D9"/>
+          </a:solidFill>
+          <a:ln/>
+        </p:spPr>
+      </p:sp>
+      <p:sp>
+        <p:nvSpPr>
+          <p:cNvPr id="20" name="Shape 18"/>
+          <p:cNvSpPr/>
+          <p:nvPr/>
+        </p:nvSpPr>
+        <p:spPr>
+          <a:xfrm>
+            <a:off x="5180990" y="1691640"/>
+            <a:ext cx="10973" cy="3977640"/>
+          </a:xfrm>
+          <a:prstGeom prst="rect">
+            <a:avLst/>
+          </a:prstGeom>
+          <a:solidFill>
+            <a:srgbClr val="D9D9D9"/>
+          </a:solidFill>
+          <a:ln/>
+        </p:spPr>
+      </p:sp>
+      <p:sp>
+        <p:nvSpPr>
+          <p:cNvPr id="21" name="Shape 19"/>
+          <p:cNvSpPr/>
+          <p:nvPr/>
+        </p:nvSpPr>
+        <p:spPr>
+          <a:xfrm>
+            <a:off x="7317029" y="1691640"/>
+            <a:ext cx="10973" cy="3977640"/>
+          </a:xfrm>
+          <a:prstGeom prst="rect">
+            <a:avLst/>
+          </a:prstGeom>
+          <a:solidFill>
+            <a:srgbClr val="D9D9D9"/>
+          </a:solidFill>
+          <a:ln/>
+        </p:spPr>
+      </p:sp>
+      <p:sp>
+        <p:nvSpPr>
+          <p:cNvPr id="22" name="Shape 20"/>
+          <p:cNvSpPr/>
+          <p:nvPr/>
+        </p:nvSpPr>
+        <p:spPr>
+          <a:xfrm>
+            <a:off x="9453067" y="1691640"/>
+            <a:ext cx="10973" cy="3977640"/>
+          </a:xfrm>
+          <a:prstGeom prst="rect">
+            <a:avLst/>
+          </a:prstGeom>
+          <a:solidFill>
+            <a:srgbClr val="D9D9D9"/>
+          </a:solidFill>
+          <a:ln/>
+        </p:spPr>
+      </p:sp>
+      <p:sp>
+        <p:nvSpPr>
+          <p:cNvPr id="23" name="Shape 21"/>
+          <p:cNvSpPr/>
+          <p:nvPr/>
+        </p:nvSpPr>
+        <p:spPr>
+          <a:xfrm>
             <a:off x="969264" y="1691640"/>
             <a:ext cx="2026310" cy="45720"/>
           </a:xfrm>
@@ -24705,7 +24865,7 @@
       </p:sp>
       <p:sp>
         <p:nvSpPr>
-          <p:cNvPr id="20" name="Text 18"/>
+          <p:cNvPr id="24" name="Text 22"/>
           <p:cNvSpPr txBox="1"/>
           <p:nvPr/>
         </p:nvSpPr>
@@ -24746,7 +24906,7 @@
       </p:sp>
       <p:sp>
         <p:nvSpPr>
-          <p:cNvPr id="21" name="Text 19"/>
+          <p:cNvPr id="25" name="Text 23"/>
           <p:cNvSpPr txBox="1"/>
           <p:nvPr/>
         </p:nvSpPr>
@@ -24785,7 +24945,7 @@
       </p:sp>
       <p:sp>
         <p:nvSpPr>
-          <p:cNvPr id="22" name="Text 20"/>
+          <p:cNvPr id="26" name="Text 24"/>
           <p:cNvSpPr txBox="1"/>
           <p:nvPr/>
         </p:nvSpPr>
@@ -24824,7 +24984,7 @@
       </p:sp>
       <p:sp>
         <p:nvSpPr>
-          <p:cNvPr id="23" name="Text 21"/>
+          <p:cNvPr id="27" name="Text 25"/>
           <p:cNvSpPr txBox="1"/>
           <p:nvPr/>
         </p:nvSpPr>
@@ -24863,7 +25023,7 @@
       </p:sp>
       <p:sp>
         <p:nvSpPr>
-          <p:cNvPr id="24" name="Text 22"/>
+          <p:cNvPr id="28" name="Text 26"/>
           <p:cNvSpPr txBox="1"/>
           <p:nvPr/>
         </p:nvSpPr>
@@ -24902,7 +25062,7 @@
       </p:sp>
       <p:sp>
         <p:nvSpPr>
-          <p:cNvPr id="25" name="Text 23"/>
+          <p:cNvPr id="29" name="Text 27"/>
           <p:cNvSpPr txBox="1"/>
           <p:nvPr/>
         </p:nvSpPr>
@@ -24941,7 +25101,7 @@
       </p:sp>
       <p:sp>
         <p:nvSpPr>
-          <p:cNvPr id="26" name="Text 24"/>
+          <p:cNvPr id="30" name="Text 28"/>
           <p:cNvSpPr txBox="1"/>
           <p:nvPr/>
         </p:nvSpPr>
@@ -24980,7 +25140,7 @@
       </p:sp>
       <p:sp>
         <p:nvSpPr>
-          <p:cNvPr id="27" name="Text 25"/>
+          <p:cNvPr id="31" name="Text 29"/>
           <p:cNvSpPr txBox="1"/>
           <p:nvPr/>
         </p:nvSpPr>
@@ -25019,7 +25179,7 @@
       </p:sp>
       <p:sp>
         <p:nvSpPr>
-          <p:cNvPr id="28" name="Text 26"/>
+          <p:cNvPr id="32" name="Text 30"/>
           <p:cNvSpPr txBox="1"/>
           <p:nvPr/>
         </p:nvSpPr>
@@ -25058,7 +25218,7 @@
       </p:sp>
       <p:sp>
         <p:nvSpPr>
-          <p:cNvPr id="29" name="Text 27"/>
+          <p:cNvPr id="33" name="Text 31"/>
           <p:cNvSpPr txBox="1"/>
           <p:nvPr/>
         </p:nvSpPr>
@@ -25097,7 +25257,7 @@
       </p:sp>
       <p:sp>
         <p:nvSpPr>
-          <p:cNvPr id="30" name="Text 28"/>
+          <p:cNvPr id="34" name="Text 32"/>
           <p:cNvSpPr txBox="1"/>
           <p:nvPr/>
         </p:nvSpPr>
@@ -25136,7 +25296,7 @@
       </p:sp>
       <p:sp>
         <p:nvSpPr>
-          <p:cNvPr id="31" name="Text 29"/>
+          <p:cNvPr id="35" name="Text 33"/>
           <p:cNvSpPr txBox="1"/>
           <p:nvPr/>
         </p:nvSpPr>
@@ -25175,7 +25335,7 @@
       </p:sp>
       <p:sp>
         <p:nvSpPr>
-          <p:cNvPr id="32" name="Text 30"/>
+          <p:cNvPr id="36" name="Text 34"/>
           <p:cNvSpPr txBox="1"/>
           <p:nvPr/>
         </p:nvSpPr>
@@ -25214,7 +25374,7 @@
       </p:sp>
       <p:sp>
         <p:nvSpPr>
-          <p:cNvPr id="33" name="Text 31"/>
+          <p:cNvPr id="37" name="Text 35"/>
           <p:cNvSpPr txBox="1"/>
           <p:nvPr/>
         </p:nvSpPr>
@@ -25253,7 +25413,7 @@
       </p:sp>
       <p:sp>
         <p:nvSpPr>
-          <p:cNvPr id="34" name="Shape 32"/>
+          <p:cNvPr id="38" name="Shape 36"/>
           <p:cNvSpPr/>
           <p:nvPr/>
         </p:nvSpPr>
@@ -25273,7 +25433,7 @@
       </p:sp>
       <p:sp>
         <p:nvSpPr>
-          <p:cNvPr id="35" name="Text 33"/>
+          <p:cNvPr id="39" name="Text 37"/>
           <p:cNvSpPr txBox="1"/>
           <p:nvPr/>
         </p:nvSpPr>
@@ -25314,7 +25474,7 @@
       </p:sp>
       <p:sp>
         <p:nvSpPr>
-          <p:cNvPr id="36" name="Text 34"/>
+          <p:cNvPr id="40" name="Text 38"/>
           <p:cNvSpPr txBox="1"/>
           <p:nvPr/>
         </p:nvSpPr>
@@ -25353,7 +25513,7 @@
       </p:sp>
       <p:sp>
         <p:nvSpPr>
-          <p:cNvPr id="37" name="Text 35"/>
+          <p:cNvPr id="41" name="Text 39"/>
           <p:cNvSpPr txBox="1"/>
           <p:nvPr/>
         </p:nvSpPr>
@@ -25392,7 +25552,7 @@
       </p:sp>
       <p:sp>
         <p:nvSpPr>
-          <p:cNvPr id="38" name="Text 36"/>
+          <p:cNvPr id="42" name="Text 40"/>
           <p:cNvSpPr txBox="1"/>
           <p:nvPr/>
         </p:nvSpPr>
@@ -25431,7 +25591,7 @@
       </p:sp>
       <p:sp>
         <p:nvSpPr>
-          <p:cNvPr id="39" name="Text 37"/>
+          <p:cNvPr id="43" name="Text 41"/>
           <p:cNvSpPr txBox="1"/>
           <p:nvPr/>
         </p:nvSpPr>
@@ -25470,7 +25630,7 @@
       </p:sp>
       <p:sp>
         <p:nvSpPr>
-          <p:cNvPr id="40" name="Text 38"/>
+          <p:cNvPr id="44" name="Text 42"/>
           <p:cNvSpPr txBox="1"/>
           <p:nvPr/>
         </p:nvSpPr>
@@ -25509,7 +25669,7 @@
       </p:sp>
       <p:sp>
         <p:nvSpPr>
-          <p:cNvPr id="41" name="Text 39"/>
+          <p:cNvPr id="45" name="Text 43"/>
           <p:cNvSpPr txBox="1"/>
           <p:nvPr/>
         </p:nvSpPr>
@@ -25548,7 +25708,7 @@
       </p:sp>
       <p:sp>
         <p:nvSpPr>
-          <p:cNvPr id="42" name="Text 40"/>
+          <p:cNvPr id="46" name="Text 44"/>
           <p:cNvSpPr txBox="1"/>
           <p:nvPr/>
         </p:nvSpPr>
@@ -25587,7 +25747,7 @@
       </p:sp>
       <p:sp>
         <p:nvSpPr>
-          <p:cNvPr id="43" name="Text 41"/>
+          <p:cNvPr id="47" name="Text 45"/>
           <p:cNvSpPr txBox="1"/>
           <p:nvPr/>
         </p:nvSpPr>
@@ -25626,7 +25786,7 @@
       </p:sp>
       <p:sp>
         <p:nvSpPr>
-          <p:cNvPr id="44" name="Text 42"/>
+          <p:cNvPr id="48" name="Text 46"/>
           <p:cNvSpPr txBox="1"/>
           <p:nvPr/>
         </p:nvSpPr>
@@ -25665,7 +25825,7 @@
       </p:sp>
       <p:sp>
         <p:nvSpPr>
-          <p:cNvPr id="45" name="Text 43"/>
+          <p:cNvPr id="49" name="Text 47"/>
           <p:cNvSpPr txBox="1"/>
           <p:nvPr/>
         </p:nvSpPr>
@@ -25704,7 +25864,7 @@
       </p:sp>
       <p:sp>
         <p:nvSpPr>
-          <p:cNvPr id="46" name="Text 44"/>
+          <p:cNvPr id="50" name="Text 48"/>
           <p:cNvSpPr txBox="1"/>
           <p:nvPr/>
         </p:nvSpPr>
@@ -25743,7 +25903,7 @@
       </p:sp>
       <p:sp>
         <p:nvSpPr>
-          <p:cNvPr id="47" name="Text 45"/>
+          <p:cNvPr id="51" name="Text 49"/>
           <p:cNvSpPr txBox="1"/>
           <p:nvPr/>
         </p:nvSpPr>
@@ -25782,7 +25942,7 @@
       </p:sp>
       <p:sp>
         <p:nvSpPr>
-          <p:cNvPr id="48" name="Text 46"/>
+          <p:cNvPr id="52" name="Text 50"/>
           <p:cNvSpPr txBox="1"/>
           <p:nvPr/>
         </p:nvSpPr>
@@ -25821,7 +25981,7 @@
       </p:sp>
       <p:sp>
         <p:nvSpPr>
-          <p:cNvPr id="49" name="Shape 47"/>
+          <p:cNvPr id="53" name="Shape 51"/>
           <p:cNvSpPr/>
           <p:nvPr/>
         </p:nvSpPr>
@@ -25841,7 +26001,7 @@
       </p:sp>
       <p:sp>
         <p:nvSpPr>
-          <p:cNvPr id="50" name="Text 48"/>
+          <p:cNvPr id="54" name="Text 52"/>
           <p:cNvSpPr txBox="1"/>
           <p:nvPr/>
         </p:nvSpPr>
@@ -25882,7 +26042,7 @@
       </p:sp>
       <p:sp>
         <p:nvSpPr>
-          <p:cNvPr id="51" name="Text 49"/>
+          <p:cNvPr id="55" name="Text 53"/>
           <p:cNvSpPr txBox="1"/>
           <p:nvPr/>
         </p:nvSpPr>
@@ -25921,7 +26081,7 @@
       </p:sp>
       <p:sp>
         <p:nvSpPr>
-          <p:cNvPr id="52" name="Text 50"/>
+          <p:cNvPr id="56" name="Text 54"/>
           <p:cNvSpPr txBox="1"/>
           <p:nvPr/>
         </p:nvSpPr>
@@ -25960,7 +26120,7 @@
       </p:sp>
       <p:sp>
         <p:nvSpPr>
-          <p:cNvPr id="53" name="Text 51"/>
+          <p:cNvPr id="57" name="Text 55"/>
           <p:cNvSpPr txBox="1"/>
           <p:nvPr/>
         </p:nvSpPr>
@@ -25999,7 +26159,7 @@
       </p:sp>
       <p:sp>
         <p:nvSpPr>
-          <p:cNvPr id="54" name="Text 52"/>
+          <p:cNvPr id="58" name="Text 56"/>
           <p:cNvSpPr txBox="1"/>
           <p:nvPr/>
         </p:nvSpPr>
@@ -26038,7 +26198,7 @@
       </p:sp>
       <p:sp>
         <p:nvSpPr>
-          <p:cNvPr id="55" name="Text 53"/>
+          <p:cNvPr id="59" name="Text 57"/>
           <p:cNvSpPr txBox="1"/>
           <p:nvPr/>
         </p:nvSpPr>
@@ -26077,7 +26237,7 @@
       </p:sp>
       <p:sp>
         <p:nvSpPr>
-          <p:cNvPr id="56" name="Text 54"/>
+          <p:cNvPr id="60" name="Text 58"/>
           <p:cNvSpPr txBox="1"/>
           <p:nvPr/>
         </p:nvSpPr>
@@ -26116,7 +26276,7 @@
       </p:sp>
       <p:sp>
         <p:nvSpPr>
-          <p:cNvPr id="57" name="Text 55"/>
+          <p:cNvPr id="61" name="Text 59"/>
           <p:cNvSpPr txBox="1"/>
           <p:nvPr/>
         </p:nvSpPr>
@@ -26155,7 +26315,7 @@
       </p:sp>
       <p:sp>
         <p:nvSpPr>
-          <p:cNvPr id="58" name="Text 56"/>
+          <p:cNvPr id="62" name="Text 60"/>
           <p:cNvSpPr txBox="1"/>
           <p:nvPr/>
         </p:nvSpPr>
@@ -26194,7 +26354,7 @@
       </p:sp>
       <p:sp>
         <p:nvSpPr>
-          <p:cNvPr id="59" name="Text 57"/>
+          <p:cNvPr id="63" name="Text 61"/>
           <p:cNvSpPr txBox="1"/>
           <p:nvPr/>
         </p:nvSpPr>
@@ -26233,7 +26393,7 @@
       </p:sp>
       <p:sp>
         <p:nvSpPr>
-          <p:cNvPr id="60" name="Text 58"/>
+          <p:cNvPr id="64" name="Text 62"/>
           <p:cNvSpPr txBox="1"/>
           <p:nvPr/>
         </p:nvSpPr>
@@ -26272,7 +26432,7 @@
       </p:sp>
       <p:sp>
         <p:nvSpPr>
-          <p:cNvPr id="61" name="Text 59"/>
+          <p:cNvPr id="65" name="Text 63"/>
           <p:cNvSpPr txBox="1"/>
           <p:nvPr/>
         </p:nvSpPr>
@@ -26311,7 +26471,7 @@
       </p:sp>
       <p:sp>
         <p:nvSpPr>
-          <p:cNvPr id="62" name="Text 60"/>
+          <p:cNvPr id="66" name="Text 64"/>
           <p:cNvSpPr txBox="1"/>
           <p:nvPr/>
         </p:nvSpPr>
@@ -26350,7 +26510,7 @@
       </p:sp>
       <p:sp>
         <p:nvSpPr>
-          <p:cNvPr id="63" name="Text 61"/>
+          <p:cNvPr id="67" name="Text 65"/>
           <p:cNvSpPr txBox="1"/>
           <p:nvPr/>
         </p:nvSpPr>
@@ -26389,7 +26549,7 @@
       </p:sp>
       <p:sp>
         <p:nvSpPr>
-          <p:cNvPr id="64" name="Shape 62"/>
+          <p:cNvPr id="68" name="Shape 66"/>
           <p:cNvSpPr/>
           <p:nvPr/>
         </p:nvSpPr>
@@ -26409,7 +26569,7 @@
       </p:sp>
       <p:sp>
         <p:nvSpPr>
-          <p:cNvPr id="65" name="Text 63"/>
+          <p:cNvPr id="69" name="Text 67"/>
           <p:cNvSpPr txBox="1"/>
           <p:nvPr/>
         </p:nvSpPr>
@@ -26450,7 +26610,7 @@
       </p:sp>
       <p:sp>
         <p:nvSpPr>
-          <p:cNvPr id="66" name="Text 64"/>
+          <p:cNvPr id="70" name="Text 68"/>
           <p:cNvSpPr txBox="1"/>
           <p:nvPr/>
         </p:nvSpPr>
@@ -26489,7 +26649,7 @@
       </p:sp>
       <p:sp>
         <p:nvSpPr>
-          <p:cNvPr id="67" name="Text 65"/>
+          <p:cNvPr id="71" name="Text 69"/>
           <p:cNvSpPr txBox="1"/>
           <p:nvPr/>
         </p:nvSpPr>
@@ -26528,7 +26688,7 @@
       </p:sp>
       <p:sp>
         <p:nvSpPr>
-          <p:cNvPr id="68" name="Text 66"/>
+          <p:cNvPr id="72" name="Text 70"/>
           <p:cNvSpPr txBox="1"/>
           <p:nvPr/>
         </p:nvSpPr>
@@ -26567,7 +26727,7 @@
       </p:sp>
       <p:sp>
         <p:nvSpPr>
-          <p:cNvPr id="69" name="Text 67"/>
+          <p:cNvPr id="73" name="Text 71"/>
           <p:cNvSpPr txBox="1"/>
           <p:nvPr/>
         </p:nvSpPr>
@@ -26606,7 +26766,7 @@
       </p:sp>
       <p:sp>
         <p:nvSpPr>
-          <p:cNvPr id="70" name="Text 68"/>
+          <p:cNvPr id="74" name="Text 72"/>
           <p:cNvSpPr txBox="1"/>
           <p:nvPr/>
         </p:nvSpPr>
@@ -26645,7 +26805,7 @@
       </p:sp>
       <p:sp>
         <p:nvSpPr>
-          <p:cNvPr id="71" name="Text 69"/>
+          <p:cNvPr id="75" name="Text 73"/>
           <p:cNvSpPr txBox="1"/>
           <p:nvPr/>
         </p:nvSpPr>
@@ -26684,7 +26844,7 @@
       </p:sp>
       <p:sp>
         <p:nvSpPr>
-          <p:cNvPr id="72" name="Text 70"/>
+          <p:cNvPr id="76" name="Text 74"/>
           <p:cNvSpPr txBox="1"/>
           <p:nvPr/>
         </p:nvSpPr>
@@ -26723,7 +26883,7 @@
       </p:sp>
       <p:sp>
         <p:nvSpPr>
-          <p:cNvPr id="73" name="Text 71"/>
+          <p:cNvPr id="77" name="Text 75"/>
           <p:cNvSpPr txBox="1"/>
           <p:nvPr/>
         </p:nvSpPr>
@@ -26762,7 +26922,7 @@
       </p:sp>
       <p:sp>
         <p:nvSpPr>
-          <p:cNvPr id="74" name="Text 72"/>
+          <p:cNvPr id="78" name="Text 76"/>
           <p:cNvSpPr txBox="1"/>
           <p:nvPr/>
         </p:nvSpPr>
@@ -26801,7 +26961,7 @@
       </p:sp>
       <p:sp>
         <p:nvSpPr>
-          <p:cNvPr id="75" name="Text 73"/>
+          <p:cNvPr id="79" name="Text 77"/>
           <p:cNvSpPr txBox="1"/>
           <p:nvPr/>
         </p:nvSpPr>
@@ -26840,7 +27000,7 @@
       </p:sp>
       <p:sp>
         <p:nvSpPr>
-          <p:cNvPr id="76" name="Text 74"/>
+          <p:cNvPr id="80" name="Text 78"/>
           <p:cNvSpPr txBox="1"/>
           <p:nvPr/>
         </p:nvSpPr>
@@ -26879,7 +27039,7 @@
       </p:sp>
       <p:sp>
         <p:nvSpPr>
-          <p:cNvPr id="77" name="Text 75"/>
+          <p:cNvPr id="81" name="Text 79"/>
           <p:cNvSpPr txBox="1"/>
           <p:nvPr/>
         </p:nvSpPr>
@@ -26918,7 +27078,7 @@
       </p:sp>
       <p:sp>
         <p:nvSpPr>
-          <p:cNvPr id="78" name="Text 76"/>
+          <p:cNvPr id="82" name="Text 80"/>
           <p:cNvSpPr txBox="1"/>
           <p:nvPr/>
         </p:nvSpPr>
@@ -26957,7 +27117,7 @@
       </p:sp>
       <p:sp>
         <p:nvSpPr>
-          <p:cNvPr id="79" name="Shape 77"/>
+          <p:cNvPr id="83" name="Shape 81"/>
           <p:cNvSpPr/>
           <p:nvPr/>
         </p:nvSpPr>
@@ -26977,7 +27137,7 @@
       </p:sp>
       <p:sp>
         <p:nvSpPr>
-          <p:cNvPr id="80" name="Text 78"/>
+          <p:cNvPr id="84" name="Text 82"/>
           <p:cNvSpPr txBox="1"/>
           <p:nvPr/>
         </p:nvSpPr>
@@ -27018,7 +27178,7 @@
       </p:sp>
       <p:sp>
         <p:nvSpPr>
-          <p:cNvPr id="81" name="Text 79"/>
+          <p:cNvPr id="85" name="Text 83"/>
           <p:cNvSpPr txBox="1"/>
           <p:nvPr/>
         </p:nvSpPr>
@@ -27057,7 +27217,7 @@
       </p:sp>
       <p:sp>
         <p:nvSpPr>
-          <p:cNvPr id="82" name="Text 80"/>
+          <p:cNvPr id="86" name="Text 84"/>
           <p:cNvSpPr txBox="1"/>
           <p:nvPr/>
         </p:nvSpPr>
@@ -27096,7 +27256,7 @@
       </p:sp>
       <p:sp>
         <p:nvSpPr>
-          <p:cNvPr id="83" name="Text 81"/>
+          <p:cNvPr id="87" name="Text 85"/>
           <p:cNvSpPr txBox="1"/>
           <p:nvPr/>
         </p:nvSpPr>
@@ -27135,7 +27295,7 @@
       </p:sp>
       <p:sp>
         <p:nvSpPr>
-          <p:cNvPr id="84" name="Text 82"/>
+          <p:cNvPr id="88" name="Text 86"/>
           <p:cNvSpPr txBox="1"/>
           <p:nvPr/>
         </p:nvSpPr>
@@ -27174,7 +27334,7 @@
       </p:sp>
       <p:sp>
         <p:nvSpPr>
-          <p:cNvPr id="85" name="Text 83"/>
+          <p:cNvPr id="89" name="Text 87"/>
           <p:cNvSpPr txBox="1"/>
           <p:nvPr/>
         </p:nvSpPr>
@@ -27213,7 +27373,7 @@
       </p:sp>
       <p:sp>
         <p:nvSpPr>
-          <p:cNvPr id="86" name="Text 84"/>
+          <p:cNvPr id="90" name="Text 88"/>
           <p:cNvSpPr txBox="1"/>
           <p:nvPr/>
         </p:nvSpPr>
@@ -27252,7 +27412,7 @@
       </p:sp>
       <p:sp>
         <p:nvSpPr>
-          <p:cNvPr id="87" name="Text 85"/>
+          <p:cNvPr id="91" name="Text 89"/>
           <p:cNvSpPr txBox="1"/>
           <p:nvPr/>
         </p:nvSpPr>
@@ -27291,7 +27451,7 @@
       </p:sp>
       <p:sp>
         <p:nvSpPr>
-          <p:cNvPr id="88" name="Text 86"/>
+          <p:cNvPr id="92" name="Text 90"/>
           <p:cNvSpPr txBox="1"/>
           <p:nvPr/>
         </p:nvSpPr>
@@ -27330,7 +27490,7 @@
       </p:sp>
       <p:sp>
         <p:nvSpPr>
-          <p:cNvPr id="89" name="Text 87"/>
+          <p:cNvPr id="93" name="Text 91"/>
           <p:cNvSpPr txBox="1"/>
           <p:nvPr/>
         </p:nvSpPr>
@@ -27369,7 +27529,7 @@
       </p:sp>
       <p:sp>
         <p:nvSpPr>
-          <p:cNvPr id="90" name="Text 88"/>
+          <p:cNvPr id="94" name="Text 92"/>
           <p:cNvSpPr txBox="1"/>
           <p:nvPr/>
         </p:nvSpPr>
@@ -27408,7 +27568,7 @@
       </p:sp>
       <p:sp>
         <p:nvSpPr>
-          <p:cNvPr id="91" name="Text 89"/>
+          <p:cNvPr id="95" name="Text 93"/>
           <p:cNvSpPr txBox="1"/>
           <p:nvPr/>
         </p:nvSpPr>
@@ -27447,7 +27607,7 @@
       </p:sp>
       <p:sp>
         <p:nvSpPr>
-          <p:cNvPr id="92" name="Text 90"/>
+          <p:cNvPr id="96" name="Text 94"/>
           <p:cNvSpPr txBox="1"/>
           <p:nvPr/>
         </p:nvSpPr>
@@ -27486,7 +27646,7 @@
       </p:sp>
       <p:sp>
         <p:nvSpPr>
-          <p:cNvPr id="93" name="Text 91"/>
+          <p:cNvPr id="97" name="Text 95"/>
           <p:cNvSpPr txBox="1"/>
           <p:nvPr/>
         </p:nvSpPr>
@@ -43697,6 +43857,26 @@
         </p:nvSpPr>
         <p:spPr>
           <a:xfrm>
+            <a:off x="5788152" y="3968496"/>
+            <a:ext cx="64008" cy="512064"/>
+          </a:xfrm>
+          <a:prstGeom prst="rect">
+            <a:avLst/>
+          </a:prstGeom>
+          <a:solidFill>
+            <a:srgbClr val="12A566"/>
+          </a:solidFill>
+          <a:ln/>
+        </p:spPr>
+      </p:sp>
+      <p:sp>
+        <p:nvSpPr>
+          <p:cNvPr id="28" name="Shape 26"/>
+          <p:cNvSpPr/>
+          <p:nvPr/>
+        </p:nvSpPr>
+        <p:spPr>
+          <a:xfrm>
             <a:off x="621792" y="4517136"/>
             <a:ext cx="5230368" cy="585216"/>
           </a:xfrm>
@@ -43711,7 +43891,7 @@
       </p:sp>
       <p:sp>
         <p:nvSpPr>
-          <p:cNvPr id="28" name="Text 26"/>
+          <p:cNvPr id="29" name="Text 27"/>
           <p:cNvSpPr txBox="1"/>
           <p:nvPr/>
         </p:nvSpPr>
@@ -43750,7 +43930,7 @@
       </p:sp>
       <p:sp>
         <p:nvSpPr>
-          <p:cNvPr id="29" name="Text 27"/>
+          <p:cNvPr id="30" name="Text 28"/>
           <p:cNvSpPr txBox="1"/>
           <p:nvPr/>
         </p:nvSpPr>
@@ -43789,7 +43969,7 @@
       </p:sp>
       <p:sp>
         <p:nvSpPr>
-          <p:cNvPr id="30" name="Shape 28"/>
+          <p:cNvPr id="31" name="Shape 29"/>
           <p:cNvSpPr/>
           <p:nvPr/>
         </p:nvSpPr>
@@ -43809,7 +43989,7 @@
       </p:sp>
       <p:sp>
         <p:nvSpPr>
-          <p:cNvPr id="31" name="Text 29"/>
+          <p:cNvPr id="32" name="Text 30"/>
           <p:cNvSpPr txBox="1"/>
           <p:nvPr/>
         </p:nvSpPr>
@@ -43848,7 +44028,7 @@
       </p:sp>
       <p:sp>
         <p:nvSpPr>
-          <p:cNvPr id="32" name="Text 30"/>
+          <p:cNvPr id="33" name="Text 31"/>
           <p:cNvSpPr txBox="1"/>
           <p:nvPr/>
         </p:nvSpPr>
@@ -43887,7 +44067,7 @@
       </p:sp>
       <p:sp>
         <p:nvSpPr>
-          <p:cNvPr id="33" name="Text 31"/>
+          <p:cNvPr id="34" name="Text 32"/>
           <p:cNvSpPr txBox="1"/>
           <p:nvPr/>
         </p:nvSpPr>
@@ -43926,7 +44106,7 @@
       </p:sp>
       <p:sp>
         <p:nvSpPr>
-          <p:cNvPr id="34" name="Shape 32"/>
+          <p:cNvPr id="35" name="Shape 33"/>
           <p:cNvSpPr/>
           <p:nvPr/>
         </p:nvSpPr>
@@ -43946,7 +44126,7 @@
       </p:sp>
       <p:sp>
         <p:nvSpPr>
-          <p:cNvPr id="35" name="Text 33"/>
+          <p:cNvPr id="36" name="Text 34"/>
           <p:cNvSpPr txBox="1"/>
           <p:nvPr/>
         </p:nvSpPr>
@@ -43985,7 +44165,7 @@
       </p:sp>
       <p:sp>
         <p:nvSpPr>
-          <p:cNvPr id="36" name="Shape 34"/>
+          <p:cNvPr id="37" name="Shape 35"/>
           <p:cNvSpPr/>
           <p:nvPr/>
         </p:nvSpPr>
@@ -44005,7 +44185,7 @@
       </p:sp>
       <p:sp>
         <p:nvSpPr>
-          <p:cNvPr id="37" name="Text 35"/>
+          <p:cNvPr id="38" name="Text 36"/>
           <p:cNvSpPr txBox="1"/>
           <p:nvPr/>
         </p:nvSpPr>
@@ -44044,7 +44224,7 @@
       </p:sp>
       <p:sp>
         <p:nvSpPr>
-          <p:cNvPr id="38" name="Shape 36"/>
+          <p:cNvPr id="39" name="Shape 37"/>
           <p:cNvSpPr/>
           <p:nvPr/>
         </p:nvSpPr>
@@ -44064,7 +44244,7 @@
       </p:sp>
       <p:sp>
         <p:nvSpPr>
-          <p:cNvPr id="39" name="Text 37"/>
+          <p:cNvPr id="40" name="Text 38"/>
           <p:cNvSpPr txBox="1"/>
           <p:nvPr/>
         </p:nvSpPr>
@@ -44103,7 +44283,7 @@
       </p:sp>
       <p:sp>
         <p:nvSpPr>
-          <p:cNvPr id="40" name="Shape 38"/>
+          <p:cNvPr id="41" name="Shape 39"/>
           <p:cNvSpPr/>
           <p:nvPr/>
         </p:nvSpPr>
@@ -44123,7 +44303,7 @@
       </p:sp>
       <p:sp>
         <p:nvSpPr>
-          <p:cNvPr id="41" name="Text 39"/>
+          <p:cNvPr id="42" name="Text 40"/>
           <p:cNvSpPr txBox="1"/>
           <p:nvPr/>
         </p:nvSpPr>
@@ -44162,7 +44342,7 @@
       </p:sp>
       <p:sp>
         <p:nvSpPr>
-          <p:cNvPr id="42" name="Text 40"/>
+          <p:cNvPr id="43" name="Text 41"/>
           <p:cNvSpPr txBox="1"/>
           <p:nvPr/>
         </p:nvSpPr>
@@ -44201,7 +44381,7 @@
       </p:sp>
       <p:sp>
         <p:nvSpPr>
-          <p:cNvPr id="43" name="Shape 41"/>
+          <p:cNvPr id="44" name="Shape 42"/>
           <p:cNvSpPr/>
           <p:nvPr/>
         </p:nvSpPr>
@@ -44221,7 +44401,7 @@
       </p:sp>
       <p:sp>
         <p:nvSpPr>
-          <p:cNvPr id="44" name="Text 42"/>
+          <p:cNvPr id="45" name="Text 43"/>
           <p:cNvSpPr txBox="1"/>
           <p:nvPr/>
         </p:nvSpPr>
@@ -44260,7 +44440,7 @@
       </p:sp>
       <p:sp>
         <p:nvSpPr>
-          <p:cNvPr id="45" name="Text 43"/>
+          <p:cNvPr id="46" name="Text 44"/>
           <p:cNvSpPr txBox="1"/>
           <p:nvPr/>
         </p:nvSpPr>
@@ -44299,7 +44479,7 @@
       </p:sp>
       <p:sp>
         <p:nvSpPr>
-          <p:cNvPr id="46" name="Text 44"/>
+          <p:cNvPr id="47" name="Text 45"/>
           <p:cNvSpPr txBox="1"/>
           <p:nvPr/>
         </p:nvSpPr>
@@ -44338,7 +44518,7 @@
       </p:sp>
       <p:sp>
         <p:nvSpPr>
-          <p:cNvPr id="47" name="Shape 45"/>
+          <p:cNvPr id="48" name="Shape 46"/>
           <p:cNvSpPr/>
           <p:nvPr/>
         </p:nvSpPr>
@@ -44358,7 +44538,7 @@
       </p:sp>
       <p:sp>
         <p:nvSpPr>
-          <p:cNvPr id="48" name="Text 46"/>
+          <p:cNvPr id="49" name="Text 47"/>
           <p:cNvSpPr txBox="1"/>
           <p:nvPr/>
         </p:nvSpPr>
@@ -44397,7 +44577,27 @@
       </p:sp>
       <p:sp>
         <p:nvSpPr>
-          <p:cNvPr id="49" name="Shape 47"/>
+          <p:cNvPr id="50" name="Shape 48"/>
+          <p:cNvSpPr/>
+          <p:nvPr/>
+        </p:nvSpPr>
+        <p:spPr>
+          <a:xfrm>
+            <a:off x="11503152" y="2798064"/>
+            <a:ext cx="64008" cy="512064"/>
+          </a:xfrm>
+          <a:prstGeom prst="rect">
+            <a:avLst/>
+          </a:prstGeom>
+          <a:solidFill>
+            <a:srgbClr val="12A566"/>
+          </a:solidFill>
+          <a:ln/>
+        </p:spPr>
+      </p:sp>
+      <p:sp>
+        <p:nvSpPr>
+          <p:cNvPr id="51" name="Shape 49"/>
           <p:cNvSpPr/>
           <p:nvPr/>
         </p:nvSpPr>
@@ -44417,7 +44617,7 @@
       </p:sp>
       <p:sp>
         <p:nvSpPr>
-          <p:cNvPr id="50" name="Text 48"/>
+          <p:cNvPr id="52" name="Text 50"/>
           <p:cNvSpPr txBox="1"/>
           <p:nvPr/>
         </p:nvSpPr>
@@ -44456,7 +44656,7 @@
       </p:sp>
       <p:sp>
         <p:nvSpPr>
-          <p:cNvPr id="51" name="Text 49"/>
+          <p:cNvPr id="53" name="Text 51"/>
           <p:cNvSpPr txBox="1"/>
           <p:nvPr/>
         </p:nvSpPr>
@@ -44495,7 +44695,7 @@
       </p:sp>
       <p:sp>
         <p:nvSpPr>
-          <p:cNvPr id="52" name="Shape 50"/>
+          <p:cNvPr id="54" name="Shape 52"/>
           <p:cNvSpPr/>
           <p:nvPr/>
         </p:nvSpPr>
@@ -44515,7 +44715,7 @@
       </p:sp>
       <p:sp>
         <p:nvSpPr>
-          <p:cNvPr id="53" name="Text 51"/>
+          <p:cNvPr id="55" name="Text 53"/>
           <p:cNvSpPr txBox="1"/>
           <p:nvPr/>
         </p:nvSpPr>
@@ -44554,7 +44754,7 @@
       </p:sp>
       <p:sp>
         <p:nvSpPr>
-          <p:cNvPr id="54" name="Text 52"/>
+          <p:cNvPr id="56" name="Text 54"/>
           <p:cNvSpPr txBox="1"/>
           <p:nvPr/>
         </p:nvSpPr>
@@ -44593,7 +44793,7 @@
       </p:sp>
       <p:sp>
         <p:nvSpPr>
-          <p:cNvPr id="55" name="Text 53"/>
+          <p:cNvPr id="57" name="Text 55"/>
           <p:cNvSpPr txBox="1"/>
           <p:nvPr/>
         </p:nvSpPr>
@@ -44632,7 +44832,7 @@
       </p:sp>
       <p:sp>
         <p:nvSpPr>
-          <p:cNvPr id="56" name="Shape 54"/>
+          <p:cNvPr id="58" name="Shape 56"/>
           <p:cNvSpPr/>
           <p:nvPr/>
         </p:nvSpPr>
@@ -44652,7 +44852,7 @@
       </p:sp>
       <p:sp>
         <p:nvSpPr>
-          <p:cNvPr id="57" name="Text 55"/>
+          <p:cNvPr id="59" name="Text 57"/>
           <p:cNvSpPr txBox="1"/>
           <p:nvPr/>
         </p:nvSpPr>
@@ -44691,7 +44891,7 @@
       </p:sp>
       <p:sp>
         <p:nvSpPr>
-          <p:cNvPr id="58" name="Shape 56"/>
+          <p:cNvPr id="60" name="Shape 58"/>
           <p:cNvSpPr/>
           <p:nvPr/>
         </p:nvSpPr>
@@ -44711,7 +44911,7 @@
       </p:sp>
       <p:sp>
         <p:nvSpPr>
-          <p:cNvPr id="59" name="Text 57"/>
+          <p:cNvPr id="61" name="Text 59"/>
           <p:cNvSpPr txBox="1"/>
           <p:nvPr/>
         </p:nvSpPr>
@@ -44750,7 +44950,7 @@
       </p:sp>
       <p:sp>
         <p:nvSpPr>
-          <p:cNvPr id="60" name="Text 58"/>
+          <p:cNvPr id="62" name="Text 60"/>
           <p:cNvSpPr txBox="1"/>
           <p:nvPr/>
         </p:nvSpPr>
@@ -44789,7 +44989,7 @@
       </p:sp>
       <p:sp>
         <p:nvSpPr>
-          <p:cNvPr id="61" name="Shape 59"/>
+          <p:cNvPr id="63" name="Shape 61"/>
           <p:cNvSpPr/>
           <p:nvPr/>
         </p:nvSpPr>
@@ -44809,7 +45009,7 @@
       </p:sp>
       <p:sp>
         <p:nvSpPr>
-          <p:cNvPr id="62" name="Text 60"/>
+          <p:cNvPr id="64" name="Text 62"/>
           <p:cNvSpPr txBox="1"/>
           <p:nvPr/>
         </p:nvSpPr>
@@ -44848,7 +45048,7 @@
       </p:sp>
       <p:sp>
         <p:nvSpPr>
-          <p:cNvPr id="63" name="Text 61"/>
+          <p:cNvPr id="65" name="Text 63"/>
           <p:cNvSpPr txBox="1"/>
           <p:nvPr/>
         </p:nvSpPr>
@@ -44887,7 +45087,7 @@
       </p:sp>
       <p:sp>
         <p:nvSpPr>
-          <p:cNvPr id="64" name="Text 62"/>
+          <p:cNvPr id="66" name="Text 64"/>
           <p:cNvSpPr txBox="1"/>
           <p:nvPr/>
         </p:nvSpPr>
@@ -44926,7 +45126,7 @@
       </p:sp>
       <p:sp>
         <p:nvSpPr>
-          <p:cNvPr id="65" name="Shape 63"/>
+          <p:cNvPr id="67" name="Shape 65"/>
           <p:cNvSpPr/>
           <p:nvPr/>
         </p:nvSpPr>
@@ -44946,7 +45146,7 @@
       </p:sp>
       <p:sp>
         <p:nvSpPr>
-          <p:cNvPr id="66" name="Text 64"/>
+          <p:cNvPr id="68" name="Text 66"/>
           <p:cNvSpPr txBox="1"/>
           <p:nvPr/>
         </p:nvSpPr>
@@ -44985,7 +45185,7 @@
       </p:sp>
       <p:sp>
         <p:nvSpPr>
-          <p:cNvPr id="68" name="Shape 65"/>
+          <p:cNvPr id="70" name="Shape 67"/>
           <p:cNvSpPr/>
           <p:nvPr/>
         </p:nvSpPr>
@@ -45005,7 +45205,7 @@
       </p:sp>
       <p:sp>
         <p:nvSpPr>
-          <p:cNvPr id="69" name="Text 66"/>
+          <p:cNvPr id="71" name="Text 68"/>
           <p:cNvSpPr txBox="1"/>
           <p:nvPr/>
         </p:nvSpPr>
@@ -45036,7 +45236,7 @@
                 <a:ea typeface="Inter" pitchFamily="34" charset="-122"/>
                 <a:cs typeface="Inter" pitchFamily="34" charset="-120"/>
               </a:rPr>
-              <a:t>Moving now: Three stores tie. Eight stores make both views.</a:t>
+              <a:t>Moving now: Three stores tie. One store is on both lists (green bar).</a:t>
             </a:r>
             <a:endParaRPr lang="en-US" sz="1600" dirty="0"/>
           </a:p>

</xml_diff>

<commit_message>
Day 2 deck: Service Is Sales monthly increase, Flai back to last 90 days, People bullets, What Changed lists all opcodes
Co-Authored-By: Claude Opus 5.5 <noreply@anthropic.com>
Claude-Session: https://claude.ai/code/session_01Xa4nFVxuQGXmHARGph9WhS
</commit_message>
<xml_diff>
--- a/day2-deck/decks/Most Improved v2 - Review.pptx
+++ b/day2-deck/decks/Most Improved v2 - Review.pptx
@@ -18065,7 +18065,7 @@
           <a:p>
             <a:r>
               <a:rPr lang="en-US" dirty="0"/>
-              <a:t>Source: Qlik - Closed Repair Orders. Customer pay, by close date. Same-store, 33 stores (INEOS excluded, opened 2026). GMC Prescott body shop labor types excluded. CP gross = CP labor gross + CP parts gross. Change is Jul-Sep 2026 (Q3) vs Jan-Mar 2026 (Q1), each store against itself. Gross and ROs are per-month averages of each quarter. The group's own Q1-to-Q3 change is the seasonal baseline: it is the same for every store, so ranking by a store's change is the same as ranking by how far it beat the group. 'Stepped up in' = the month that best splits the store's year into a lower stretch before and a higher stretch after (at least three months before, two after). It is a conversation starter, not proof of cause. Each row is the top Q1-to-Q3 mover on that measure. Opcode row: MAZDA tops 3 of the four opcode lists; the biggest of those moves is shown. Opcode closing % = ROs with the service ÷ customer-pay ROs on the op-code report basis.
+              <a:t>Source: Qlik - Closed Repair Orders. Customer pay, by close date. Same-store, 33 stores (INEOS excluded, opened 2026). GMC Prescott body shop labor types excluded. CP gross = CP labor gross + CP parts gross. Change is Jul-Sep 2026 (Q3) vs Jan-Mar 2026 (Q1), each store against itself. Gross and ROs are per-month averages of each quarter. The group's own Q1-to-Q3 change is the seasonal baseline: it is the same for every store, so ranking by a store's change is the same as ranking by how far it beat the group. 'Stepped up in' = the month that best splits the store's year into a lower stretch before and a higher stretch after (at least three months before, two after). It is a conversation starter, not proof of cause. Each row is the top Q1-to-Q3 mover on that measure, the four opcodes included. Opcode closing % = ROs with the service ÷ customer-pay ROs on the op-code report basis.
 MAZDA's August opcode increase was confirmed with the store as a real change (Noah, Oct 19 2026).</a:t>
             </a:r>
             <a:endParaRPr lang="en-US" dirty="0"/>
@@ -22939,8 +22939,8 @@
         </p:nvSpPr>
         <p:spPr>
           <a:xfrm>
-            <a:off x="621792" y="1773936"/>
-            <a:ext cx="10945368" cy="548640"/>
+            <a:off x="621792" y="1755648"/>
+            <a:ext cx="10945368" cy="438912"/>
           </a:xfrm>
           <a:prstGeom prst="rect">
             <a:avLst/>
@@ -22959,24 +22959,24 @@
         </p:nvSpPr>
         <p:spPr>
           <a:xfrm>
-            <a:off x="749808" y="1773936"/>
-            <a:ext cx="2651760" cy="548640"/>
-          </a:xfrm>
-          <a:prstGeom prst="rect">
-            <a:avLst/>
-          </a:prstGeom>
-          <a:noFill/>
-          <a:ln/>
-        </p:spPr>
-        <p:txBody>
-          <a:bodyPr wrap="square" lIns="0" tIns="0" rIns="0" bIns="0" rtlCol="0" anchor="ctr"/>
-          <a:lstStyle/>
-          <a:p>
-            <a:pPr indent="0" marL="0">
-              <a:buNone/>
-            </a:pPr>
-            <a:r>
-              <a:rPr lang="en-US" sz="1500" b="1" dirty="0">
+            <a:off x="749808" y="1755648"/>
+            <a:ext cx="2651760" cy="438912"/>
+          </a:xfrm>
+          <a:prstGeom prst="rect">
+            <a:avLst/>
+          </a:prstGeom>
+          <a:noFill/>
+          <a:ln/>
+        </p:spPr>
+        <p:txBody>
+          <a:bodyPr wrap="square" lIns="0" tIns="0" rIns="0" bIns="0" rtlCol="0" anchor="ctr"/>
+          <a:lstStyle/>
+          <a:p>
+            <a:pPr indent="0" marL="0">
+              <a:buNone/>
+            </a:pPr>
+            <a:r>
+              <a:rPr lang="en-US" sz="1400" b="1" dirty="0">
                 <a:solidFill>
                   <a:srgbClr val="1A1A1A"/>
                 </a:solidFill>
@@ -22986,7 +22986,7 @@
               </a:rPr>
               <a:t>MAZDA</a:t>
             </a:r>
-            <a:endParaRPr lang="en-US" sz="1500" dirty="0"/>
+            <a:endParaRPr lang="en-US" sz="1400" dirty="0"/>
           </a:p>
         </p:txBody>
       </p:sp>
@@ -22998,24 +22998,24 @@
         </p:nvSpPr>
         <p:spPr>
           <a:xfrm>
-            <a:off x="3520440" y="1773936"/>
-            <a:ext cx="2103120" cy="548640"/>
-          </a:xfrm>
-          <a:prstGeom prst="rect">
-            <a:avLst/>
-          </a:prstGeom>
-          <a:noFill/>
-          <a:ln/>
-        </p:spPr>
-        <p:txBody>
-          <a:bodyPr wrap="square" lIns="0" tIns="0" rIns="0" bIns="0" rtlCol="0" anchor="ctr"/>
-          <a:lstStyle/>
-          <a:p>
-            <a:pPr indent="0" marL="0">
-              <a:buNone/>
-            </a:pPr>
-            <a:r>
-              <a:rPr lang="en-US" sz="1500" dirty="0">
+            <a:off x="3520440" y="1755648"/>
+            <a:ext cx="2103120" cy="438912"/>
+          </a:xfrm>
+          <a:prstGeom prst="rect">
+            <a:avLst/>
+          </a:prstGeom>
+          <a:noFill/>
+          <a:ln/>
+        </p:spPr>
+        <p:txBody>
+          <a:bodyPr wrap="square" lIns="0" tIns="0" rIns="0" bIns="0" rtlCol="0" anchor="ctr"/>
+          <a:lstStyle/>
+          <a:p>
+            <a:pPr indent="0" marL="0">
+              <a:buNone/>
+            </a:pPr>
+            <a:r>
+              <a:rPr lang="en-US" sz="1400" dirty="0">
                 <a:solidFill>
                   <a:srgbClr val="1A1A1A"/>
                 </a:solidFill>
@@ -23025,7 +23025,7 @@
               </a:rPr>
               <a:t>CP Gross per Month</a:t>
             </a:r>
-            <a:endParaRPr lang="en-US" sz="1500" dirty="0"/>
+            <a:endParaRPr lang="en-US" sz="1400" dirty="0"/>
           </a:p>
         </p:txBody>
       </p:sp>
@@ -23037,24 +23037,24 @@
         </p:nvSpPr>
         <p:spPr>
           <a:xfrm>
-            <a:off x="5669280" y="1773936"/>
-            <a:ext cx="2011680" cy="548640"/>
-          </a:xfrm>
-          <a:prstGeom prst="rect">
-            <a:avLst/>
-          </a:prstGeom>
-          <a:noFill/>
-          <a:ln/>
-        </p:spPr>
-        <p:txBody>
-          <a:bodyPr wrap="square" lIns="0" tIns="0" rIns="0" bIns="0" rtlCol="0" anchor="ctr"/>
-          <a:lstStyle/>
-          <a:p>
-            <a:pPr indent="0" marL="0">
-              <a:buNone/>
-            </a:pPr>
-            <a:r>
-              <a:rPr lang="en-US" sz="1500" dirty="0">
+            <a:off x="5669280" y="1755648"/>
+            <a:ext cx="2011680" cy="438912"/>
+          </a:xfrm>
+          <a:prstGeom prst="rect">
+            <a:avLst/>
+          </a:prstGeom>
+          <a:noFill/>
+          <a:ln/>
+        </p:spPr>
+        <p:txBody>
+          <a:bodyPr wrap="square" lIns="0" tIns="0" rIns="0" bIns="0" rtlCol="0" anchor="ctr"/>
+          <a:lstStyle/>
+          <a:p>
+            <a:pPr indent="0" marL="0">
+              <a:buNone/>
+            </a:pPr>
+            <a:r>
+              <a:rPr lang="en-US" sz="1400" dirty="0">
                 <a:solidFill>
                   <a:srgbClr val="1A1A1A"/>
                 </a:solidFill>
@@ -23064,7 +23064,7 @@
               </a:rPr>
               <a:t>$155K → $209K</a:t>
             </a:r>
-            <a:endParaRPr lang="en-US" sz="1500" dirty="0"/>
+            <a:endParaRPr lang="en-US" sz="1400" dirty="0"/>
           </a:p>
         </p:txBody>
       </p:sp>
@@ -23076,24 +23076,24 @@
         </p:nvSpPr>
         <p:spPr>
           <a:xfrm>
-            <a:off x="7726680" y="1773936"/>
-            <a:ext cx="1554480" cy="548640"/>
-          </a:xfrm>
-          <a:prstGeom prst="rect">
-            <a:avLst/>
-          </a:prstGeom>
-          <a:noFill/>
-          <a:ln/>
-        </p:spPr>
-        <p:txBody>
-          <a:bodyPr wrap="square" lIns="0" tIns="0" rIns="0" bIns="0" rtlCol="0" anchor="ctr"/>
-          <a:lstStyle/>
-          <a:p>
-            <a:pPr indent="0" marL="0">
-              <a:buNone/>
-            </a:pPr>
-            <a:r>
-              <a:rPr lang="en-US" sz="1500" b="1" dirty="0">
+            <a:off x="7726680" y="1755648"/>
+            <a:ext cx="1554480" cy="438912"/>
+          </a:xfrm>
+          <a:prstGeom prst="rect">
+            <a:avLst/>
+          </a:prstGeom>
+          <a:noFill/>
+          <a:ln/>
+        </p:spPr>
+        <p:txBody>
+          <a:bodyPr wrap="square" lIns="0" tIns="0" rIns="0" bIns="0" rtlCol="0" anchor="ctr"/>
+          <a:lstStyle/>
+          <a:p>
+            <a:pPr indent="0" marL="0">
+              <a:buNone/>
+            </a:pPr>
+            <a:r>
+              <a:rPr lang="en-US" sz="1400" b="1" dirty="0">
                 <a:solidFill>
                   <a:srgbClr val="0B2C4A"/>
                 </a:solidFill>
@@ -23103,7 +23103,7 @@
               </a:rPr>
               <a:t>August</a:t>
             </a:r>
-            <a:endParaRPr lang="en-US" sz="1500" dirty="0"/>
+            <a:endParaRPr lang="en-US" sz="1400" dirty="0"/>
           </a:p>
         </p:txBody>
       </p:sp>
@@ -23115,24 +23115,24 @@
         </p:nvSpPr>
         <p:spPr>
           <a:xfrm>
-            <a:off x="9326880" y="1773936"/>
-            <a:ext cx="1280160" cy="548640"/>
-          </a:xfrm>
-          <a:prstGeom prst="rect">
-            <a:avLst/>
-          </a:prstGeom>
-          <a:noFill/>
-          <a:ln/>
-        </p:spPr>
-        <p:txBody>
-          <a:bodyPr wrap="square" lIns="0" tIns="0" rIns="0" bIns="0" rtlCol="0" anchor="ctr"/>
-          <a:lstStyle/>
-          <a:p>
-            <a:pPr indent="0" marL="0">
-              <a:buNone/>
-            </a:pPr>
-            <a:r>
-              <a:rPr lang="en-US" sz="1500" b="1" dirty="0">
+            <a:off x="9326880" y="1755648"/>
+            <a:ext cx="1280160" cy="438912"/>
+          </a:xfrm>
+          <a:prstGeom prst="rect">
+            <a:avLst/>
+          </a:prstGeom>
+          <a:noFill/>
+          <a:ln/>
+        </p:spPr>
+        <p:txBody>
+          <a:bodyPr wrap="square" lIns="0" tIns="0" rIns="0" bIns="0" rtlCol="0" anchor="ctr"/>
+          <a:lstStyle/>
+          <a:p>
+            <a:pPr indent="0" marL="0">
+              <a:buNone/>
+            </a:pPr>
+            <a:r>
+              <a:rPr lang="en-US" sz="1400" b="1" dirty="0">
                 <a:solidFill>
                   <a:srgbClr val="0B7A4A"/>
                 </a:solidFill>
@@ -23142,7 +23142,7 @@
               </a:rPr>
               <a:t>+34.6%</a:t>
             </a:r>
-            <a:endParaRPr lang="en-US" sz="1500" dirty="0"/>
+            <a:endParaRPr lang="en-US" sz="1400" dirty="0"/>
           </a:p>
         </p:txBody>
       </p:sp>
@@ -23154,24 +23154,24 @@
         </p:nvSpPr>
         <p:spPr>
           <a:xfrm>
-            <a:off x="749808" y="2322576"/>
-            <a:ext cx="2651760" cy="548640"/>
-          </a:xfrm>
-          <a:prstGeom prst="rect">
-            <a:avLst/>
-          </a:prstGeom>
-          <a:noFill/>
-          <a:ln/>
-        </p:spPr>
-        <p:txBody>
-          <a:bodyPr wrap="square" lIns="0" tIns="0" rIns="0" bIns="0" rtlCol="0" anchor="ctr"/>
-          <a:lstStyle/>
-          <a:p>
-            <a:pPr indent="0" marL="0">
-              <a:buNone/>
-            </a:pPr>
-            <a:r>
-              <a:rPr lang="en-US" sz="1500" b="1" dirty="0">
+            <a:off x="749808" y="2194560"/>
+            <a:ext cx="2651760" cy="438912"/>
+          </a:xfrm>
+          <a:prstGeom prst="rect">
+            <a:avLst/>
+          </a:prstGeom>
+          <a:noFill/>
+          <a:ln/>
+        </p:spPr>
+        <p:txBody>
+          <a:bodyPr wrap="square" lIns="0" tIns="0" rIns="0" bIns="0" rtlCol="0" anchor="ctr"/>
+          <a:lstStyle/>
+          <a:p>
+            <a:pPr indent="0" marL="0">
+              <a:buNone/>
+            </a:pPr>
+            <a:r>
+              <a:rPr lang="en-US" sz="1400" b="1" dirty="0">
                 <a:solidFill>
                   <a:srgbClr val="1A1A1A"/>
                 </a:solidFill>
@@ -23181,7 +23181,7 @@
               </a:rPr>
               <a:t>LEXUS</a:t>
             </a:r>
-            <a:endParaRPr lang="en-US" sz="1500" dirty="0"/>
+            <a:endParaRPr lang="en-US" sz="1400" dirty="0"/>
           </a:p>
         </p:txBody>
       </p:sp>
@@ -23193,24 +23193,24 @@
         </p:nvSpPr>
         <p:spPr>
           <a:xfrm>
-            <a:off x="3520440" y="2322576"/>
-            <a:ext cx="2103120" cy="548640"/>
-          </a:xfrm>
-          <a:prstGeom prst="rect">
-            <a:avLst/>
-          </a:prstGeom>
-          <a:noFill/>
-          <a:ln/>
-        </p:spPr>
-        <p:txBody>
-          <a:bodyPr wrap="square" lIns="0" tIns="0" rIns="0" bIns="0" rtlCol="0" anchor="ctr"/>
-          <a:lstStyle/>
-          <a:p>
-            <a:pPr indent="0" marL="0">
-              <a:buNone/>
-            </a:pPr>
-            <a:r>
-              <a:rPr lang="en-US" sz="1500" dirty="0">
+            <a:off x="3520440" y="2194560"/>
+            <a:ext cx="2103120" cy="438912"/>
+          </a:xfrm>
+          <a:prstGeom prst="rect">
+            <a:avLst/>
+          </a:prstGeom>
+          <a:noFill/>
+          <a:ln/>
+        </p:spPr>
+        <p:txBody>
+          <a:bodyPr wrap="square" lIns="0" tIns="0" rIns="0" bIns="0" rtlCol="0" anchor="ctr"/>
+          <a:lstStyle/>
+          <a:p>
+            <a:pPr indent="0" marL="0">
+              <a:buNone/>
+            </a:pPr>
+            <a:r>
+              <a:rPr lang="en-US" sz="1400" dirty="0">
                 <a:solidFill>
                   <a:srgbClr val="1A1A1A"/>
                 </a:solidFill>
@@ -23220,7 +23220,7 @@
               </a:rPr>
               <a:t>CP ROs per Month</a:t>
             </a:r>
-            <a:endParaRPr lang="en-US" sz="1500" dirty="0"/>
+            <a:endParaRPr lang="en-US" sz="1400" dirty="0"/>
           </a:p>
         </p:txBody>
       </p:sp>
@@ -23232,24 +23232,24 @@
         </p:nvSpPr>
         <p:spPr>
           <a:xfrm>
-            <a:off x="5669280" y="2322576"/>
-            <a:ext cx="2011680" cy="548640"/>
-          </a:xfrm>
-          <a:prstGeom prst="rect">
-            <a:avLst/>
-          </a:prstGeom>
-          <a:noFill/>
-          <a:ln/>
-        </p:spPr>
-        <p:txBody>
-          <a:bodyPr wrap="square" lIns="0" tIns="0" rIns="0" bIns="0" rtlCol="0" anchor="ctr"/>
-          <a:lstStyle/>
-          <a:p>
-            <a:pPr indent="0" marL="0">
-              <a:buNone/>
-            </a:pPr>
-            <a:r>
-              <a:rPr lang="en-US" sz="1500" dirty="0">
+            <a:off x="5669280" y="2194560"/>
+            <a:ext cx="2011680" cy="438912"/>
+          </a:xfrm>
+          <a:prstGeom prst="rect">
+            <a:avLst/>
+          </a:prstGeom>
+          <a:noFill/>
+          <a:ln/>
+        </p:spPr>
+        <p:txBody>
+          <a:bodyPr wrap="square" lIns="0" tIns="0" rIns="0" bIns="0" rtlCol="0" anchor="ctr"/>
+          <a:lstStyle/>
+          <a:p>
+            <a:pPr indent="0" marL="0">
+              <a:buNone/>
+            </a:pPr>
+            <a:r>
+              <a:rPr lang="en-US" sz="1400" dirty="0">
                 <a:solidFill>
                   <a:srgbClr val="1A1A1A"/>
                 </a:solidFill>
@@ -23259,7 +23259,7 @@
               </a:rPr>
               <a:t>425 → 570</a:t>
             </a:r>
-            <a:endParaRPr lang="en-US" sz="1500" dirty="0"/>
+            <a:endParaRPr lang="en-US" sz="1400" dirty="0"/>
           </a:p>
         </p:txBody>
       </p:sp>
@@ -23271,24 +23271,24 @@
         </p:nvSpPr>
         <p:spPr>
           <a:xfrm>
-            <a:off x="7726680" y="2322576"/>
-            <a:ext cx="1554480" cy="548640"/>
-          </a:xfrm>
-          <a:prstGeom prst="rect">
-            <a:avLst/>
-          </a:prstGeom>
-          <a:noFill/>
-          <a:ln/>
-        </p:spPr>
-        <p:txBody>
-          <a:bodyPr wrap="square" lIns="0" tIns="0" rIns="0" bIns="0" rtlCol="0" anchor="ctr"/>
-          <a:lstStyle/>
-          <a:p>
-            <a:pPr indent="0" marL="0">
-              <a:buNone/>
-            </a:pPr>
-            <a:r>
-              <a:rPr lang="en-US" sz="1500" b="1" dirty="0">
+            <a:off x="7726680" y="2194560"/>
+            <a:ext cx="1554480" cy="438912"/>
+          </a:xfrm>
+          <a:prstGeom prst="rect">
+            <a:avLst/>
+          </a:prstGeom>
+          <a:noFill/>
+          <a:ln/>
+        </p:spPr>
+        <p:txBody>
+          <a:bodyPr wrap="square" lIns="0" tIns="0" rIns="0" bIns="0" rtlCol="0" anchor="ctr"/>
+          <a:lstStyle/>
+          <a:p>
+            <a:pPr indent="0" marL="0">
+              <a:buNone/>
+            </a:pPr>
+            <a:r>
+              <a:rPr lang="en-US" sz="1400" b="1" dirty="0">
                 <a:solidFill>
                   <a:srgbClr val="0B2C4A"/>
                 </a:solidFill>
@@ -23298,7 +23298,7 @@
               </a:rPr>
               <a:t>April</a:t>
             </a:r>
-            <a:endParaRPr lang="en-US" sz="1500" dirty="0"/>
+            <a:endParaRPr lang="en-US" sz="1400" dirty="0"/>
           </a:p>
         </p:txBody>
       </p:sp>
@@ -23310,24 +23310,24 @@
         </p:nvSpPr>
         <p:spPr>
           <a:xfrm>
-            <a:off x="9326880" y="2322576"/>
-            <a:ext cx="1280160" cy="548640"/>
-          </a:xfrm>
-          <a:prstGeom prst="rect">
-            <a:avLst/>
-          </a:prstGeom>
-          <a:noFill/>
-          <a:ln/>
-        </p:spPr>
-        <p:txBody>
-          <a:bodyPr wrap="square" lIns="0" tIns="0" rIns="0" bIns="0" rtlCol="0" anchor="ctr"/>
-          <a:lstStyle/>
-          <a:p>
-            <a:pPr indent="0" marL="0">
-              <a:buNone/>
-            </a:pPr>
-            <a:r>
-              <a:rPr lang="en-US" sz="1500" b="1" dirty="0">
+            <a:off x="9326880" y="2194560"/>
+            <a:ext cx="1280160" cy="438912"/>
+          </a:xfrm>
+          <a:prstGeom prst="rect">
+            <a:avLst/>
+          </a:prstGeom>
+          <a:noFill/>
+          <a:ln/>
+        </p:spPr>
+        <p:txBody>
+          <a:bodyPr wrap="square" lIns="0" tIns="0" rIns="0" bIns="0" rtlCol="0" anchor="ctr"/>
+          <a:lstStyle/>
+          <a:p>
+            <a:pPr indent="0" marL="0">
+              <a:buNone/>
+            </a:pPr>
+            <a:r>
+              <a:rPr lang="en-US" sz="1400" b="1" dirty="0">
                 <a:solidFill>
                   <a:srgbClr val="0B7A4A"/>
                 </a:solidFill>
@@ -23337,7 +23337,7 @@
               </a:rPr>
               <a:t>+34.0%</a:t>
             </a:r>
-            <a:endParaRPr lang="en-US" sz="1500" dirty="0"/>
+            <a:endParaRPr lang="en-US" sz="1400" dirty="0"/>
           </a:p>
         </p:txBody>
       </p:sp>
@@ -23349,8 +23349,8 @@
         </p:nvSpPr>
         <p:spPr>
           <a:xfrm>
-            <a:off x="621792" y="2871216"/>
-            <a:ext cx="10945368" cy="548640"/>
+            <a:off x="621792" y="2633472"/>
+            <a:ext cx="10945368" cy="438912"/>
           </a:xfrm>
           <a:prstGeom prst="rect">
             <a:avLst/>
@@ -23369,24 +23369,24 @@
         </p:nvSpPr>
         <p:spPr>
           <a:xfrm>
-            <a:off x="749808" y="2871216"/>
-            <a:ext cx="2651760" cy="548640"/>
-          </a:xfrm>
-          <a:prstGeom prst="rect">
-            <a:avLst/>
-          </a:prstGeom>
-          <a:noFill/>
-          <a:ln/>
-        </p:spPr>
-        <p:txBody>
-          <a:bodyPr wrap="square" lIns="0" tIns="0" rIns="0" bIns="0" rtlCol="0" anchor="ctr"/>
-          <a:lstStyle/>
-          <a:p>
-            <a:pPr indent="0" marL="0">
-              <a:buNone/>
-            </a:pPr>
-            <a:r>
-              <a:rPr lang="en-US" sz="1500" b="1" dirty="0">
+            <a:off x="749808" y="2633472"/>
+            <a:ext cx="2651760" cy="438912"/>
+          </a:xfrm>
+          <a:prstGeom prst="rect">
+            <a:avLst/>
+          </a:prstGeom>
+          <a:noFill/>
+          <a:ln/>
+        </p:spPr>
+        <p:txBody>
+          <a:bodyPr wrap="square" lIns="0" tIns="0" rIns="0" bIns="0" rtlCol="0" anchor="ctr"/>
+          <a:lstStyle/>
+          <a:p>
+            <a:pPr indent="0" marL="0">
+              <a:buNone/>
+            </a:pPr>
+            <a:r>
+              <a:rPr lang="en-US" sz="1400" b="1" dirty="0">
                 <a:solidFill>
                   <a:srgbClr val="1A1A1A"/>
                 </a:solidFill>
@@ -23396,7 +23396,7 @@
               </a:rPr>
               <a:t>MAZDA</a:t>
             </a:r>
-            <a:endParaRPr lang="en-US" sz="1500" dirty="0"/>
+            <a:endParaRPr lang="en-US" sz="1400" dirty="0"/>
           </a:p>
         </p:txBody>
       </p:sp>
@@ -23408,24 +23408,24 @@
         </p:nvSpPr>
         <p:spPr>
           <a:xfrm>
-            <a:off x="3520440" y="2871216"/>
-            <a:ext cx="2103120" cy="548640"/>
-          </a:xfrm>
-          <a:prstGeom prst="rect">
-            <a:avLst/>
-          </a:prstGeom>
-          <a:noFill/>
-          <a:ln/>
-        </p:spPr>
-        <p:txBody>
-          <a:bodyPr wrap="square" lIns="0" tIns="0" rIns="0" bIns="0" rtlCol="0" anchor="ctr"/>
-          <a:lstStyle/>
-          <a:p>
-            <a:pPr indent="0" marL="0">
-              <a:buNone/>
-            </a:pPr>
-            <a:r>
-              <a:rPr lang="en-US" sz="1500" dirty="0">
+            <a:off x="3520440" y="2633472"/>
+            <a:ext cx="2103120" cy="438912"/>
+          </a:xfrm>
+          <a:prstGeom prst="rect">
+            <a:avLst/>
+          </a:prstGeom>
+          <a:noFill/>
+          <a:ln/>
+        </p:spPr>
+        <p:txBody>
+          <a:bodyPr wrap="square" lIns="0" tIns="0" rIns="0" bIns="0" rtlCol="0" anchor="ctr"/>
+          <a:lstStyle/>
+          <a:p>
+            <a:pPr indent="0" marL="0">
+              <a:buNone/>
+            </a:pPr>
+            <a:r>
+              <a:rPr lang="en-US" sz="1400" dirty="0">
                 <a:solidFill>
                   <a:srgbClr val="1A1A1A"/>
                 </a:solidFill>
@@ -23435,7 +23435,7 @@
               </a:rPr>
               <a:t>CP Hours per RO</a:t>
             </a:r>
-            <a:endParaRPr lang="en-US" sz="1500" dirty="0"/>
+            <a:endParaRPr lang="en-US" sz="1400" dirty="0"/>
           </a:p>
         </p:txBody>
       </p:sp>
@@ -23447,24 +23447,24 @@
         </p:nvSpPr>
         <p:spPr>
           <a:xfrm>
-            <a:off x="5669280" y="2871216"/>
-            <a:ext cx="2011680" cy="548640"/>
-          </a:xfrm>
-          <a:prstGeom prst="rect">
-            <a:avLst/>
-          </a:prstGeom>
-          <a:noFill/>
-          <a:ln/>
-        </p:spPr>
-        <p:txBody>
-          <a:bodyPr wrap="square" lIns="0" tIns="0" rIns="0" bIns="0" rtlCol="0" anchor="ctr"/>
-          <a:lstStyle/>
-          <a:p>
-            <a:pPr indent="0" marL="0">
-              <a:buNone/>
-            </a:pPr>
-            <a:r>
-              <a:rPr lang="en-US" sz="1500" dirty="0">
+            <a:off x="5669280" y="2633472"/>
+            <a:ext cx="2011680" cy="438912"/>
+          </a:xfrm>
+          <a:prstGeom prst="rect">
+            <a:avLst/>
+          </a:prstGeom>
+          <a:noFill/>
+          <a:ln/>
+        </p:spPr>
+        <p:txBody>
+          <a:bodyPr wrap="square" lIns="0" tIns="0" rIns="0" bIns="0" rtlCol="0" anchor="ctr"/>
+          <a:lstStyle/>
+          <a:p>
+            <a:pPr indent="0" marL="0">
+              <a:buNone/>
+            </a:pPr>
+            <a:r>
+              <a:rPr lang="en-US" sz="1400" dirty="0">
                 <a:solidFill>
                   <a:srgbClr val="1A1A1A"/>
                 </a:solidFill>
@@ -23474,7 +23474,7 @@
               </a:rPr>
               <a:t>1.35 → 1.65</a:t>
             </a:r>
-            <a:endParaRPr lang="en-US" sz="1500" dirty="0"/>
+            <a:endParaRPr lang="en-US" sz="1400" dirty="0"/>
           </a:p>
         </p:txBody>
       </p:sp>
@@ -23486,24 +23486,24 @@
         </p:nvSpPr>
         <p:spPr>
           <a:xfrm>
-            <a:off x="7726680" y="2871216"/>
-            <a:ext cx="1554480" cy="548640"/>
-          </a:xfrm>
-          <a:prstGeom prst="rect">
-            <a:avLst/>
-          </a:prstGeom>
-          <a:noFill/>
-          <a:ln/>
-        </p:spPr>
-        <p:txBody>
-          <a:bodyPr wrap="square" lIns="0" tIns="0" rIns="0" bIns="0" rtlCol="0" anchor="ctr"/>
-          <a:lstStyle/>
-          <a:p>
-            <a:pPr indent="0" marL="0">
-              <a:buNone/>
-            </a:pPr>
-            <a:r>
-              <a:rPr lang="en-US" sz="1500" b="1" dirty="0">
+            <a:off x="7726680" y="2633472"/>
+            <a:ext cx="1554480" cy="438912"/>
+          </a:xfrm>
+          <a:prstGeom prst="rect">
+            <a:avLst/>
+          </a:prstGeom>
+          <a:noFill/>
+          <a:ln/>
+        </p:spPr>
+        <p:txBody>
+          <a:bodyPr wrap="square" lIns="0" tIns="0" rIns="0" bIns="0" rtlCol="0" anchor="ctr"/>
+          <a:lstStyle/>
+          <a:p>
+            <a:pPr indent="0" marL="0">
+              <a:buNone/>
+            </a:pPr>
+            <a:r>
+              <a:rPr lang="en-US" sz="1400" b="1" dirty="0">
                 <a:solidFill>
                   <a:srgbClr val="0B2C4A"/>
                 </a:solidFill>
@@ -23513,7 +23513,7 @@
               </a:rPr>
               <a:t>August</a:t>
             </a:r>
-            <a:endParaRPr lang="en-US" sz="1500" dirty="0"/>
+            <a:endParaRPr lang="en-US" sz="1400" dirty="0"/>
           </a:p>
         </p:txBody>
       </p:sp>
@@ -23525,24 +23525,24 @@
         </p:nvSpPr>
         <p:spPr>
           <a:xfrm>
-            <a:off x="9326880" y="2871216"/>
-            <a:ext cx="1280160" cy="548640"/>
-          </a:xfrm>
-          <a:prstGeom prst="rect">
-            <a:avLst/>
-          </a:prstGeom>
-          <a:noFill/>
-          <a:ln/>
-        </p:spPr>
-        <p:txBody>
-          <a:bodyPr wrap="square" lIns="0" tIns="0" rIns="0" bIns="0" rtlCol="0" anchor="ctr"/>
-          <a:lstStyle/>
-          <a:p>
-            <a:pPr indent="0" marL="0">
-              <a:buNone/>
-            </a:pPr>
-            <a:r>
-              <a:rPr lang="en-US" sz="1500" b="1" dirty="0">
+            <a:off x="9326880" y="2633472"/>
+            <a:ext cx="1280160" cy="438912"/>
+          </a:xfrm>
+          <a:prstGeom prst="rect">
+            <a:avLst/>
+          </a:prstGeom>
+          <a:noFill/>
+          <a:ln/>
+        </p:spPr>
+        <p:txBody>
+          <a:bodyPr wrap="square" lIns="0" tIns="0" rIns="0" bIns="0" rtlCol="0" anchor="ctr"/>
+          <a:lstStyle/>
+          <a:p>
+            <a:pPr indent="0" marL="0">
+              <a:buNone/>
+            </a:pPr>
+            <a:r>
+              <a:rPr lang="en-US" sz="1400" b="1" dirty="0">
                 <a:solidFill>
                   <a:srgbClr val="0B7A4A"/>
                 </a:solidFill>
@@ -23552,7 +23552,7 @@
               </a:rPr>
               <a:t>+22.2%</a:t>
             </a:r>
-            <a:endParaRPr lang="en-US" sz="1500" dirty="0"/>
+            <a:endParaRPr lang="en-US" sz="1400" dirty="0"/>
           </a:p>
         </p:txBody>
       </p:sp>
@@ -23564,24 +23564,24 @@
         </p:nvSpPr>
         <p:spPr>
           <a:xfrm>
-            <a:off x="749808" y="3419856"/>
-            <a:ext cx="2651760" cy="548640"/>
-          </a:xfrm>
-          <a:prstGeom prst="rect">
-            <a:avLst/>
-          </a:prstGeom>
-          <a:noFill/>
-          <a:ln/>
-        </p:spPr>
-        <p:txBody>
-          <a:bodyPr wrap="square" lIns="0" tIns="0" rIns="0" bIns="0" rtlCol="0" anchor="ctr"/>
-          <a:lstStyle/>
-          <a:p>
-            <a:pPr indent="0" marL="0">
-              <a:buNone/>
-            </a:pPr>
-            <a:r>
-              <a:rPr lang="en-US" sz="1500" b="1" dirty="0">
+            <a:off x="749808" y="3072384"/>
+            <a:ext cx="2651760" cy="438912"/>
+          </a:xfrm>
+          <a:prstGeom prst="rect">
+            <a:avLst/>
+          </a:prstGeom>
+          <a:noFill/>
+          <a:ln/>
+        </p:spPr>
+        <p:txBody>
+          <a:bodyPr wrap="square" lIns="0" tIns="0" rIns="0" bIns="0" rtlCol="0" anchor="ctr"/>
+          <a:lstStyle/>
+          <a:p>
+            <a:pPr indent="0" marL="0">
+              <a:buNone/>
+            </a:pPr>
+            <a:r>
+              <a:rPr lang="en-US" sz="1400" b="1" dirty="0">
                 <a:solidFill>
                   <a:srgbClr val="1A1A1A"/>
                 </a:solidFill>
@@ -23591,7 +23591,7 @@
               </a:rPr>
               <a:t>VW ST GEORGE</a:t>
             </a:r>
-            <a:endParaRPr lang="en-US" sz="1500" dirty="0"/>
+            <a:endParaRPr lang="en-US" sz="1400" dirty="0"/>
           </a:p>
         </p:txBody>
       </p:sp>
@@ -23603,24 +23603,24 @@
         </p:nvSpPr>
         <p:spPr>
           <a:xfrm>
-            <a:off x="3520440" y="3419856"/>
-            <a:ext cx="2103120" cy="548640"/>
-          </a:xfrm>
-          <a:prstGeom prst="rect">
-            <a:avLst/>
-          </a:prstGeom>
-          <a:noFill/>
-          <a:ln/>
-        </p:spPr>
-        <p:txBody>
-          <a:bodyPr wrap="square" lIns="0" tIns="0" rIns="0" bIns="0" rtlCol="0" anchor="ctr"/>
-          <a:lstStyle/>
-          <a:p>
-            <a:pPr indent="0" marL="0">
-              <a:buNone/>
-            </a:pPr>
-            <a:r>
-              <a:rPr lang="en-US" sz="1500" dirty="0">
+            <a:off x="3520440" y="3072384"/>
+            <a:ext cx="2103120" cy="438912"/>
+          </a:xfrm>
+          <a:prstGeom prst="rect">
+            <a:avLst/>
+          </a:prstGeom>
+          <a:noFill/>
+          <a:ln/>
+        </p:spPr>
+        <p:txBody>
+          <a:bodyPr wrap="square" lIns="0" tIns="0" rIns="0" bIns="0" rtlCol="0" anchor="ctr"/>
+          <a:lstStyle/>
+          <a:p>
+            <a:pPr indent="0" marL="0">
+              <a:buNone/>
+            </a:pPr>
+            <a:r>
+              <a:rPr lang="en-US" sz="1400" dirty="0">
                 <a:solidFill>
                   <a:srgbClr val="1A1A1A"/>
                 </a:solidFill>
@@ -23630,7 +23630,7 @@
               </a:rPr>
               <a:t>CP ELR</a:t>
             </a:r>
-            <a:endParaRPr lang="en-US" sz="1500" dirty="0"/>
+            <a:endParaRPr lang="en-US" sz="1400" dirty="0"/>
           </a:p>
         </p:txBody>
       </p:sp>
@@ -23642,24 +23642,24 @@
         </p:nvSpPr>
         <p:spPr>
           <a:xfrm>
-            <a:off x="5669280" y="3419856"/>
-            <a:ext cx="2011680" cy="548640"/>
-          </a:xfrm>
-          <a:prstGeom prst="rect">
-            <a:avLst/>
-          </a:prstGeom>
-          <a:noFill/>
-          <a:ln/>
-        </p:spPr>
-        <p:txBody>
-          <a:bodyPr wrap="square" lIns="0" tIns="0" rIns="0" bIns="0" rtlCol="0" anchor="ctr"/>
-          <a:lstStyle/>
-          <a:p>
-            <a:pPr indent="0" marL="0">
-              <a:buNone/>
-            </a:pPr>
-            <a:r>
-              <a:rPr lang="en-US" sz="1500" dirty="0">
+            <a:off x="5669280" y="3072384"/>
+            <a:ext cx="2011680" cy="438912"/>
+          </a:xfrm>
+          <a:prstGeom prst="rect">
+            <a:avLst/>
+          </a:prstGeom>
+          <a:noFill/>
+          <a:ln/>
+        </p:spPr>
+        <p:txBody>
+          <a:bodyPr wrap="square" lIns="0" tIns="0" rIns="0" bIns="0" rtlCol="0" anchor="ctr"/>
+          <a:lstStyle/>
+          <a:p>
+            <a:pPr indent="0" marL="0">
+              <a:buNone/>
+            </a:pPr>
+            <a:r>
+              <a:rPr lang="en-US" sz="1400" dirty="0">
                 <a:solidFill>
                   <a:srgbClr val="1A1A1A"/>
                 </a:solidFill>
@@ -23669,7 +23669,7 @@
               </a:rPr>
               <a:t>$128.27 → $141.89</a:t>
             </a:r>
-            <a:endParaRPr lang="en-US" sz="1500" dirty="0"/>
+            <a:endParaRPr lang="en-US" sz="1400" dirty="0"/>
           </a:p>
         </p:txBody>
       </p:sp>
@@ -23681,24 +23681,24 @@
         </p:nvSpPr>
         <p:spPr>
           <a:xfrm>
-            <a:off x="7726680" y="3419856"/>
-            <a:ext cx="1554480" cy="548640"/>
-          </a:xfrm>
-          <a:prstGeom prst="rect">
-            <a:avLst/>
-          </a:prstGeom>
-          <a:noFill/>
-          <a:ln/>
-        </p:spPr>
-        <p:txBody>
-          <a:bodyPr wrap="square" lIns="0" tIns="0" rIns="0" bIns="0" rtlCol="0" anchor="ctr"/>
-          <a:lstStyle/>
-          <a:p>
-            <a:pPr indent="0" marL="0">
-              <a:buNone/>
-            </a:pPr>
-            <a:r>
-              <a:rPr lang="en-US" sz="1500" b="1" dirty="0">
+            <a:off x="7726680" y="3072384"/>
+            <a:ext cx="1554480" cy="438912"/>
+          </a:xfrm>
+          <a:prstGeom prst="rect">
+            <a:avLst/>
+          </a:prstGeom>
+          <a:noFill/>
+          <a:ln/>
+        </p:spPr>
+        <p:txBody>
+          <a:bodyPr wrap="square" lIns="0" tIns="0" rIns="0" bIns="0" rtlCol="0" anchor="ctr"/>
+          <a:lstStyle/>
+          <a:p>
+            <a:pPr indent="0" marL="0">
+              <a:buNone/>
+            </a:pPr>
+            <a:r>
+              <a:rPr lang="en-US" sz="1400" b="1" dirty="0">
                 <a:solidFill>
                   <a:srgbClr val="0B2C4A"/>
                 </a:solidFill>
@@ -23708,7 +23708,7 @@
               </a:rPr>
               <a:t>June</a:t>
             </a:r>
-            <a:endParaRPr lang="en-US" sz="1500" dirty="0"/>
+            <a:endParaRPr lang="en-US" sz="1400" dirty="0"/>
           </a:p>
         </p:txBody>
       </p:sp>
@@ -23720,24 +23720,24 @@
         </p:nvSpPr>
         <p:spPr>
           <a:xfrm>
-            <a:off x="9326880" y="3419856"/>
-            <a:ext cx="1280160" cy="548640"/>
-          </a:xfrm>
-          <a:prstGeom prst="rect">
-            <a:avLst/>
-          </a:prstGeom>
-          <a:noFill/>
-          <a:ln/>
-        </p:spPr>
-        <p:txBody>
-          <a:bodyPr wrap="square" lIns="0" tIns="0" rIns="0" bIns="0" rtlCol="0" anchor="ctr"/>
-          <a:lstStyle/>
-          <a:p>
-            <a:pPr indent="0" marL="0">
-              <a:buNone/>
-            </a:pPr>
-            <a:r>
-              <a:rPr lang="en-US" sz="1500" b="1" dirty="0">
+            <a:off x="9326880" y="3072384"/>
+            <a:ext cx="1280160" cy="438912"/>
+          </a:xfrm>
+          <a:prstGeom prst="rect">
+            <a:avLst/>
+          </a:prstGeom>
+          <a:noFill/>
+          <a:ln/>
+        </p:spPr>
+        <p:txBody>
+          <a:bodyPr wrap="square" lIns="0" tIns="0" rIns="0" bIns="0" rtlCol="0" anchor="ctr"/>
+          <a:lstStyle/>
+          <a:p>
+            <a:pPr indent="0" marL="0">
+              <a:buNone/>
+            </a:pPr>
+            <a:r>
+              <a:rPr lang="en-US" sz="1400" b="1" dirty="0">
                 <a:solidFill>
                   <a:srgbClr val="0B7A4A"/>
                 </a:solidFill>
@@ -23747,7 +23747,7 @@
               </a:rPr>
               <a:t>+10.6%</a:t>
             </a:r>
-            <a:endParaRPr lang="en-US" sz="1500" dirty="0"/>
+            <a:endParaRPr lang="en-US" sz="1400" dirty="0"/>
           </a:p>
         </p:txBody>
       </p:sp>
@@ -23759,8 +23759,8 @@
         </p:nvSpPr>
         <p:spPr>
           <a:xfrm>
-            <a:off x="621792" y="3968496"/>
-            <a:ext cx="10945368" cy="548640"/>
+            <a:off x="621792" y="3511296"/>
+            <a:ext cx="10945368" cy="438912"/>
           </a:xfrm>
           <a:prstGeom prst="rect">
             <a:avLst/>
@@ -23779,24 +23779,24 @@
         </p:nvSpPr>
         <p:spPr>
           <a:xfrm>
-            <a:off x="749808" y="3968496"/>
-            <a:ext cx="2651760" cy="548640"/>
-          </a:xfrm>
-          <a:prstGeom prst="rect">
-            <a:avLst/>
-          </a:prstGeom>
-          <a:noFill/>
-          <a:ln/>
-        </p:spPr>
-        <p:txBody>
-          <a:bodyPr wrap="square" lIns="0" tIns="0" rIns="0" bIns="0" rtlCol="0" anchor="ctr"/>
-          <a:lstStyle/>
-          <a:p>
-            <a:pPr indent="0" marL="0">
-              <a:buNone/>
-            </a:pPr>
-            <a:r>
-              <a:rPr lang="en-US" sz="1500" b="1" dirty="0">
+            <a:off x="749808" y="3511296"/>
+            <a:ext cx="2651760" cy="438912"/>
+          </a:xfrm>
+          <a:prstGeom prst="rect">
+            <a:avLst/>
+          </a:prstGeom>
+          <a:noFill/>
+          <a:ln/>
+        </p:spPr>
+        <p:txBody>
+          <a:bodyPr wrap="square" lIns="0" tIns="0" rIns="0" bIns="0" rtlCol="0" anchor="ctr"/>
+          <a:lstStyle/>
+          <a:p>
+            <a:pPr indent="0" marL="0">
+              <a:buNone/>
+            </a:pPr>
+            <a:r>
+              <a:rPr lang="en-US" sz="1400" b="1" dirty="0">
                 <a:solidFill>
                   <a:srgbClr val="1A1A1A"/>
                 </a:solidFill>
@@ -23806,7 +23806,7 @@
               </a:rPr>
               <a:t>ACURA</a:t>
             </a:r>
-            <a:endParaRPr lang="en-US" sz="1500" dirty="0"/>
+            <a:endParaRPr lang="en-US" sz="1400" dirty="0"/>
           </a:p>
         </p:txBody>
       </p:sp>
@@ -23818,24 +23818,24 @@
         </p:nvSpPr>
         <p:spPr>
           <a:xfrm>
-            <a:off x="3520440" y="3968496"/>
-            <a:ext cx="2103120" cy="548640"/>
-          </a:xfrm>
-          <a:prstGeom prst="rect">
-            <a:avLst/>
-          </a:prstGeom>
-          <a:noFill/>
-          <a:ln/>
-        </p:spPr>
-        <p:txBody>
-          <a:bodyPr wrap="square" lIns="0" tIns="0" rIns="0" bIns="0" rtlCol="0" anchor="ctr"/>
-          <a:lstStyle/>
-          <a:p>
-            <a:pPr indent="0" marL="0">
-              <a:buNone/>
-            </a:pPr>
-            <a:r>
-              <a:rPr lang="en-US" sz="1500" dirty="0">
+            <a:off x="3520440" y="3511296"/>
+            <a:ext cx="2103120" cy="438912"/>
+          </a:xfrm>
+          <a:prstGeom prst="rect">
+            <a:avLst/>
+          </a:prstGeom>
+          <a:noFill/>
+          <a:ln/>
+        </p:spPr>
+        <p:txBody>
+          <a:bodyPr wrap="square" lIns="0" tIns="0" rIns="0" bIns="0" rtlCol="0" anchor="ctr"/>
+          <a:lstStyle/>
+          <a:p>
+            <a:pPr indent="0" marL="0">
+              <a:buNone/>
+            </a:pPr>
+            <a:r>
+              <a:rPr lang="en-US" sz="1400" dirty="0">
                 <a:solidFill>
                   <a:srgbClr val="1A1A1A"/>
                 </a:solidFill>
@@ -23845,7 +23845,7 @@
               </a:rPr>
               <a:t>CP Parts GP %</a:t>
             </a:r>
-            <a:endParaRPr lang="en-US" sz="1500" dirty="0"/>
+            <a:endParaRPr lang="en-US" sz="1400" dirty="0"/>
           </a:p>
         </p:txBody>
       </p:sp>
@@ -23857,24 +23857,24 @@
         </p:nvSpPr>
         <p:spPr>
           <a:xfrm>
-            <a:off x="5669280" y="3968496"/>
-            <a:ext cx="2011680" cy="548640"/>
-          </a:xfrm>
-          <a:prstGeom prst="rect">
-            <a:avLst/>
-          </a:prstGeom>
-          <a:noFill/>
-          <a:ln/>
-        </p:spPr>
-        <p:txBody>
-          <a:bodyPr wrap="square" lIns="0" tIns="0" rIns="0" bIns="0" rtlCol="0" anchor="ctr"/>
-          <a:lstStyle/>
-          <a:p>
-            <a:pPr indent="0" marL="0">
-              <a:buNone/>
-            </a:pPr>
-            <a:r>
-              <a:rPr lang="en-US" sz="1500" dirty="0">
+            <a:off x="5669280" y="3511296"/>
+            <a:ext cx="2011680" cy="438912"/>
+          </a:xfrm>
+          <a:prstGeom prst="rect">
+            <a:avLst/>
+          </a:prstGeom>
+          <a:noFill/>
+          <a:ln/>
+        </p:spPr>
+        <p:txBody>
+          <a:bodyPr wrap="square" lIns="0" tIns="0" rIns="0" bIns="0" rtlCol="0" anchor="ctr"/>
+          <a:lstStyle/>
+          <a:p>
+            <a:pPr indent="0" marL="0">
+              <a:buNone/>
+            </a:pPr>
+            <a:r>
+              <a:rPr lang="en-US" sz="1400" dirty="0">
                 <a:solidFill>
                   <a:srgbClr val="1A1A1A"/>
                 </a:solidFill>
@@ -23884,7 +23884,7 @@
               </a:rPr>
               <a:t>39.4% → 46.6%</a:t>
             </a:r>
-            <a:endParaRPr lang="en-US" sz="1500" dirty="0"/>
+            <a:endParaRPr lang="en-US" sz="1400" dirty="0"/>
           </a:p>
         </p:txBody>
       </p:sp>
@@ -23896,24 +23896,24 @@
         </p:nvSpPr>
         <p:spPr>
           <a:xfrm>
-            <a:off x="7726680" y="3968496"/>
-            <a:ext cx="1554480" cy="548640"/>
-          </a:xfrm>
-          <a:prstGeom prst="rect">
-            <a:avLst/>
-          </a:prstGeom>
-          <a:noFill/>
-          <a:ln/>
-        </p:spPr>
-        <p:txBody>
-          <a:bodyPr wrap="square" lIns="0" tIns="0" rIns="0" bIns="0" rtlCol="0" anchor="ctr"/>
-          <a:lstStyle/>
-          <a:p>
-            <a:pPr indent="0" marL="0">
-              <a:buNone/>
-            </a:pPr>
-            <a:r>
-              <a:rPr lang="en-US" sz="1500" b="1" dirty="0">
+            <a:off x="7726680" y="3511296"/>
+            <a:ext cx="1554480" cy="438912"/>
+          </a:xfrm>
+          <a:prstGeom prst="rect">
+            <a:avLst/>
+          </a:prstGeom>
+          <a:noFill/>
+          <a:ln/>
+        </p:spPr>
+        <p:txBody>
+          <a:bodyPr wrap="square" lIns="0" tIns="0" rIns="0" bIns="0" rtlCol="0" anchor="ctr"/>
+          <a:lstStyle/>
+          <a:p>
+            <a:pPr indent="0" marL="0">
+              <a:buNone/>
+            </a:pPr>
+            <a:r>
+              <a:rPr lang="en-US" sz="1400" b="1" dirty="0">
                 <a:solidFill>
                   <a:srgbClr val="0B2C4A"/>
                 </a:solidFill>
@@ -23923,7 +23923,7 @@
               </a:rPr>
               <a:t>April</a:t>
             </a:r>
-            <a:endParaRPr lang="en-US" sz="1500" dirty="0"/>
+            <a:endParaRPr lang="en-US" sz="1400" dirty="0"/>
           </a:p>
         </p:txBody>
       </p:sp>
@@ -23935,24 +23935,24 @@
         </p:nvSpPr>
         <p:spPr>
           <a:xfrm>
-            <a:off x="9326880" y="3968496"/>
-            <a:ext cx="1280160" cy="548640"/>
-          </a:xfrm>
-          <a:prstGeom prst="rect">
-            <a:avLst/>
-          </a:prstGeom>
-          <a:noFill/>
-          <a:ln/>
-        </p:spPr>
-        <p:txBody>
-          <a:bodyPr wrap="square" lIns="0" tIns="0" rIns="0" bIns="0" rtlCol="0" anchor="ctr"/>
-          <a:lstStyle/>
-          <a:p>
-            <a:pPr indent="0" marL="0">
-              <a:buNone/>
-            </a:pPr>
-            <a:r>
-              <a:rPr lang="en-US" sz="1500" b="1" dirty="0">
+            <a:off x="9326880" y="3511296"/>
+            <a:ext cx="1280160" cy="438912"/>
+          </a:xfrm>
+          <a:prstGeom prst="rect">
+            <a:avLst/>
+          </a:prstGeom>
+          <a:noFill/>
+          <a:ln/>
+        </p:spPr>
+        <p:txBody>
+          <a:bodyPr wrap="square" lIns="0" tIns="0" rIns="0" bIns="0" rtlCol="0" anchor="ctr"/>
+          <a:lstStyle/>
+          <a:p>
+            <a:pPr indent="0" marL="0">
+              <a:buNone/>
+            </a:pPr>
+            <a:r>
+              <a:rPr lang="en-US" sz="1400" b="1" dirty="0">
                 <a:solidFill>
                   <a:srgbClr val="0B7A4A"/>
                 </a:solidFill>
@@ -23962,7 +23962,7 @@
               </a:rPr>
               <a:t>+7.2 pts</a:t>
             </a:r>
-            <a:endParaRPr lang="en-US" sz="1500" dirty="0"/>
+            <a:endParaRPr lang="en-US" sz="1400" dirty="0"/>
           </a:p>
         </p:txBody>
       </p:sp>
@@ -23974,24 +23974,24 @@
         </p:nvSpPr>
         <p:spPr>
           <a:xfrm>
-            <a:off x="749808" y="4517136"/>
-            <a:ext cx="2651760" cy="548640"/>
-          </a:xfrm>
-          <a:prstGeom prst="rect">
-            <a:avLst/>
-          </a:prstGeom>
-          <a:noFill/>
-          <a:ln/>
-        </p:spPr>
-        <p:txBody>
-          <a:bodyPr wrap="square" lIns="0" tIns="0" rIns="0" bIns="0" rtlCol="0" anchor="ctr"/>
-          <a:lstStyle/>
-          <a:p>
-            <a:pPr indent="0" marL="0">
-              <a:buNone/>
-            </a:pPr>
-            <a:r>
-              <a:rPr lang="en-US" sz="1500" b="1" dirty="0">
+            <a:off x="749808" y="3950208"/>
+            <a:ext cx="2651760" cy="438912"/>
+          </a:xfrm>
+          <a:prstGeom prst="rect">
+            <a:avLst/>
+          </a:prstGeom>
+          <a:noFill/>
+          <a:ln/>
+        </p:spPr>
+        <p:txBody>
+          <a:bodyPr wrap="square" lIns="0" tIns="0" rIns="0" bIns="0" rtlCol="0" anchor="ctr"/>
+          <a:lstStyle/>
+          <a:p>
+            <a:pPr indent="0" marL="0">
+              <a:buNone/>
+            </a:pPr>
+            <a:r>
+              <a:rPr lang="en-US" sz="1400" b="1" dirty="0">
                 <a:solidFill>
                   <a:srgbClr val="1A1A1A"/>
                 </a:solidFill>
@@ -23999,38 +23999,253 @@
                 <a:ea typeface="Inter" pitchFamily="34" charset="-122"/>
                 <a:cs typeface="Inter" pitchFamily="34" charset="-120"/>
               </a:rPr>
+              <a:t>AUDI HENDERSON</a:t>
+            </a:r>
+            <a:endParaRPr lang="en-US" sz="1400" dirty="0"/>
+          </a:p>
+        </p:txBody>
+      </p:sp>
+      <p:sp>
+        <p:nvSpPr>
+          <p:cNvPr id="40" name="Text 38"/>
+          <p:cNvSpPr txBox="1"/>
+          <p:nvPr/>
+        </p:nvSpPr>
+        <p:spPr>
+          <a:xfrm>
+            <a:off x="3520440" y="3950208"/>
+            <a:ext cx="2103120" cy="438912"/>
+          </a:xfrm>
+          <a:prstGeom prst="rect">
+            <a:avLst/>
+          </a:prstGeom>
+          <a:noFill/>
+          <a:ln/>
+        </p:spPr>
+        <p:txBody>
+          <a:bodyPr wrap="square" lIns="0" tIns="0" rIns="0" bIns="0" rtlCol="0" anchor="ctr"/>
+          <a:lstStyle/>
+          <a:p>
+            <a:pPr indent="0" marL="0">
+              <a:buNone/>
+            </a:pPr>
+            <a:r>
+              <a:rPr lang="en-US" sz="1400" dirty="0">
+                <a:solidFill>
+                  <a:srgbClr val="1A1A1A"/>
+                </a:solidFill>
+                <a:latin typeface="Inter" pitchFamily="34" charset="0"/>
+                <a:ea typeface="Inter" pitchFamily="34" charset="-122"/>
+                <a:cs typeface="Inter" pitchFamily="34" charset="-120"/>
+              </a:rPr>
+              <a:t>Opcodes · alignment</a:t>
+            </a:r>
+            <a:endParaRPr lang="en-US" sz="1400" dirty="0"/>
+          </a:p>
+        </p:txBody>
+      </p:sp>
+      <p:sp>
+        <p:nvSpPr>
+          <p:cNvPr id="41" name="Text 39"/>
+          <p:cNvSpPr txBox="1"/>
+          <p:nvPr/>
+        </p:nvSpPr>
+        <p:spPr>
+          <a:xfrm>
+            <a:off x="5669280" y="3950208"/>
+            <a:ext cx="2011680" cy="438912"/>
+          </a:xfrm>
+          <a:prstGeom prst="rect">
+            <a:avLst/>
+          </a:prstGeom>
+          <a:noFill/>
+          <a:ln/>
+        </p:spPr>
+        <p:txBody>
+          <a:bodyPr wrap="square" lIns="0" tIns="0" rIns="0" bIns="0" rtlCol="0" anchor="ctr"/>
+          <a:lstStyle/>
+          <a:p>
+            <a:pPr indent="0" marL="0">
+              <a:buNone/>
+            </a:pPr>
+            <a:r>
+              <a:rPr lang="en-US" sz="1400" dirty="0">
+                <a:solidFill>
+                  <a:srgbClr val="1A1A1A"/>
+                </a:solidFill>
+                <a:latin typeface="Inter" pitchFamily="34" charset="0"/>
+                <a:ea typeface="Inter" pitchFamily="34" charset="-122"/>
+                <a:cs typeface="Inter" pitchFamily="34" charset="-120"/>
+              </a:rPr>
+              <a:t>21.0% → 31.7%</a:t>
+            </a:r>
+            <a:endParaRPr lang="en-US" sz="1400" dirty="0"/>
+          </a:p>
+        </p:txBody>
+      </p:sp>
+      <p:sp>
+        <p:nvSpPr>
+          <p:cNvPr id="42" name="Text 40"/>
+          <p:cNvSpPr txBox="1"/>
+          <p:nvPr/>
+        </p:nvSpPr>
+        <p:spPr>
+          <a:xfrm>
+            <a:off x="7726680" y="3950208"/>
+            <a:ext cx="1554480" cy="438912"/>
+          </a:xfrm>
+          <a:prstGeom prst="rect">
+            <a:avLst/>
+          </a:prstGeom>
+          <a:noFill/>
+          <a:ln/>
+        </p:spPr>
+        <p:txBody>
+          <a:bodyPr wrap="square" lIns="0" tIns="0" rIns="0" bIns="0" rtlCol="0" anchor="ctr"/>
+          <a:lstStyle/>
+          <a:p>
+            <a:pPr indent="0" marL="0">
+              <a:buNone/>
+            </a:pPr>
+            <a:r>
+              <a:rPr lang="en-US" sz="1400" b="1" dirty="0">
+                <a:solidFill>
+                  <a:srgbClr val="0B2C4A"/>
+                </a:solidFill>
+                <a:latin typeface="Inter" pitchFamily="34" charset="0"/>
+                <a:ea typeface="Inter" pitchFamily="34" charset="-122"/>
+                <a:cs typeface="Inter" pitchFamily="34" charset="-120"/>
+              </a:rPr>
+              <a:t>May</a:t>
+            </a:r>
+            <a:endParaRPr lang="en-US" sz="1400" dirty="0"/>
+          </a:p>
+        </p:txBody>
+      </p:sp>
+      <p:sp>
+        <p:nvSpPr>
+          <p:cNvPr id="43" name="Text 41"/>
+          <p:cNvSpPr txBox="1"/>
+          <p:nvPr/>
+        </p:nvSpPr>
+        <p:spPr>
+          <a:xfrm>
+            <a:off x="9326880" y="3950208"/>
+            <a:ext cx="1280160" cy="438912"/>
+          </a:xfrm>
+          <a:prstGeom prst="rect">
+            <a:avLst/>
+          </a:prstGeom>
+          <a:noFill/>
+          <a:ln/>
+        </p:spPr>
+        <p:txBody>
+          <a:bodyPr wrap="square" lIns="0" tIns="0" rIns="0" bIns="0" rtlCol="0" anchor="ctr"/>
+          <a:lstStyle/>
+          <a:p>
+            <a:pPr indent="0" marL="0">
+              <a:buNone/>
+            </a:pPr>
+            <a:r>
+              <a:rPr lang="en-US" sz="1400" b="1" dirty="0">
+                <a:solidFill>
+                  <a:srgbClr val="0B7A4A"/>
+                </a:solidFill>
+                <a:latin typeface="Inter" pitchFamily="34" charset="0"/>
+                <a:ea typeface="Inter" pitchFamily="34" charset="-122"/>
+                <a:cs typeface="Inter" pitchFamily="34" charset="-120"/>
+              </a:rPr>
+              <a:t>+10.7 pts</a:t>
+            </a:r>
+            <a:endParaRPr lang="en-US" sz="1400" dirty="0"/>
+          </a:p>
+        </p:txBody>
+      </p:sp>
+      <p:sp>
+        <p:nvSpPr>
+          <p:cNvPr id="44" name="Shape 42"/>
+          <p:cNvSpPr/>
+          <p:nvPr/>
+        </p:nvSpPr>
+        <p:spPr>
+          <a:xfrm>
+            <a:off x="621792" y="4389120"/>
+            <a:ext cx="10945368" cy="438912"/>
+          </a:xfrm>
+          <a:prstGeom prst="rect">
+            <a:avLst/>
+          </a:prstGeom>
+          <a:solidFill>
+            <a:srgbClr val="F7F7F7"/>
+          </a:solidFill>
+          <a:ln/>
+        </p:spPr>
+      </p:sp>
+      <p:sp>
+        <p:nvSpPr>
+          <p:cNvPr id="45" name="Text 43"/>
+          <p:cNvSpPr txBox="1"/>
+          <p:nvPr/>
+        </p:nvSpPr>
+        <p:spPr>
+          <a:xfrm>
+            <a:off x="749808" y="4389120"/>
+            <a:ext cx="2651760" cy="438912"/>
+          </a:xfrm>
+          <a:prstGeom prst="rect">
+            <a:avLst/>
+          </a:prstGeom>
+          <a:noFill/>
+          <a:ln/>
+        </p:spPr>
+        <p:txBody>
+          <a:bodyPr wrap="square" lIns="0" tIns="0" rIns="0" bIns="0" rtlCol="0" anchor="ctr"/>
+          <a:lstStyle/>
+          <a:p>
+            <a:pPr indent="0" marL="0">
+              <a:buNone/>
+            </a:pPr>
+            <a:r>
+              <a:rPr lang="en-US" sz="1400" b="1" dirty="0">
+                <a:solidFill>
+                  <a:srgbClr val="1A1A1A"/>
+                </a:solidFill>
+                <a:latin typeface="Inter" pitchFamily="34" charset="0"/>
+                <a:ea typeface="Inter" pitchFamily="34" charset="-122"/>
+                <a:cs typeface="Inter" pitchFamily="34" charset="-120"/>
+              </a:rPr>
               <a:t>MAZDA</a:t>
             </a:r>
-            <a:endParaRPr lang="en-US" sz="1500" dirty="0"/>
-          </a:p>
-        </p:txBody>
-      </p:sp>
-      <p:sp>
-        <p:nvSpPr>
-          <p:cNvPr id="40" name="Text 38"/>
-          <p:cNvSpPr txBox="1"/>
-          <p:nvPr/>
-        </p:nvSpPr>
-        <p:spPr>
-          <a:xfrm>
-            <a:off x="3520440" y="4517136"/>
-            <a:ext cx="2103120" cy="548640"/>
-          </a:xfrm>
-          <a:prstGeom prst="rect">
-            <a:avLst/>
-          </a:prstGeom>
-          <a:noFill/>
-          <a:ln/>
-        </p:spPr>
-        <p:txBody>
-          <a:bodyPr wrap="square" lIns="0" tIns="0" rIns="0" bIns="0" rtlCol="0" anchor="ctr"/>
-          <a:lstStyle/>
-          <a:p>
-            <a:pPr indent="0" marL="0">
-              <a:buNone/>
-            </a:pPr>
-            <a:r>
-              <a:rPr lang="en-US" sz="1500" dirty="0">
+            <a:endParaRPr lang="en-US" sz="1400" dirty="0"/>
+          </a:p>
+        </p:txBody>
+      </p:sp>
+      <p:sp>
+        <p:nvSpPr>
+          <p:cNvPr id="46" name="Text 44"/>
+          <p:cNvSpPr txBox="1"/>
+          <p:nvPr/>
+        </p:nvSpPr>
+        <p:spPr>
+          <a:xfrm>
+            <a:off x="3520440" y="4389120"/>
+            <a:ext cx="2103120" cy="438912"/>
+          </a:xfrm>
+          <a:prstGeom prst="rect">
+            <a:avLst/>
+          </a:prstGeom>
+          <a:noFill/>
+          <a:ln/>
+        </p:spPr>
+        <p:txBody>
+          <a:bodyPr wrap="square" lIns="0" tIns="0" rIns="0" bIns="0" rtlCol="0" anchor="ctr"/>
+          <a:lstStyle/>
+          <a:p>
+            <a:pPr indent="0" marL="0">
+              <a:buNone/>
+            </a:pPr>
+            <a:r>
+              <a:rPr lang="en-US" sz="1400" dirty="0">
                 <a:solidFill>
                   <a:srgbClr val="1A1A1A"/>
                 </a:solidFill>
@@ -24040,36 +24255,36 @@
               </a:rPr>
               <a:t>Opcodes · balance</a:t>
             </a:r>
-            <a:endParaRPr lang="en-US" sz="1500" dirty="0"/>
-          </a:p>
-        </p:txBody>
-      </p:sp>
-      <p:sp>
-        <p:nvSpPr>
-          <p:cNvPr id="41" name="Text 39"/>
-          <p:cNvSpPr txBox="1"/>
-          <p:nvPr/>
-        </p:nvSpPr>
-        <p:spPr>
-          <a:xfrm>
-            <a:off x="5669280" y="4517136"/>
-            <a:ext cx="2011680" cy="548640"/>
-          </a:xfrm>
-          <a:prstGeom prst="rect">
-            <a:avLst/>
-          </a:prstGeom>
-          <a:noFill/>
-          <a:ln/>
-        </p:spPr>
-        <p:txBody>
-          <a:bodyPr wrap="square" lIns="0" tIns="0" rIns="0" bIns="0" rtlCol="0" anchor="ctr"/>
-          <a:lstStyle/>
-          <a:p>
-            <a:pPr indent="0" marL="0">
-              <a:buNone/>
-            </a:pPr>
-            <a:r>
-              <a:rPr lang="en-US" sz="1500" dirty="0">
+            <a:endParaRPr lang="en-US" sz="1400" dirty="0"/>
+          </a:p>
+        </p:txBody>
+      </p:sp>
+      <p:sp>
+        <p:nvSpPr>
+          <p:cNvPr id="47" name="Text 45"/>
+          <p:cNvSpPr txBox="1"/>
+          <p:nvPr/>
+        </p:nvSpPr>
+        <p:spPr>
+          <a:xfrm>
+            <a:off x="5669280" y="4389120"/>
+            <a:ext cx="2011680" cy="438912"/>
+          </a:xfrm>
+          <a:prstGeom prst="rect">
+            <a:avLst/>
+          </a:prstGeom>
+          <a:noFill/>
+          <a:ln/>
+        </p:spPr>
+        <p:txBody>
+          <a:bodyPr wrap="square" lIns="0" tIns="0" rIns="0" bIns="0" rtlCol="0" anchor="ctr"/>
+          <a:lstStyle/>
+          <a:p>
+            <a:pPr indent="0" marL="0">
+              <a:buNone/>
+            </a:pPr>
+            <a:r>
+              <a:rPr lang="en-US" sz="1400" dirty="0">
                 <a:solidFill>
                   <a:srgbClr val="1A1A1A"/>
                 </a:solidFill>
@@ -24079,36 +24294,36 @@
               </a:rPr>
               <a:t>10.1% → 19.3%</a:t>
             </a:r>
-            <a:endParaRPr lang="en-US" sz="1500" dirty="0"/>
-          </a:p>
-        </p:txBody>
-      </p:sp>
-      <p:sp>
-        <p:nvSpPr>
-          <p:cNvPr id="42" name="Text 40"/>
-          <p:cNvSpPr txBox="1"/>
-          <p:nvPr/>
-        </p:nvSpPr>
-        <p:spPr>
-          <a:xfrm>
-            <a:off x="7726680" y="4517136"/>
-            <a:ext cx="1554480" cy="548640"/>
-          </a:xfrm>
-          <a:prstGeom prst="rect">
-            <a:avLst/>
-          </a:prstGeom>
-          <a:noFill/>
-          <a:ln/>
-        </p:spPr>
-        <p:txBody>
-          <a:bodyPr wrap="square" lIns="0" tIns="0" rIns="0" bIns="0" rtlCol="0" anchor="ctr"/>
-          <a:lstStyle/>
-          <a:p>
-            <a:pPr indent="0" marL="0">
-              <a:buNone/>
-            </a:pPr>
-            <a:r>
-              <a:rPr lang="en-US" sz="1500" b="1" dirty="0">
+            <a:endParaRPr lang="en-US" sz="1400" dirty="0"/>
+          </a:p>
+        </p:txBody>
+      </p:sp>
+      <p:sp>
+        <p:nvSpPr>
+          <p:cNvPr id="48" name="Text 46"/>
+          <p:cNvSpPr txBox="1"/>
+          <p:nvPr/>
+        </p:nvSpPr>
+        <p:spPr>
+          <a:xfrm>
+            <a:off x="7726680" y="4389120"/>
+            <a:ext cx="1554480" cy="438912"/>
+          </a:xfrm>
+          <a:prstGeom prst="rect">
+            <a:avLst/>
+          </a:prstGeom>
+          <a:noFill/>
+          <a:ln/>
+        </p:spPr>
+        <p:txBody>
+          <a:bodyPr wrap="square" lIns="0" tIns="0" rIns="0" bIns="0" rtlCol="0" anchor="ctr"/>
+          <a:lstStyle/>
+          <a:p>
+            <a:pPr indent="0" marL="0">
+              <a:buNone/>
+            </a:pPr>
+            <a:r>
+              <a:rPr lang="en-US" sz="1400" b="1" dirty="0">
                 <a:solidFill>
                   <a:srgbClr val="0B2C4A"/>
                 </a:solidFill>
@@ -24118,36 +24333,36 @@
               </a:rPr>
               <a:t>August</a:t>
             </a:r>
-            <a:endParaRPr lang="en-US" sz="1500" dirty="0"/>
-          </a:p>
-        </p:txBody>
-      </p:sp>
-      <p:sp>
-        <p:nvSpPr>
-          <p:cNvPr id="43" name="Text 41"/>
-          <p:cNvSpPr txBox="1"/>
-          <p:nvPr/>
-        </p:nvSpPr>
-        <p:spPr>
-          <a:xfrm>
-            <a:off x="9326880" y="4517136"/>
-            <a:ext cx="1280160" cy="548640"/>
-          </a:xfrm>
-          <a:prstGeom prst="rect">
-            <a:avLst/>
-          </a:prstGeom>
-          <a:noFill/>
-          <a:ln/>
-        </p:spPr>
-        <p:txBody>
-          <a:bodyPr wrap="square" lIns="0" tIns="0" rIns="0" bIns="0" rtlCol="0" anchor="ctr"/>
-          <a:lstStyle/>
-          <a:p>
-            <a:pPr indent="0" marL="0">
-              <a:buNone/>
-            </a:pPr>
-            <a:r>
-              <a:rPr lang="en-US" sz="1500" b="1" dirty="0">
+            <a:endParaRPr lang="en-US" sz="1400" dirty="0"/>
+          </a:p>
+        </p:txBody>
+      </p:sp>
+      <p:sp>
+        <p:nvSpPr>
+          <p:cNvPr id="49" name="Text 47"/>
+          <p:cNvSpPr txBox="1"/>
+          <p:nvPr/>
+        </p:nvSpPr>
+        <p:spPr>
+          <a:xfrm>
+            <a:off x="9326880" y="4389120"/>
+            <a:ext cx="1280160" cy="438912"/>
+          </a:xfrm>
+          <a:prstGeom prst="rect">
+            <a:avLst/>
+          </a:prstGeom>
+          <a:noFill/>
+          <a:ln/>
+        </p:spPr>
+        <p:txBody>
+          <a:bodyPr wrap="square" lIns="0" tIns="0" rIns="0" bIns="0" rtlCol="0" anchor="ctr"/>
+          <a:lstStyle/>
+          <a:p>
+            <a:pPr indent="0" marL="0">
+              <a:buNone/>
+            </a:pPr>
+            <a:r>
+              <a:rPr lang="en-US" sz="1400" b="1" dirty="0">
                 <a:solidFill>
                   <a:srgbClr val="0B7A4A"/>
                 </a:solidFill>
@@ -24157,13 +24372,423 @@
               </a:rPr>
               <a:t>+9.2 pts</a:t>
             </a:r>
-            <a:endParaRPr lang="en-US" sz="1500" dirty="0"/>
-          </a:p>
-        </p:txBody>
-      </p:sp>
-      <p:sp>
-        <p:nvSpPr>
-          <p:cNvPr id="44" name="Shape 42"/>
+            <a:endParaRPr lang="en-US" sz="1400" dirty="0"/>
+          </a:p>
+        </p:txBody>
+      </p:sp>
+      <p:sp>
+        <p:nvSpPr>
+          <p:cNvPr id="50" name="Text 48"/>
+          <p:cNvSpPr txBox="1"/>
+          <p:nvPr/>
+        </p:nvSpPr>
+        <p:spPr>
+          <a:xfrm>
+            <a:off x="749808" y="4828032"/>
+            <a:ext cx="2651760" cy="438912"/>
+          </a:xfrm>
+          <a:prstGeom prst="rect">
+            <a:avLst/>
+          </a:prstGeom>
+          <a:noFill/>
+          <a:ln/>
+        </p:spPr>
+        <p:txBody>
+          <a:bodyPr wrap="square" lIns="0" tIns="0" rIns="0" bIns="0" rtlCol="0" anchor="ctr"/>
+          <a:lstStyle/>
+          <a:p>
+            <a:pPr indent="0" marL="0">
+              <a:buNone/>
+            </a:pPr>
+            <a:r>
+              <a:rPr lang="en-US" sz="1400" b="1" dirty="0">
+                <a:solidFill>
+                  <a:srgbClr val="1A1A1A"/>
+                </a:solidFill>
+                <a:latin typeface="Inter" pitchFamily="34" charset="0"/>
+                <a:ea typeface="Inter" pitchFamily="34" charset="-122"/>
+                <a:cs typeface="Inter" pitchFamily="34" charset="-120"/>
+              </a:rPr>
+              <a:t>MAZDA</a:t>
+            </a:r>
+            <a:endParaRPr lang="en-US" sz="1400" dirty="0"/>
+          </a:p>
+        </p:txBody>
+      </p:sp>
+      <p:sp>
+        <p:nvSpPr>
+          <p:cNvPr id="51" name="Text 49"/>
+          <p:cNvSpPr txBox="1"/>
+          <p:nvPr/>
+        </p:nvSpPr>
+        <p:spPr>
+          <a:xfrm>
+            <a:off x="3520440" y="4828032"/>
+            <a:ext cx="2103120" cy="438912"/>
+          </a:xfrm>
+          <a:prstGeom prst="rect">
+            <a:avLst/>
+          </a:prstGeom>
+          <a:noFill/>
+          <a:ln/>
+        </p:spPr>
+        <p:txBody>
+          <a:bodyPr wrap="square" lIns="0" tIns="0" rIns="0" bIns="0" rtlCol="0" anchor="ctr"/>
+          <a:lstStyle/>
+          <a:p>
+            <a:pPr indent="0" marL="0">
+              <a:buNone/>
+            </a:pPr>
+            <a:r>
+              <a:rPr lang="en-US" sz="1400" dirty="0">
+                <a:solidFill>
+                  <a:srgbClr val="1A1A1A"/>
+                </a:solidFill>
+                <a:latin typeface="Inter" pitchFamily="34" charset="0"/>
+                <a:ea typeface="Inter" pitchFamily="34" charset="-122"/>
+                <a:cs typeface="Inter" pitchFamily="34" charset="-120"/>
+              </a:rPr>
+              <a:t>Opcodes · brake fluid</a:t>
+            </a:r>
+            <a:endParaRPr lang="en-US" sz="1400" dirty="0"/>
+          </a:p>
+        </p:txBody>
+      </p:sp>
+      <p:sp>
+        <p:nvSpPr>
+          <p:cNvPr id="52" name="Text 50"/>
+          <p:cNvSpPr txBox="1"/>
+          <p:nvPr/>
+        </p:nvSpPr>
+        <p:spPr>
+          <a:xfrm>
+            <a:off x="5669280" y="4828032"/>
+            <a:ext cx="2011680" cy="438912"/>
+          </a:xfrm>
+          <a:prstGeom prst="rect">
+            <a:avLst/>
+          </a:prstGeom>
+          <a:noFill/>
+          <a:ln/>
+        </p:spPr>
+        <p:txBody>
+          <a:bodyPr wrap="square" lIns="0" tIns="0" rIns="0" bIns="0" rtlCol="0" anchor="ctr"/>
+          <a:lstStyle/>
+          <a:p>
+            <a:pPr indent="0" marL="0">
+              <a:buNone/>
+            </a:pPr>
+            <a:r>
+              <a:rPr lang="en-US" sz="1400" dirty="0">
+                <a:solidFill>
+                  <a:srgbClr val="1A1A1A"/>
+                </a:solidFill>
+                <a:latin typeface="Inter" pitchFamily="34" charset="0"/>
+                <a:ea typeface="Inter" pitchFamily="34" charset="-122"/>
+                <a:cs typeface="Inter" pitchFamily="34" charset="-120"/>
+              </a:rPr>
+              <a:t>5.1% → 14.1%</a:t>
+            </a:r>
+            <a:endParaRPr lang="en-US" sz="1400" dirty="0"/>
+          </a:p>
+        </p:txBody>
+      </p:sp>
+      <p:sp>
+        <p:nvSpPr>
+          <p:cNvPr id="53" name="Text 51"/>
+          <p:cNvSpPr txBox="1"/>
+          <p:nvPr/>
+        </p:nvSpPr>
+        <p:spPr>
+          <a:xfrm>
+            <a:off x="7726680" y="4828032"/>
+            <a:ext cx="1554480" cy="438912"/>
+          </a:xfrm>
+          <a:prstGeom prst="rect">
+            <a:avLst/>
+          </a:prstGeom>
+          <a:noFill/>
+          <a:ln/>
+        </p:spPr>
+        <p:txBody>
+          <a:bodyPr wrap="square" lIns="0" tIns="0" rIns="0" bIns="0" rtlCol="0" anchor="ctr"/>
+          <a:lstStyle/>
+          <a:p>
+            <a:pPr indent="0" marL="0">
+              <a:buNone/>
+            </a:pPr>
+            <a:r>
+              <a:rPr lang="en-US" sz="1400" b="1" dirty="0">
+                <a:solidFill>
+                  <a:srgbClr val="0B2C4A"/>
+                </a:solidFill>
+                <a:latin typeface="Inter" pitchFamily="34" charset="0"/>
+                <a:ea typeface="Inter" pitchFamily="34" charset="-122"/>
+                <a:cs typeface="Inter" pitchFamily="34" charset="-120"/>
+              </a:rPr>
+              <a:t>August</a:t>
+            </a:r>
+            <a:endParaRPr lang="en-US" sz="1400" dirty="0"/>
+          </a:p>
+        </p:txBody>
+      </p:sp>
+      <p:sp>
+        <p:nvSpPr>
+          <p:cNvPr id="54" name="Text 52"/>
+          <p:cNvSpPr txBox="1"/>
+          <p:nvPr/>
+        </p:nvSpPr>
+        <p:spPr>
+          <a:xfrm>
+            <a:off x="9326880" y="4828032"/>
+            <a:ext cx="1280160" cy="438912"/>
+          </a:xfrm>
+          <a:prstGeom prst="rect">
+            <a:avLst/>
+          </a:prstGeom>
+          <a:noFill/>
+          <a:ln/>
+        </p:spPr>
+        <p:txBody>
+          <a:bodyPr wrap="square" lIns="0" tIns="0" rIns="0" bIns="0" rtlCol="0" anchor="ctr"/>
+          <a:lstStyle/>
+          <a:p>
+            <a:pPr indent="0" marL="0">
+              <a:buNone/>
+            </a:pPr>
+            <a:r>
+              <a:rPr lang="en-US" sz="1400" b="1" dirty="0">
+                <a:solidFill>
+                  <a:srgbClr val="0B7A4A"/>
+                </a:solidFill>
+                <a:latin typeface="Inter" pitchFamily="34" charset="0"/>
+                <a:ea typeface="Inter" pitchFamily="34" charset="-122"/>
+                <a:cs typeface="Inter" pitchFamily="34" charset="-120"/>
+              </a:rPr>
+              <a:t>+9.0 pts</a:t>
+            </a:r>
+            <a:endParaRPr lang="en-US" sz="1400" dirty="0"/>
+          </a:p>
+        </p:txBody>
+      </p:sp>
+      <p:sp>
+        <p:nvSpPr>
+          <p:cNvPr id="55" name="Shape 53"/>
+          <p:cNvSpPr/>
+          <p:nvPr/>
+        </p:nvSpPr>
+        <p:spPr>
+          <a:xfrm>
+            <a:off x="621792" y="5266944"/>
+            <a:ext cx="10945368" cy="438912"/>
+          </a:xfrm>
+          <a:prstGeom prst="rect">
+            <a:avLst/>
+          </a:prstGeom>
+          <a:solidFill>
+            <a:srgbClr val="F7F7F7"/>
+          </a:solidFill>
+          <a:ln/>
+        </p:spPr>
+      </p:sp>
+      <p:sp>
+        <p:nvSpPr>
+          <p:cNvPr id="56" name="Text 54"/>
+          <p:cNvSpPr txBox="1"/>
+          <p:nvPr/>
+        </p:nvSpPr>
+        <p:spPr>
+          <a:xfrm>
+            <a:off x="749808" y="5266944"/>
+            <a:ext cx="2651760" cy="438912"/>
+          </a:xfrm>
+          <a:prstGeom prst="rect">
+            <a:avLst/>
+          </a:prstGeom>
+          <a:noFill/>
+          <a:ln/>
+        </p:spPr>
+        <p:txBody>
+          <a:bodyPr wrap="square" lIns="0" tIns="0" rIns="0" bIns="0" rtlCol="0" anchor="ctr"/>
+          <a:lstStyle/>
+          <a:p>
+            <a:pPr indent="0" marL="0">
+              <a:buNone/>
+            </a:pPr>
+            <a:r>
+              <a:rPr lang="en-US" sz="1400" b="1" dirty="0">
+                <a:solidFill>
+                  <a:srgbClr val="1A1A1A"/>
+                </a:solidFill>
+                <a:latin typeface="Inter" pitchFamily="34" charset="0"/>
+                <a:ea typeface="Inter" pitchFamily="34" charset="-122"/>
+                <a:cs typeface="Inter" pitchFamily="34" charset="-120"/>
+              </a:rPr>
+              <a:t>MAZDA</a:t>
+            </a:r>
+            <a:endParaRPr lang="en-US" sz="1400" dirty="0"/>
+          </a:p>
+        </p:txBody>
+      </p:sp>
+      <p:sp>
+        <p:nvSpPr>
+          <p:cNvPr id="57" name="Text 55"/>
+          <p:cNvSpPr txBox="1"/>
+          <p:nvPr/>
+        </p:nvSpPr>
+        <p:spPr>
+          <a:xfrm>
+            <a:off x="3520440" y="5266944"/>
+            <a:ext cx="2103120" cy="438912"/>
+          </a:xfrm>
+          <a:prstGeom prst="rect">
+            <a:avLst/>
+          </a:prstGeom>
+          <a:noFill/>
+          <a:ln/>
+        </p:spPr>
+        <p:txBody>
+          <a:bodyPr wrap="square" lIns="0" tIns="0" rIns="0" bIns="0" rtlCol="0" anchor="ctr"/>
+          <a:lstStyle/>
+          <a:p>
+            <a:pPr indent="0" marL="0">
+              <a:buNone/>
+            </a:pPr>
+            <a:r>
+              <a:rPr lang="en-US" sz="1400" dirty="0">
+                <a:solidFill>
+                  <a:srgbClr val="1A1A1A"/>
+                </a:solidFill>
+                <a:latin typeface="Inter" pitchFamily="34" charset="0"/>
+                <a:ea typeface="Inter" pitchFamily="34" charset="-122"/>
+                <a:cs typeface="Inter" pitchFamily="34" charset="-120"/>
+              </a:rPr>
+              <a:t>Opcodes · fuel service</a:t>
+            </a:r>
+            <a:endParaRPr lang="en-US" sz="1400" dirty="0"/>
+          </a:p>
+        </p:txBody>
+      </p:sp>
+      <p:sp>
+        <p:nvSpPr>
+          <p:cNvPr id="58" name="Text 56"/>
+          <p:cNvSpPr txBox="1"/>
+          <p:nvPr/>
+        </p:nvSpPr>
+        <p:spPr>
+          <a:xfrm>
+            <a:off x="5669280" y="5266944"/>
+            <a:ext cx="2011680" cy="438912"/>
+          </a:xfrm>
+          <a:prstGeom prst="rect">
+            <a:avLst/>
+          </a:prstGeom>
+          <a:noFill/>
+          <a:ln/>
+        </p:spPr>
+        <p:txBody>
+          <a:bodyPr wrap="square" lIns="0" tIns="0" rIns="0" bIns="0" rtlCol="0" anchor="ctr"/>
+          <a:lstStyle/>
+          <a:p>
+            <a:pPr indent="0" marL="0">
+              <a:buNone/>
+            </a:pPr>
+            <a:r>
+              <a:rPr lang="en-US" sz="1400" dirty="0">
+                <a:solidFill>
+                  <a:srgbClr val="1A1A1A"/>
+                </a:solidFill>
+                <a:latin typeface="Inter" pitchFamily="34" charset="0"/>
+                <a:ea typeface="Inter" pitchFamily="34" charset="-122"/>
+                <a:cs typeface="Inter" pitchFamily="34" charset="-120"/>
+              </a:rPr>
+              <a:t>2.5% → 10.6%</a:t>
+            </a:r>
+            <a:endParaRPr lang="en-US" sz="1400" dirty="0"/>
+          </a:p>
+        </p:txBody>
+      </p:sp>
+      <p:sp>
+        <p:nvSpPr>
+          <p:cNvPr id="59" name="Text 57"/>
+          <p:cNvSpPr txBox="1"/>
+          <p:nvPr/>
+        </p:nvSpPr>
+        <p:spPr>
+          <a:xfrm>
+            <a:off x="7726680" y="5266944"/>
+            <a:ext cx="1554480" cy="438912"/>
+          </a:xfrm>
+          <a:prstGeom prst="rect">
+            <a:avLst/>
+          </a:prstGeom>
+          <a:noFill/>
+          <a:ln/>
+        </p:spPr>
+        <p:txBody>
+          <a:bodyPr wrap="square" lIns="0" tIns="0" rIns="0" bIns="0" rtlCol="0" anchor="ctr"/>
+          <a:lstStyle/>
+          <a:p>
+            <a:pPr indent="0" marL="0">
+              <a:buNone/>
+            </a:pPr>
+            <a:r>
+              <a:rPr lang="en-US" sz="1400" b="1" dirty="0">
+                <a:solidFill>
+                  <a:srgbClr val="0B2C4A"/>
+                </a:solidFill>
+                <a:latin typeface="Inter" pitchFamily="34" charset="0"/>
+                <a:ea typeface="Inter" pitchFamily="34" charset="-122"/>
+                <a:cs typeface="Inter" pitchFamily="34" charset="-120"/>
+              </a:rPr>
+              <a:t>August</a:t>
+            </a:r>
+            <a:endParaRPr lang="en-US" sz="1400" dirty="0"/>
+          </a:p>
+        </p:txBody>
+      </p:sp>
+      <p:sp>
+        <p:nvSpPr>
+          <p:cNvPr id="60" name="Text 58"/>
+          <p:cNvSpPr txBox="1"/>
+          <p:nvPr/>
+        </p:nvSpPr>
+        <p:spPr>
+          <a:xfrm>
+            <a:off x="9326880" y="5266944"/>
+            <a:ext cx="1280160" cy="438912"/>
+          </a:xfrm>
+          <a:prstGeom prst="rect">
+            <a:avLst/>
+          </a:prstGeom>
+          <a:noFill/>
+          <a:ln/>
+        </p:spPr>
+        <p:txBody>
+          <a:bodyPr wrap="square" lIns="0" tIns="0" rIns="0" bIns="0" rtlCol="0" anchor="ctr"/>
+          <a:lstStyle/>
+          <a:p>
+            <a:pPr indent="0" marL="0">
+              <a:buNone/>
+            </a:pPr>
+            <a:r>
+              <a:rPr lang="en-US" sz="1400" b="1" dirty="0">
+                <a:solidFill>
+                  <a:srgbClr val="0B7A4A"/>
+                </a:solidFill>
+                <a:latin typeface="Inter" pitchFamily="34" charset="0"/>
+                <a:ea typeface="Inter" pitchFamily="34" charset="-122"/>
+                <a:cs typeface="Inter" pitchFamily="34" charset="-120"/>
+              </a:rPr>
+              <a:t>+8.1 pts</a:t>
+            </a:r>
+            <a:endParaRPr lang="en-US" sz="1400" dirty="0"/>
+          </a:p>
+        </p:txBody>
+      </p:sp>
+      <p:sp>
+        <p:nvSpPr>
+          <p:cNvPr id="61" name="Shape 59"/>
           <p:cNvSpPr/>
           <p:nvPr/>
         </p:nvSpPr>
@@ -24183,7 +24808,7 @@
       </p:sp>
       <p:sp>
         <p:nvSpPr>
-          <p:cNvPr id="45" name="Text 43"/>
+          <p:cNvPr id="62" name="Text 60"/>
           <p:cNvSpPr txBox="1"/>
           <p:nvPr/>
         </p:nvSpPr>
@@ -24214,7 +24839,7 @@
                 <a:ea typeface="Inter" pitchFamily="34" charset="-122"/>
                 <a:cs typeface="Inter" pitchFamily="34" charset="-120"/>
               </a:rPr>
-              <a:t>Four stores, one question each: what did you start doing that month? One sentence, before you leave.</a:t>
+              <a:t>Five stores, one question each: what did you start doing that month? One sentence, before you leave.</a:t>
             </a:r>
             <a:endParaRPr lang="en-US" sz="1550" dirty="0"/>
           </a:p>

</xml_diff>

<commit_message>
Two Ways to Read Improvement: eight measures in the deck
Co-Authored-By: Claude Opus 5.5 <noreply@anthropic.com>
Claude-Session: https://claude.ai/code/session_01Xa4nFVxuQGXmHARGph9WhS
</commit_message>
<xml_diff>
--- a/day2-deck/decks/Most Improved v2 - Review.pptx
+++ b/day2-deck/decks/Most Improved v2 - Review.pptx
@@ -18156,7 +18156,7 @@
           <a:p>
             <a:r>
               <a:rPr lang="en-US" dirty="0"/>
-              <a:t>Takeaway with the store call-outs (off the slide): Last year: SUBARU PRESCOTT leads. Moving now: Three stores tie. One store is on both lists (green bar).Source: Qlik - Closed Repair Orders. Customer pay, by close date. Same-store, 33 stores (INEOS excluded, opened 2026). GMC Prescott body shop labor types excluded. CP gross = CP labor gross + CP parts gross. Left: Jan-Sep 2026 vs Jan-Sep 2025. Right: Q3 2026 vs Q1 2026. Top-5 finishes counted across five measures (parts $ per RO dropped, Oct 23); top six stores shown in each view.</a:t>
+              <a:t>Takeaway with the store call-outs (off the slide): Last year: Two stores tie. Moving now: KIA ST GEORGE leads. One store is on both lists (green bar).Source: Qlik - Closed Repair Orders. Customer pay, by close date. Same-store, 33 stores (INEOS excluded, opened 2026). GMC Prescott body shop labor types excluded. CP gross = CP labor gross + CP parts gross. Left: Jan-Sep 2026 vs Jan-Sep 2025. Right: Q3 2026 vs Q1 2026. Top-5 finishes counted across eight measures (parts $ per RO dropped, Oct 23); CP labor $ per RO (percent), fixed absorption and the four opcodes combined (points) added Oct 29; fixed ops net profit left out (ranked in dollars, it favors larger stores); top six stores shown in each view.</a:t>
             </a:r>
             <a:endParaRPr lang="en-US" dirty="0"/>
           </a:p>
@@ -25571,7 +25571,7 @@
                 <a:ea typeface="Inter" pitchFamily="34" charset="-122"/>
                 <a:cs typeface="Inter" pitchFamily="34" charset="-120"/>
               </a:rPr>
-              <a:t>Top-5 finishes, of five measures</a:t>
+              <a:t>Top-5 finishes, of eight measures</a:t>
             </a:r>
             <a:endParaRPr lang="en-US" sz="1400" dirty="0"/>
           </a:p>
@@ -25630,7 +25630,7 @@
                 <a:ea typeface="Inter" pitchFamily="34" charset="-122"/>
                 <a:cs typeface="Inter" pitchFamily="34" charset="-120"/>
               </a:rPr>
-              <a:t>SUBARU PRESCOTT</a:t>
+              <a:t>LINCOLN</a:t>
             </a:r>
             <a:endParaRPr lang="en-US" sz="1400" dirty="0"/>
           </a:p>
@@ -25645,7 +25645,7 @@
         <p:spPr>
           <a:xfrm>
             <a:off x="731520" y="2478024"/>
-            <a:ext cx="3520440" cy="237744"/>
+            <a:ext cx="4096512" cy="237744"/>
           </a:xfrm>
           <a:prstGeom prst="rect">
             <a:avLst/>
@@ -25669,7 +25669,7 @@
                 <a:ea typeface="Inter" pitchFamily="34" charset="-122"/>
                 <a:cs typeface="Inter" pitchFamily="34" charset="-120"/>
               </a:rPr>
-              <a:t>CP gross, hours/RO, ELR, parts GP%</a:t>
+              <a:t>gross, ELR, parts GP, labor/RO, absorption, opcodes</a:t>
             </a:r>
             <a:endParaRPr lang="en-US" sz="1300" dirty="0"/>
           </a:p>
@@ -25683,8 +25683,8 @@
         </p:nvSpPr>
         <p:spPr>
           <a:xfrm>
-            <a:off x="4343400" y="2351837"/>
-            <a:ext cx="960120" cy="234086"/>
+            <a:off x="4892040" y="2351837"/>
+            <a:ext cx="365760" cy="234086"/>
           </a:xfrm>
           <a:prstGeom prst="rect">
             <a:avLst/>
@@ -25728,7 +25728,7 @@
                 <a:ea typeface="Inter" pitchFamily="34" charset="-122"/>
                 <a:cs typeface="Inter" pitchFamily="34" charset="-120"/>
               </a:rPr>
-              <a:t>4</a:t>
+              <a:t>6</a:t>
             </a:r>
             <a:endParaRPr lang="en-US" sz="1800" dirty="0"/>
           </a:p>
@@ -25767,7 +25767,7 @@
                 <a:ea typeface="Inter" pitchFamily="34" charset="-122"/>
                 <a:cs typeface="Inter" pitchFamily="34" charset="-120"/>
               </a:rPr>
-              <a:t>LINCOLN</a:t>
+              <a:t>SUBARU PRESCOTT</a:t>
             </a:r>
             <a:endParaRPr lang="en-US" sz="1400" dirty="0"/>
           </a:p>
@@ -25782,7 +25782,7 @@
         <p:spPr>
           <a:xfrm>
             <a:off x="731520" y="3063240"/>
-            <a:ext cx="3520440" cy="237744"/>
+            <a:ext cx="4096512" cy="237744"/>
           </a:xfrm>
           <a:prstGeom prst="rect">
             <a:avLst/>
@@ -25806,7 +25806,7 @@
                 <a:ea typeface="Inter" pitchFamily="34" charset="-122"/>
                 <a:cs typeface="Inter" pitchFamily="34" charset="-120"/>
               </a:rPr>
-              <a:t>CP gross, ELR, parts GP%</a:t>
+              <a:t>gross, hrs/RO, ELR, parts GP, labor/RO, opcodes</a:t>
             </a:r>
             <a:endParaRPr lang="en-US" sz="1300" dirty="0"/>
           </a:p>
@@ -25820,8 +25820,8 @@
         </p:nvSpPr>
         <p:spPr>
           <a:xfrm>
-            <a:off x="4343400" y="2937053"/>
-            <a:ext cx="720090" cy="234086"/>
+            <a:off x="4892040" y="2937053"/>
+            <a:ext cx="365760" cy="234086"/>
           </a:xfrm>
           <a:prstGeom prst="rect">
             <a:avLst/>
@@ -25865,7 +25865,7 @@
                 <a:ea typeface="Inter" pitchFamily="34" charset="-122"/>
                 <a:cs typeface="Inter" pitchFamily="34" charset="-120"/>
               </a:rPr>
-              <a:t>3</a:t>
+              <a:t>6</a:t>
             </a:r>
             <a:endParaRPr lang="en-US" sz="1800" dirty="0"/>
           </a:p>
@@ -25924,7 +25924,7 @@
                 <a:ea typeface="Inter" pitchFamily="34" charset="-122"/>
                 <a:cs typeface="Inter" pitchFamily="34" charset="-120"/>
               </a:rPr>
-              <a:t>SUBARU ST GEORGE</a:t>
+              <a:t>KIA ST GEORGE</a:t>
             </a:r>
             <a:endParaRPr lang="en-US" sz="1400" dirty="0"/>
           </a:p>
@@ -25939,7 +25939,7 @@
         <p:spPr>
           <a:xfrm>
             <a:off x="731520" y="3648456"/>
-            <a:ext cx="3520440" cy="237744"/>
+            <a:ext cx="4096512" cy="237744"/>
           </a:xfrm>
           <a:prstGeom prst="rect">
             <a:avLst/>
@@ -25963,7 +25963,7 @@
                 <a:ea typeface="Inter" pitchFamily="34" charset="-122"/>
                 <a:cs typeface="Inter" pitchFamily="34" charset="-120"/>
               </a:rPr>
-              <a:t>CP gross, CP ROs, hours/RO</a:t>
+              <a:t>gross, hrs/RO, labor/RO, opcodes</a:t>
             </a:r>
             <a:endParaRPr lang="en-US" sz="1300" dirty="0"/>
           </a:p>
@@ -25977,8 +25977,8 @@
         </p:nvSpPr>
         <p:spPr>
           <a:xfrm>
-            <a:off x="4343400" y="3522269"/>
-            <a:ext cx="720090" cy="234086"/>
+            <a:off x="4892040" y="3522269"/>
+            <a:ext cx="243840" cy="234086"/>
           </a:xfrm>
           <a:prstGeom prst="rect">
             <a:avLst/>
@@ -26022,7 +26022,7 @@
                 <a:ea typeface="Inter" pitchFamily="34" charset="-122"/>
                 <a:cs typeface="Inter" pitchFamily="34" charset="-120"/>
               </a:rPr>
-              <a:t>3</a:t>
+              <a:t>4</a:t>
             </a:r>
             <a:endParaRPr lang="en-US" sz="1800" dirty="0"/>
           </a:p>
@@ -26030,92 +26030,14 @@
       </p:sp>
       <p:sp>
         <p:nvSpPr>
-          <p:cNvPr id="23" name="Text 21"/>
-          <p:cNvSpPr txBox="1"/>
-          <p:nvPr/>
-        </p:nvSpPr>
-        <p:spPr>
-          <a:xfrm>
-            <a:off x="731520" y="3977640"/>
-            <a:ext cx="2377440" cy="274320"/>
-          </a:xfrm>
-          <a:prstGeom prst="rect">
-            <a:avLst/>
-          </a:prstGeom>
-          <a:noFill/>
-          <a:ln/>
-        </p:spPr>
-        <p:txBody>
-          <a:bodyPr wrap="square" lIns="0" tIns="0" rIns="0" bIns="0" rtlCol="0" anchor="ctr"/>
-          <a:lstStyle/>
-          <a:p>
-            <a:pPr indent="0" marL="0">
-              <a:buNone/>
-            </a:pPr>
-            <a:r>
-              <a:rPr lang="en-US" sz="1400" b="1" dirty="0">
-                <a:solidFill>
-                  <a:srgbClr val="1A1A1A"/>
-                </a:solidFill>
-                <a:latin typeface="Inter" pitchFamily="34" charset="0"/>
-                <a:ea typeface="Inter" pitchFamily="34" charset="-122"/>
-                <a:cs typeface="Inter" pitchFamily="34" charset="-120"/>
-              </a:rPr>
-              <a:t>KIA ST GEORGE</a:t>
-            </a:r>
-            <a:endParaRPr lang="en-US" sz="1400" dirty="0"/>
-          </a:p>
-        </p:txBody>
-      </p:sp>
-      <p:sp>
-        <p:nvSpPr>
-          <p:cNvPr id="24" name="Text 22"/>
-          <p:cNvSpPr txBox="1"/>
-          <p:nvPr/>
-        </p:nvSpPr>
-        <p:spPr>
-          <a:xfrm>
-            <a:off x="731520" y="4233672"/>
-            <a:ext cx="3520440" cy="237744"/>
-          </a:xfrm>
-          <a:prstGeom prst="rect">
-            <a:avLst/>
-          </a:prstGeom>
-          <a:noFill/>
-          <a:ln/>
-        </p:spPr>
-        <p:txBody>
-          <a:bodyPr wrap="square" lIns="0" tIns="0" rIns="0" bIns="0" rtlCol="0" anchor="ctr"/>
-          <a:lstStyle/>
-          <a:p>
-            <a:pPr indent="0" marL="0">
-              <a:buNone/>
-            </a:pPr>
-            <a:r>
-              <a:rPr lang="en-US" sz="1300" dirty="0">
-                <a:solidFill>
-                  <a:srgbClr val="595959"/>
-                </a:solidFill>
-                <a:latin typeface="Inter" pitchFamily="34" charset="0"/>
-                <a:ea typeface="Inter" pitchFamily="34" charset="-122"/>
-                <a:cs typeface="Inter" pitchFamily="34" charset="-120"/>
-              </a:rPr>
-              <a:t>CP gross, hours/RO</a:t>
-            </a:r>
-            <a:endParaRPr lang="en-US" sz="1300" dirty="0"/>
-          </a:p>
-        </p:txBody>
-      </p:sp>
-      <p:sp>
-        <p:nvSpPr>
-          <p:cNvPr id="25" name="Shape 23"/>
+          <p:cNvPr id="23" name="Shape 21"/>
           <p:cNvSpPr/>
           <p:nvPr/>
         </p:nvSpPr>
         <p:spPr>
           <a:xfrm>
-            <a:off x="4343400" y="4107485"/>
-            <a:ext cx="480060" cy="234086"/>
+            <a:off x="5788152" y="3383280"/>
+            <a:ext cx="64008" cy="512064"/>
           </a:xfrm>
           <a:prstGeom prst="rect">
             <a:avLst/>
@@ -26128,53 +26050,92 @@
       </p:sp>
       <p:sp>
         <p:nvSpPr>
-          <p:cNvPr id="26" name="Text 24"/>
-          <p:cNvSpPr txBox="1"/>
-          <p:nvPr/>
-        </p:nvSpPr>
-        <p:spPr>
-          <a:xfrm>
-            <a:off x="5330952" y="3931920"/>
-            <a:ext cx="411480" cy="585216"/>
-          </a:xfrm>
-          <a:prstGeom prst="rect">
-            <a:avLst/>
-          </a:prstGeom>
-          <a:noFill/>
-          <a:ln/>
-        </p:spPr>
-        <p:txBody>
-          <a:bodyPr wrap="square" lIns="0" tIns="0" rIns="0" bIns="0" rtlCol="0" anchor="ctr"/>
-          <a:lstStyle/>
-          <a:p>
-            <a:pPr algn="r" indent="0" marL="0">
-              <a:buNone/>
-            </a:pPr>
-            <a:r>
-              <a:rPr lang="en-US" sz="1800" b="1" dirty="0">
-                <a:solidFill>
-                  <a:srgbClr val="0B7A4A"/>
-                </a:solidFill>
-                <a:latin typeface="Inter" pitchFamily="34" charset="0"/>
-                <a:ea typeface="Inter" pitchFamily="34" charset="-122"/>
-                <a:cs typeface="Inter" pitchFamily="34" charset="-120"/>
-              </a:rPr>
-              <a:t>2</a:t>
-            </a:r>
-            <a:endParaRPr lang="en-US" sz="1800" dirty="0"/>
-          </a:p>
-        </p:txBody>
-      </p:sp>
-      <p:sp>
-        <p:nvSpPr>
-          <p:cNvPr id="27" name="Shape 25"/>
+          <p:cNvPr id="24" name="Text 22"/>
+          <p:cNvSpPr txBox="1"/>
+          <p:nvPr/>
+        </p:nvSpPr>
+        <p:spPr>
+          <a:xfrm>
+            <a:off x="731520" y="3977640"/>
+            <a:ext cx="2377440" cy="274320"/>
+          </a:xfrm>
+          <a:prstGeom prst="rect">
+            <a:avLst/>
+          </a:prstGeom>
+          <a:noFill/>
+          <a:ln/>
+        </p:spPr>
+        <p:txBody>
+          <a:bodyPr wrap="square" lIns="0" tIns="0" rIns="0" bIns="0" rtlCol="0" anchor="ctr"/>
+          <a:lstStyle/>
+          <a:p>
+            <a:pPr indent="0" marL="0">
+              <a:buNone/>
+            </a:pPr>
+            <a:r>
+              <a:rPr lang="en-US" sz="1400" b="1" dirty="0">
+                <a:solidFill>
+                  <a:srgbClr val="1A1A1A"/>
+                </a:solidFill>
+                <a:latin typeface="Inter" pitchFamily="34" charset="0"/>
+                <a:ea typeface="Inter" pitchFamily="34" charset="-122"/>
+                <a:cs typeface="Inter" pitchFamily="34" charset="-120"/>
+              </a:rPr>
+              <a:t>SUBARU ST GEORGE</a:t>
+            </a:r>
+            <a:endParaRPr lang="en-US" sz="1400" dirty="0"/>
+          </a:p>
+        </p:txBody>
+      </p:sp>
+      <p:sp>
+        <p:nvSpPr>
+          <p:cNvPr id="25" name="Text 23"/>
+          <p:cNvSpPr txBox="1"/>
+          <p:nvPr/>
+        </p:nvSpPr>
+        <p:spPr>
+          <a:xfrm>
+            <a:off x="731520" y="4233672"/>
+            <a:ext cx="4096512" cy="237744"/>
+          </a:xfrm>
+          <a:prstGeom prst="rect">
+            <a:avLst/>
+          </a:prstGeom>
+          <a:noFill/>
+          <a:ln/>
+        </p:spPr>
+        <p:txBody>
+          <a:bodyPr wrap="square" lIns="0" tIns="0" rIns="0" bIns="0" rtlCol="0" anchor="ctr"/>
+          <a:lstStyle/>
+          <a:p>
+            <a:pPr indent="0" marL="0">
+              <a:buNone/>
+            </a:pPr>
+            <a:r>
+              <a:rPr lang="en-US" sz="1300" dirty="0">
+                <a:solidFill>
+                  <a:srgbClr val="595959"/>
+                </a:solidFill>
+                <a:latin typeface="Inter" pitchFamily="34" charset="0"/>
+                <a:ea typeface="Inter" pitchFamily="34" charset="-122"/>
+                <a:cs typeface="Inter" pitchFamily="34" charset="-120"/>
+              </a:rPr>
+              <a:t>gross, ROs, hrs/RO</a:t>
+            </a:r>
+            <a:endParaRPr lang="en-US" sz="1300" dirty="0"/>
+          </a:p>
+        </p:txBody>
+      </p:sp>
+      <p:sp>
+        <p:nvSpPr>
+          <p:cNvPr id="26" name="Shape 24"/>
           <p:cNvSpPr/>
           <p:nvPr/>
         </p:nvSpPr>
         <p:spPr>
           <a:xfrm>
-            <a:off x="5788152" y="3968496"/>
-            <a:ext cx="64008" cy="512064"/>
+            <a:off x="4892040" y="4107485"/>
+            <a:ext cx="182880" cy="234086"/>
           </a:xfrm>
           <a:prstGeom prst="rect">
             <a:avLst/>
@@ -26187,6 +26148,45 @@
       </p:sp>
       <p:sp>
         <p:nvSpPr>
+          <p:cNvPr id="27" name="Text 25"/>
+          <p:cNvSpPr txBox="1"/>
+          <p:nvPr/>
+        </p:nvSpPr>
+        <p:spPr>
+          <a:xfrm>
+            <a:off x="5330952" y="3931920"/>
+            <a:ext cx="411480" cy="585216"/>
+          </a:xfrm>
+          <a:prstGeom prst="rect">
+            <a:avLst/>
+          </a:prstGeom>
+          <a:noFill/>
+          <a:ln/>
+        </p:spPr>
+        <p:txBody>
+          <a:bodyPr wrap="square" lIns="0" tIns="0" rIns="0" bIns="0" rtlCol="0" anchor="ctr"/>
+          <a:lstStyle/>
+          <a:p>
+            <a:pPr algn="r" indent="0" marL="0">
+              <a:buNone/>
+            </a:pPr>
+            <a:r>
+              <a:rPr lang="en-US" sz="1800" b="1" dirty="0">
+                <a:solidFill>
+                  <a:srgbClr val="0B7A4A"/>
+                </a:solidFill>
+                <a:latin typeface="Inter" pitchFamily="34" charset="0"/>
+                <a:ea typeface="Inter" pitchFamily="34" charset="-122"/>
+                <a:cs typeface="Inter" pitchFamily="34" charset="-120"/>
+              </a:rPr>
+              <a:t>3</a:t>
+            </a:r>
+            <a:endParaRPr lang="en-US" sz="1800" dirty="0"/>
+          </a:p>
+        </p:txBody>
+      </p:sp>
+      <p:sp>
+        <p:nvSpPr>
           <p:cNvPr id="28" name="Shape 26"/>
           <p:cNvSpPr/>
           <p:nvPr/>
@@ -26238,7 +26238,7 @@
                 <a:ea typeface="Inter" pitchFamily="34" charset="-122"/>
                 <a:cs typeface="Inter" pitchFamily="34" charset="-120"/>
               </a:rPr>
-              <a:t>KIA LV</a:t>
+              <a:t>LR RENO</a:t>
             </a:r>
             <a:endParaRPr lang="en-US" sz="1400" dirty="0"/>
           </a:p>
@@ -26253,7 +26253,7 @@
         <p:spPr>
           <a:xfrm>
             <a:off x="731520" y="4818888"/>
-            <a:ext cx="3520440" cy="237744"/>
+            <a:ext cx="4096512" cy="237744"/>
           </a:xfrm>
           <a:prstGeom prst="rect">
             <a:avLst/>
@@ -26277,7 +26277,7 @@
                 <a:ea typeface="Inter" pitchFamily="34" charset="-122"/>
                 <a:cs typeface="Inter" pitchFamily="34" charset="-120"/>
               </a:rPr>
-              <a:t>CP ROs, hours/RO</a:t>
+              <a:t>ROs, parts GP, absorption</a:t>
             </a:r>
             <a:endParaRPr lang="en-US" sz="1300" dirty="0"/>
           </a:p>
@@ -26291,8 +26291,8 @@
         </p:nvSpPr>
         <p:spPr>
           <a:xfrm>
-            <a:off x="4343400" y="4692701"/>
-            <a:ext cx="480060" cy="234086"/>
+            <a:off x="4892040" y="4692701"/>
+            <a:ext cx="182880" cy="234086"/>
           </a:xfrm>
           <a:prstGeom prst="rect">
             <a:avLst/>
@@ -26336,7 +26336,7 @@
                 <a:ea typeface="Inter" pitchFamily="34" charset="-122"/>
                 <a:cs typeface="Inter" pitchFamily="34" charset="-120"/>
               </a:rPr>
-              <a:t>2</a:t>
+              <a:t>3</a:t>
             </a:r>
             <a:endParaRPr lang="en-US" sz="1800" dirty="0"/>
           </a:p>
@@ -26375,7 +26375,7 @@
                 <a:ea typeface="Inter" pitchFamily="34" charset="-122"/>
                 <a:cs typeface="Inter" pitchFamily="34" charset="-120"/>
               </a:rPr>
-              <a:t>LR RENO</a:t>
+              <a:t>NISSAN</a:t>
             </a:r>
             <a:endParaRPr lang="en-US" sz="1400" dirty="0"/>
           </a:p>
@@ -26390,7 +26390,7 @@
         <p:spPr>
           <a:xfrm>
             <a:off x="731520" y="5404104"/>
-            <a:ext cx="3520440" cy="237744"/>
+            <a:ext cx="4096512" cy="237744"/>
           </a:xfrm>
           <a:prstGeom prst="rect">
             <a:avLst/>
@@ -26414,7 +26414,7 @@
                 <a:ea typeface="Inter" pitchFamily="34" charset="-122"/>
                 <a:cs typeface="Inter" pitchFamily="34" charset="-120"/>
               </a:rPr>
-              <a:t>CP ROs, parts GP%</a:t>
+              <a:t>ELR, parts GP, labor/RO</a:t>
             </a:r>
             <a:endParaRPr lang="en-US" sz="1300" dirty="0"/>
           </a:p>
@@ -26428,8 +26428,8 @@
         </p:nvSpPr>
         <p:spPr>
           <a:xfrm>
-            <a:off x="4343400" y="5277917"/>
-            <a:ext cx="480060" cy="234086"/>
+            <a:off x="4892040" y="5277917"/>
+            <a:ext cx="182880" cy="234086"/>
           </a:xfrm>
           <a:prstGeom prst="rect">
             <a:avLst/>
@@ -26473,7 +26473,7 @@
                 <a:ea typeface="Inter" pitchFamily="34" charset="-122"/>
                 <a:cs typeface="Inter" pitchFamily="34" charset="-120"/>
               </a:rPr>
-              <a:t>2</a:t>
+              <a:t>3</a:t>
             </a:r>
             <a:endParaRPr lang="en-US" sz="1800" dirty="0"/>
           </a:p>
@@ -26591,7 +26591,7 @@
                 <a:ea typeface="Inter" pitchFamily="34" charset="-122"/>
                 <a:cs typeface="Inter" pitchFamily="34" charset="-120"/>
               </a:rPr>
-              <a:t>Top-5 finishes, of five measures</a:t>
+              <a:t>Top-5 finishes, of eight measures</a:t>
             </a:r>
             <a:endParaRPr lang="en-US" sz="1400" dirty="0"/>
           </a:p>
@@ -26650,7 +26650,7 @@
                 <a:ea typeface="Inter" pitchFamily="34" charset="-122"/>
                 <a:cs typeface="Inter" pitchFamily="34" charset="-120"/>
               </a:rPr>
-              <a:t>MAZDA</a:t>
+              <a:t>KIA ST GEORGE</a:t>
             </a:r>
             <a:endParaRPr lang="en-US" sz="1400" dirty="0"/>
           </a:p>
@@ -26665,7 +26665,7 @@
         <p:spPr>
           <a:xfrm>
             <a:off x="6446520" y="2478024"/>
-            <a:ext cx="3520440" cy="237744"/>
+            <a:ext cx="4096512" cy="237744"/>
           </a:xfrm>
           <a:prstGeom prst="rect">
             <a:avLst/>
@@ -26689,7 +26689,7 @@
                 <a:ea typeface="Inter" pitchFamily="34" charset="-122"/>
                 <a:cs typeface="Inter" pitchFamily="34" charset="-120"/>
               </a:rPr>
-              <a:t>CP gross, CP ROs, hours/RO</a:t>
+              <a:t>gross, hrs/RO, ELR, labor/RO, absorption, opcodes</a:t>
             </a:r>
             <a:endParaRPr lang="en-US" sz="1300" dirty="0"/>
           </a:p>
@@ -26703,8 +26703,8 @@
         </p:nvSpPr>
         <p:spPr>
           <a:xfrm>
-            <a:off x="10058400" y="2351837"/>
-            <a:ext cx="960120" cy="234086"/>
+            <a:off x="10607040" y="2351837"/>
+            <a:ext cx="365760" cy="234086"/>
           </a:xfrm>
           <a:prstGeom prst="rect">
             <a:avLst/>
@@ -26748,7 +26748,7 @@
                 <a:ea typeface="Inter" pitchFamily="34" charset="-122"/>
                 <a:cs typeface="Inter" pitchFamily="34" charset="-120"/>
               </a:rPr>
-              <a:t>3</a:t>
+              <a:t>6</a:t>
             </a:r>
             <a:endParaRPr lang="en-US" sz="1800" dirty="0"/>
           </a:p>
@@ -26756,92 +26756,14 @@
       </p:sp>
       <p:sp>
         <p:nvSpPr>
-          <p:cNvPr id="46" name="Text 44"/>
-          <p:cNvSpPr txBox="1"/>
-          <p:nvPr/>
-        </p:nvSpPr>
-        <p:spPr>
-          <a:xfrm>
-            <a:off x="6446520" y="2807208"/>
-            <a:ext cx="2377440" cy="274320"/>
-          </a:xfrm>
-          <a:prstGeom prst="rect">
-            <a:avLst/>
-          </a:prstGeom>
-          <a:noFill/>
-          <a:ln/>
-        </p:spPr>
-        <p:txBody>
-          <a:bodyPr wrap="square" lIns="0" tIns="0" rIns="0" bIns="0" rtlCol="0" anchor="ctr"/>
-          <a:lstStyle/>
-          <a:p>
-            <a:pPr indent="0" marL="0">
-              <a:buNone/>
-            </a:pPr>
-            <a:r>
-              <a:rPr lang="en-US" sz="1400" b="1" dirty="0">
-                <a:solidFill>
-                  <a:srgbClr val="1A1A1A"/>
-                </a:solidFill>
-                <a:latin typeface="Inter" pitchFamily="34" charset="0"/>
-                <a:ea typeface="Inter" pitchFamily="34" charset="-122"/>
-                <a:cs typeface="Inter" pitchFamily="34" charset="-120"/>
-              </a:rPr>
-              <a:t>KIA ST GEORGE</a:t>
-            </a:r>
-            <a:endParaRPr lang="en-US" sz="1400" dirty="0"/>
-          </a:p>
-        </p:txBody>
-      </p:sp>
-      <p:sp>
-        <p:nvSpPr>
-          <p:cNvPr id="47" name="Text 45"/>
-          <p:cNvSpPr txBox="1"/>
-          <p:nvPr/>
-        </p:nvSpPr>
-        <p:spPr>
-          <a:xfrm>
-            <a:off x="6446520" y="3063240"/>
-            <a:ext cx="3520440" cy="237744"/>
-          </a:xfrm>
-          <a:prstGeom prst="rect">
-            <a:avLst/>
-          </a:prstGeom>
-          <a:noFill/>
-          <a:ln/>
-        </p:spPr>
-        <p:txBody>
-          <a:bodyPr wrap="square" lIns="0" tIns="0" rIns="0" bIns="0" rtlCol="0" anchor="ctr"/>
-          <a:lstStyle/>
-          <a:p>
-            <a:pPr indent="0" marL="0">
-              <a:buNone/>
-            </a:pPr>
-            <a:r>
-              <a:rPr lang="en-US" sz="1300" dirty="0">
-                <a:solidFill>
-                  <a:srgbClr val="595959"/>
-                </a:solidFill>
-                <a:latin typeface="Inter" pitchFamily="34" charset="0"/>
-                <a:ea typeface="Inter" pitchFamily="34" charset="-122"/>
-                <a:cs typeface="Inter" pitchFamily="34" charset="-120"/>
-              </a:rPr>
-              <a:t>CP gross, hours/RO, ELR</a:t>
-            </a:r>
-            <a:endParaRPr lang="en-US" sz="1300" dirty="0"/>
-          </a:p>
-        </p:txBody>
-      </p:sp>
-      <p:sp>
-        <p:nvSpPr>
-          <p:cNvPr id="48" name="Shape 46"/>
+          <p:cNvPr id="46" name="Shape 44"/>
           <p:cNvSpPr/>
           <p:nvPr/>
         </p:nvSpPr>
         <p:spPr>
           <a:xfrm>
-            <a:off x="10058400" y="2937053"/>
-            <a:ext cx="960120" cy="234086"/>
+            <a:off x="11503152" y="2212848"/>
+            <a:ext cx="64008" cy="512064"/>
           </a:xfrm>
           <a:prstGeom prst="rect">
             <a:avLst/>
@@ -26854,53 +26776,92 @@
       </p:sp>
       <p:sp>
         <p:nvSpPr>
-          <p:cNvPr id="49" name="Text 47"/>
-          <p:cNvSpPr txBox="1"/>
-          <p:nvPr/>
-        </p:nvSpPr>
-        <p:spPr>
-          <a:xfrm>
-            <a:off x="11045952" y="2761488"/>
-            <a:ext cx="411480" cy="585216"/>
-          </a:xfrm>
-          <a:prstGeom prst="rect">
-            <a:avLst/>
-          </a:prstGeom>
-          <a:noFill/>
-          <a:ln/>
-        </p:spPr>
-        <p:txBody>
-          <a:bodyPr wrap="square" lIns="0" tIns="0" rIns="0" bIns="0" rtlCol="0" anchor="ctr"/>
-          <a:lstStyle/>
-          <a:p>
-            <a:pPr algn="r" indent="0" marL="0">
-              <a:buNone/>
-            </a:pPr>
-            <a:r>
-              <a:rPr lang="en-US" sz="1800" b="1" dirty="0">
-                <a:solidFill>
-                  <a:srgbClr val="0B7A4A"/>
-                </a:solidFill>
-                <a:latin typeface="Inter" pitchFamily="34" charset="0"/>
-                <a:ea typeface="Inter" pitchFamily="34" charset="-122"/>
-                <a:cs typeface="Inter" pitchFamily="34" charset="-120"/>
-              </a:rPr>
-              <a:t>3</a:t>
-            </a:r>
-            <a:endParaRPr lang="en-US" sz="1800" dirty="0"/>
-          </a:p>
-        </p:txBody>
-      </p:sp>
-      <p:sp>
-        <p:nvSpPr>
-          <p:cNvPr id="50" name="Shape 48"/>
+          <p:cNvPr id="47" name="Text 45"/>
+          <p:cNvSpPr txBox="1"/>
+          <p:nvPr/>
+        </p:nvSpPr>
+        <p:spPr>
+          <a:xfrm>
+            <a:off x="6446520" y="2807208"/>
+            <a:ext cx="2377440" cy="274320"/>
+          </a:xfrm>
+          <a:prstGeom prst="rect">
+            <a:avLst/>
+          </a:prstGeom>
+          <a:noFill/>
+          <a:ln/>
+        </p:spPr>
+        <p:txBody>
+          <a:bodyPr wrap="square" lIns="0" tIns="0" rIns="0" bIns="0" rtlCol="0" anchor="ctr"/>
+          <a:lstStyle/>
+          <a:p>
+            <a:pPr indent="0" marL="0">
+              <a:buNone/>
+            </a:pPr>
+            <a:r>
+              <a:rPr lang="en-US" sz="1400" b="1" dirty="0">
+                <a:solidFill>
+                  <a:srgbClr val="1A1A1A"/>
+                </a:solidFill>
+                <a:latin typeface="Inter" pitchFamily="34" charset="0"/>
+                <a:ea typeface="Inter" pitchFamily="34" charset="-122"/>
+                <a:cs typeface="Inter" pitchFamily="34" charset="-120"/>
+              </a:rPr>
+              <a:t>MAZDA</a:t>
+            </a:r>
+            <a:endParaRPr lang="en-US" sz="1400" dirty="0"/>
+          </a:p>
+        </p:txBody>
+      </p:sp>
+      <p:sp>
+        <p:nvSpPr>
+          <p:cNvPr id="48" name="Text 46"/>
+          <p:cNvSpPr txBox="1"/>
+          <p:nvPr/>
+        </p:nvSpPr>
+        <p:spPr>
+          <a:xfrm>
+            <a:off x="6446520" y="3063240"/>
+            <a:ext cx="4096512" cy="237744"/>
+          </a:xfrm>
+          <a:prstGeom prst="rect">
+            <a:avLst/>
+          </a:prstGeom>
+          <a:noFill/>
+          <a:ln/>
+        </p:spPr>
+        <p:txBody>
+          <a:bodyPr wrap="square" lIns="0" tIns="0" rIns="0" bIns="0" rtlCol="0" anchor="ctr"/>
+          <a:lstStyle/>
+          <a:p>
+            <a:pPr indent="0" marL="0">
+              <a:buNone/>
+            </a:pPr>
+            <a:r>
+              <a:rPr lang="en-US" sz="1300" dirty="0">
+                <a:solidFill>
+                  <a:srgbClr val="595959"/>
+                </a:solidFill>
+                <a:latin typeface="Inter" pitchFamily="34" charset="0"/>
+                <a:ea typeface="Inter" pitchFamily="34" charset="-122"/>
+                <a:cs typeface="Inter" pitchFamily="34" charset="-120"/>
+              </a:rPr>
+              <a:t>gross, ROs, hrs/RO, labor/RO, opcodes</a:t>
+            </a:r>
+            <a:endParaRPr lang="en-US" sz="1300" dirty="0"/>
+          </a:p>
+        </p:txBody>
+      </p:sp>
+      <p:sp>
+        <p:nvSpPr>
+          <p:cNvPr id="49" name="Shape 47"/>
           <p:cNvSpPr/>
           <p:nvPr/>
         </p:nvSpPr>
         <p:spPr>
           <a:xfrm>
-            <a:off x="11503152" y="2798064"/>
-            <a:ext cx="64008" cy="512064"/>
+            <a:off x="10607040" y="2937053"/>
+            <a:ext cx="304800" cy="234086"/>
           </a:xfrm>
           <a:prstGeom prst="rect">
             <a:avLst/>
@@ -26913,6 +26874,45 @@
       </p:sp>
       <p:sp>
         <p:nvSpPr>
+          <p:cNvPr id="50" name="Text 48"/>
+          <p:cNvSpPr txBox="1"/>
+          <p:nvPr/>
+        </p:nvSpPr>
+        <p:spPr>
+          <a:xfrm>
+            <a:off x="11045952" y="2761488"/>
+            <a:ext cx="411480" cy="585216"/>
+          </a:xfrm>
+          <a:prstGeom prst="rect">
+            <a:avLst/>
+          </a:prstGeom>
+          <a:noFill/>
+          <a:ln/>
+        </p:spPr>
+        <p:txBody>
+          <a:bodyPr wrap="square" lIns="0" tIns="0" rIns="0" bIns="0" rtlCol="0" anchor="ctr"/>
+          <a:lstStyle/>
+          <a:p>
+            <a:pPr algn="r" indent="0" marL="0">
+              <a:buNone/>
+            </a:pPr>
+            <a:r>
+              <a:rPr lang="en-US" sz="1800" b="1" dirty="0">
+                <a:solidFill>
+                  <a:srgbClr val="0B7A4A"/>
+                </a:solidFill>
+                <a:latin typeface="Inter" pitchFamily="34" charset="0"/>
+                <a:ea typeface="Inter" pitchFamily="34" charset="-122"/>
+                <a:cs typeface="Inter" pitchFamily="34" charset="-120"/>
+              </a:rPr>
+              <a:t>5</a:t>
+            </a:r>
+            <a:endParaRPr lang="en-US" sz="1800" dirty="0"/>
+          </a:p>
+        </p:txBody>
+      </p:sp>
+      <p:sp>
+        <p:nvSpPr>
           <p:cNvPr id="51" name="Shape 49"/>
           <p:cNvSpPr/>
           <p:nvPr/>
@@ -26964,7 +26964,7 @@
                 <a:ea typeface="Inter" pitchFamily="34" charset="-122"/>
                 <a:cs typeface="Inter" pitchFamily="34" charset="-120"/>
               </a:rPr>
-              <a:t>VW ST GEORGE</a:t>
+              <a:t>HYUNDAI PRESCOTT</a:t>
             </a:r>
             <a:endParaRPr lang="en-US" sz="1400" dirty="0"/>
           </a:p>
@@ -26979,7 +26979,7 @@
         <p:spPr>
           <a:xfrm>
             <a:off x="6446520" y="3648456"/>
-            <a:ext cx="3520440" cy="237744"/>
+            <a:ext cx="4096512" cy="237744"/>
           </a:xfrm>
           <a:prstGeom prst="rect">
             <a:avLst/>
@@ -27003,7 +27003,7 @@
                 <a:ea typeface="Inter" pitchFamily="34" charset="-122"/>
                 <a:cs typeface="Inter" pitchFamily="34" charset="-120"/>
               </a:rPr>
-              <a:t>CP gross, ELR, parts GP%</a:t>
+              <a:t>gross, hrs/RO, labor/RO, opcodes</a:t>
             </a:r>
             <a:endParaRPr lang="en-US" sz="1300" dirty="0"/>
           </a:p>
@@ -27017,8 +27017,8 @@
         </p:nvSpPr>
         <p:spPr>
           <a:xfrm>
-            <a:off x="10058400" y="3522269"/>
-            <a:ext cx="960120" cy="234086"/>
+            <a:off x="10607040" y="3522269"/>
+            <a:ext cx="243840" cy="234086"/>
           </a:xfrm>
           <a:prstGeom prst="rect">
             <a:avLst/>
@@ -27062,7 +27062,7 @@
                 <a:ea typeface="Inter" pitchFamily="34" charset="-122"/>
                 <a:cs typeface="Inter" pitchFamily="34" charset="-120"/>
               </a:rPr>
-              <a:t>3</a:t>
+              <a:t>4</a:t>
             </a:r>
             <a:endParaRPr lang="en-US" sz="1800" dirty="0"/>
           </a:p>
@@ -27101,7 +27101,7 @@
                 <a:ea typeface="Inter" pitchFamily="34" charset="-122"/>
                 <a:cs typeface="Inter" pitchFamily="34" charset="-120"/>
               </a:rPr>
-              <a:t>CDJR POST FALLS</a:t>
+              <a:t>VW ST GEORGE</a:t>
             </a:r>
             <a:endParaRPr lang="en-US" sz="1400" dirty="0"/>
           </a:p>
@@ -27116,7 +27116,7 @@
         <p:spPr>
           <a:xfrm>
             <a:off x="6446520" y="4233672"/>
-            <a:ext cx="3520440" cy="237744"/>
+            <a:ext cx="4096512" cy="237744"/>
           </a:xfrm>
           <a:prstGeom prst="rect">
             <a:avLst/>
@@ -27140,7 +27140,7 @@
                 <a:ea typeface="Inter" pitchFamily="34" charset="-122"/>
                 <a:cs typeface="Inter" pitchFamily="34" charset="-120"/>
               </a:rPr>
-              <a:t>CP gross, CP ROs</a:t>
+              <a:t>gross, ELR, parts GP</a:t>
             </a:r>
             <a:endParaRPr lang="en-US" sz="1300" dirty="0"/>
           </a:p>
@@ -27154,8 +27154,8 @@
         </p:nvSpPr>
         <p:spPr>
           <a:xfrm>
-            <a:off x="10058400" y="4107485"/>
-            <a:ext cx="640080" cy="234086"/>
+            <a:off x="10607040" y="4107485"/>
+            <a:ext cx="182880" cy="234086"/>
           </a:xfrm>
           <a:prstGeom prst="rect">
             <a:avLst/>
@@ -27199,7 +27199,7 @@
                 <a:ea typeface="Inter" pitchFamily="34" charset="-122"/>
                 <a:cs typeface="Inter" pitchFamily="34" charset="-120"/>
               </a:rPr>
-              <a:t>2</a:t>
+              <a:t>3</a:t>
             </a:r>
             <a:endParaRPr lang="en-US" sz="1800" dirty="0"/>
           </a:p>
@@ -27258,7 +27258,7 @@
                 <a:ea typeface="Inter" pitchFamily="34" charset="-122"/>
                 <a:cs typeface="Inter" pitchFamily="34" charset="-120"/>
               </a:rPr>
-              <a:t>HYUNDAI PRESCOTT</a:t>
+              <a:t>AUDI RENO</a:t>
             </a:r>
             <a:endParaRPr lang="en-US" sz="1400" dirty="0"/>
           </a:p>
@@ -27273,7 +27273,7 @@
         <p:spPr>
           <a:xfrm>
             <a:off x="6446520" y="4818888"/>
-            <a:ext cx="3520440" cy="237744"/>
+            <a:ext cx="4096512" cy="237744"/>
           </a:xfrm>
           <a:prstGeom prst="rect">
             <a:avLst/>
@@ -27297,7 +27297,7 @@
                 <a:ea typeface="Inter" pitchFamily="34" charset="-122"/>
                 <a:cs typeface="Inter" pitchFamily="34" charset="-120"/>
               </a:rPr>
-              <a:t>CP gross, hours/RO</a:t>
+              <a:t>ELR, parts GP, labor/RO</a:t>
             </a:r>
             <a:endParaRPr lang="en-US" sz="1300" dirty="0"/>
           </a:p>
@@ -27311,8 +27311,8 @@
         </p:nvSpPr>
         <p:spPr>
           <a:xfrm>
-            <a:off x="10058400" y="4692701"/>
-            <a:ext cx="640080" cy="234086"/>
+            <a:off x="10607040" y="4692701"/>
+            <a:ext cx="182880" cy="234086"/>
           </a:xfrm>
           <a:prstGeom prst="rect">
             <a:avLst/>
@@ -27356,7 +27356,7 @@
                 <a:ea typeface="Inter" pitchFamily="34" charset="-122"/>
                 <a:cs typeface="Inter" pitchFamily="34" charset="-120"/>
               </a:rPr>
-              <a:t>2</a:t>
+              <a:t>3</a:t>
             </a:r>
             <a:endParaRPr lang="en-US" sz="1800" dirty="0"/>
           </a:p>
@@ -27395,7 +27395,7 @@
                 <a:ea typeface="Inter" pitchFamily="34" charset="-122"/>
                 <a:cs typeface="Inter" pitchFamily="34" charset="-120"/>
               </a:rPr>
-              <a:t>AUDI RENO</a:t>
+              <a:t>CDJR POST FALLS</a:t>
             </a:r>
             <a:endParaRPr lang="en-US" sz="1400" dirty="0"/>
           </a:p>
@@ -27410,7 +27410,7 @@
         <p:spPr>
           <a:xfrm>
             <a:off x="6446520" y="5404104"/>
-            <a:ext cx="3520440" cy="237744"/>
+            <a:ext cx="4096512" cy="237744"/>
           </a:xfrm>
           <a:prstGeom prst="rect">
             <a:avLst/>
@@ -27434,7 +27434,7 @@
                 <a:ea typeface="Inter" pitchFamily="34" charset="-122"/>
                 <a:cs typeface="Inter" pitchFamily="34" charset="-120"/>
               </a:rPr>
-              <a:t>ELR, parts GP%</a:t>
+              <a:t>gross, ROs</a:t>
             </a:r>
             <a:endParaRPr lang="en-US" sz="1300" dirty="0"/>
           </a:p>
@@ -27448,8 +27448,8 @@
         </p:nvSpPr>
         <p:spPr>
           <a:xfrm>
-            <a:off x="10058400" y="5277917"/>
-            <a:ext cx="640080" cy="234086"/>
+            <a:off x="10607040" y="5277917"/>
+            <a:ext cx="121920" cy="234086"/>
           </a:xfrm>
           <a:prstGeom prst="rect">
             <a:avLst/>
@@ -27552,7 +27552,7 @@
                 <a:ea typeface="Inter" pitchFamily="34" charset="-122"/>
                 <a:cs typeface="Inter" pitchFamily="34" charset="-120"/>
               </a:rPr>
-              <a:t>Moving now: Three stores tie. One store is on both lists (green bar). Also tied at 2 last year: Nissan.</a:t>
+              <a:t>Last year: Two stores tie. One store is on both lists (green bar). Also tied at 2 moving now: Hyundai St George and Chevy GMC Bullhead.</a:t>
             </a:r>
             <a:endParaRPr lang="en-US" sz="1600" dirty="0"/>
           </a:p>

</xml_diff>

<commit_message>
Close grids: flat note on a zero group change (round 49)
Co-Authored-By: Claude Opus 5.5 <noreply@anthropic.com>
Claude-Session: https://claude.ai/code/session_01Xa4nFVxuQGXmHARGph9WhS
</commit_message>
<xml_diff>
--- a/day2-deck/decks/Most Improved v2 - Review.pptx
+++ b/day2-deck/decks/Most Improved v2 - Review.pptx
@@ -37988,7 +37988,7 @@
                 <a:ea typeface="Inter" pitchFamily="34" charset="-122"/>
                 <a:cs typeface="Inter" pitchFamily="34" charset="-120"/>
               </a:rPr>
-              <a:t>Group 0.0 pts</a:t>
+              <a:t>Group 0.0 pts (flat)</a:t>
             </a:r>
             <a:endParaRPr lang="en-US" sz="1300" dirty="0"/>
           </a:p>
@@ -38556,7 +38556,7 @@
                 <a:ea typeface="Inter" pitchFamily="34" charset="-122"/>
                 <a:cs typeface="Inter" pitchFamily="34" charset="-120"/>
               </a:rPr>
-              <a:t>Group 0.0 pts</a:t>
+              <a:t>Group 0.0 pts (flat)</a:t>
             </a:r>
             <a:endParaRPr lang="en-US" sz="1300" dirty="0"/>
           </a:p>

</xml_diff>